<commit_message>
feat(ppt): add Limitations and System Design Architecture slides
- Slide 12: LIMITATIONS — 6-card grid (2×3) covering single-doc-only,
  no OCR, no auth/multi-user, no persistent chat, API rate limits,
  PyMuPDF vs PDF.js extraction divergence
- Slide 13: SYSTEM DESIGN — component architecture diagram with
  Browser, FastAPI, Gemini API, and Postgres boxes; labelled
  arrows for upload/query, SSE stream, embed/rerank/answer, and
  store & retrieve flows; legend row at bottom
- Both slides inserted before the existing thank-you slide

Co-Authored-By: Claude Sonnet 4.6 <noreply@anthropic.com>
</commit_message>
<xml_diff>
--- a/NYMBL-DOCRAG.pptx
+++ b/NYMBL-DOCRAG.pptx
@@ -16,6 +16,8 @@
     <p:sldId id="264" r:id="rId14"/>
     <p:sldId id="265" r:id="rId15"/>
     <p:sldId id="266" r:id="rId16"/>
+    <p:sldId id="268" r:id="rId21"/>
+    <p:sldId id="269" r:id="rId22"/>
     <p:sldId id="267" r:id="rId17"/>
   </p:sldIdLst>
   <p:sldSz cx="18288000" cy="10287000"/>
@@ -7435,6 +7437,2373 @@
 </p:sld>
 </file>
 
+<file path=ppt/slides/slide13.xml><?xml version="1.0" encoding="utf-8"?>
+<p:sld xmlns:a="http://schemas.openxmlformats.org/drawingml/2006/main" xmlns:p="http://schemas.openxmlformats.org/presentationml/2006/main" xmlns:r="http://schemas.openxmlformats.org/officeDocument/2006/relationships">
+  <p:cSld>
+    <p:bg>
+      <p:bgPr>
+        <a:solidFill>
+          <a:srgbClr val="FFFFFF"/>
+        </a:solidFill>
+        <a:effectLst/>
+      </p:bgPr>
+    </p:bg>
+    <p:spTree>
+      <p:nvGrpSpPr>
+        <p:cNvPr id="1" name=""/>
+        <p:cNvGrpSpPr/>
+        <p:nvPr/>
+      </p:nvGrpSpPr>
+      <p:grpSpPr/>
+      <p:sp>
+        <p:nvSpPr>
+          <p:cNvPr id="2" name="TextBox 1"/>
+          <p:cNvSpPr txBox="1"/>
+          <p:nvPr/>
+        </p:nvSpPr>
+        <p:spPr>
+          <a:xfrm>
+            <a:off x="914400" y="484632"/>
+            <a:ext cx="16285463" cy="429768"/>
+          </a:xfrm>
+          <a:prstGeom prst="rect">
+            <a:avLst/>
+          </a:prstGeom>
+          <a:noFill/>
+        </p:spPr>
+        <p:txBody>
+          <a:bodyPr wrap="square">
+            <a:spAutoFit/>
+          </a:bodyPr>
+          <a:lstStyle/>
+          <a:p>
+            <a:pPr algn="l"/>
+            <a:r>
+              <a:rPr sz="1400" b="1" i="0">
+                <a:solidFill>
+                  <a:srgbClr val="7C3AED"/>
+                </a:solidFill>
+              </a:rPr>
+              <a:t>LIMITATIONS</a:t>
+            </a:r>
+          </a:p>
+        </p:txBody>
+      </p:sp>
+      <p:sp>
+        <p:nvSpPr>
+          <p:cNvPr id="3" name="TextBox 2"/>
+          <p:cNvSpPr txBox="1"/>
+          <p:nvPr/>
+        </p:nvSpPr>
+        <p:spPr>
+          <a:xfrm>
+            <a:off x="914400" y="987552"/>
+            <a:ext cx="16285463" cy="502920"/>
+          </a:xfrm>
+          <a:prstGeom prst="rect">
+            <a:avLst/>
+          </a:prstGeom>
+          <a:noFill/>
+        </p:spPr>
+        <p:txBody>
+          <a:bodyPr wrap="square">
+            <a:spAutoFit/>
+          </a:bodyPr>
+          <a:lstStyle/>
+          <a:p>
+            <a:pPr algn="l"/>
+            <a:r>
+              <a:rPr sz="2800" b="1" i="0">
+                <a:solidFill>
+                  <a:srgbClr val="4C1D95"/>
+                </a:solidFill>
+              </a:rPr>
+              <a:t>Current scope — known constraints</a:t>
+            </a:r>
+          </a:p>
+        </p:txBody>
+      </p:sp>
+      <p:sp>
+        <p:nvSpPr>
+          <p:cNvPr id="4" name="Rectangle 3"/>
+          <p:cNvSpPr/>
+          <p:nvPr/>
+        </p:nvSpPr>
+        <p:spPr>
+          <a:xfrm>
+            <a:off x="822960" y="1856231"/>
+            <a:ext cx="16651224" cy="54864"/>
+          </a:xfrm>
+          <a:prstGeom prst="rect">
+            <a:avLst/>
+          </a:prstGeom>
+          <a:solidFill>
+            <a:srgbClr val="EF4444"/>
+          </a:solidFill>
+          <a:ln>
+            <a:noFill/>
+          </a:ln>
+        </p:spPr>
+        <p:style>
+          <a:lnRef idx="1">
+            <a:schemeClr val="accent1"/>
+          </a:lnRef>
+          <a:fillRef idx="3">
+            <a:schemeClr val="accent1"/>
+          </a:fillRef>
+          <a:effectRef idx="2">
+            <a:schemeClr val="accent1"/>
+          </a:effectRef>
+          <a:fontRef idx="minor">
+            <a:schemeClr val="lt1"/>
+          </a:fontRef>
+        </p:style>
+        <p:txBody>
+          <a:bodyPr rtlCol="0" anchor="ctr"/>
+          <a:lstStyle/>
+          <a:p>
+            <a:pPr algn="ctr"/>
+          </a:p>
+        </p:txBody>
+      </p:sp>
+      <p:sp>
+        <p:nvSpPr>
+          <p:cNvPr id="5" name="Rectangle 4"/>
+          <p:cNvSpPr/>
+          <p:nvPr/>
+        </p:nvSpPr>
+        <p:spPr>
+          <a:xfrm>
+            <a:off x="402336" y="2185416"/>
+            <a:ext cx="5303520" cy="3447288"/>
+          </a:xfrm>
+          <a:prstGeom prst="rect">
+            <a:avLst/>
+          </a:prstGeom>
+          <a:solidFill>
+            <a:srgbClr val="FFFFFF"/>
+          </a:solidFill>
+          <a:ln w="6350">
+            <a:solidFill>
+              <a:srgbClr val="E2E8F0"/>
+            </a:solidFill>
+          </a:ln>
+        </p:spPr>
+        <p:style>
+          <a:lnRef idx="1">
+            <a:schemeClr val="accent1"/>
+          </a:lnRef>
+          <a:fillRef idx="3">
+            <a:schemeClr val="accent1"/>
+          </a:fillRef>
+          <a:effectRef idx="2">
+            <a:schemeClr val="accent1"/>
+          </a:effectRef>
+          <a:fontRef idx="minor">
+            <a:schemeClr val="lt1"/>
+          </a:fontRef>
+        </p:style>
+        <p:txBody>
+          <a:bodyPr rtlCol="0" anchor="ctr"/>
+          <a:lstStyle/>
+          <a:p>
+            <a:pPr algn="ctr"/>
+          </a:p>
+        </p:txBody>
+      </p:sp>
+      <p:sp>
+        <p:nvSpPr>
+          <p:cNvPr id="6" name="Rectangle 5"/>
+          <p:cNvSpPr/>
+          <p:nvPr/>
+        </p:nvSpPr>
+        <p:spPr>
+          <a:xfrm>
+            <a:off x="402336" y="2185416"/>
+            <a:ext cx="5303520" cy="64008"/>
+          </a:xfrm>
+          <a:prstGeom prst="rect">
+            <a:avLst/>
+          </a:prstGeom>
+          <a:solidFill>
+            <a:srgbClr val="EF4444"/>
+          </a:solidFill>
+          <a:ln>
+            <a:noFill/>
+          </a:ln>
+        </p:spPr>
+        <p:style>
+          <a:lnRef idx="1">
+            <a:schemeClr val="accent1"/>
+          </a:lnRef>
+          <a:fillRef idx="3">
+            <a:schemeClr val="accent1"/>
+          </a:fillRef>
+          <a:effectRef idx="2">
+            <a:schemeClr val="accent1"/>
+          </a:effectRef>
+          <a:fontRef idx="minor">
+            <a:schemeClr val="lt1"/>
+          </a:fontRef>
+        </p:style>
+        <p:txBody>
+          <a:bodyPr rtlCol="0" anchor="ctr"/>
+          <a:lstStyle/>
+          <a:p>
+            <a:pPr algn="ctr"/>
+          </a:p>
+        </p:txBody>
+      </p:sp>
+      <p:sp>
+        <p:nvSpPr>
+          <p:cNvPr id="7" name="TextBox 6"/>
+          <p:cNvSpPr txBox="1"/>
+          <p:nvPr/>
+        </p:nvSpPr>
+        <p:spPr>
+          <a:xfrm>
+            <a:off x="704088" y="2359152"/>
+            <a:ext cx="4892040" cy="466344"/>
+          </a:xfrm>
+          <a:prstGeom prst="rect">
+            <a:avLst/>
+          </a:prstGeom>
+          <a:noFill/>
+        </p:spPr>
+        <p:txBody>
+          <a:bodyPr wrap="square">
+            <a:spAutoFit/>
+          </a:bodyPr>
+          <a:lstStyle/>
+          <a:p>
+            <a:pPr algn="l"/>
+            <a:r>
+              <a:rPr sz="1500" b="1" i="0">
+                <a:solidFill>
+                  <a:srgbClr val="4C1D95"/>
+                </a:solidFill>
+              </a:rPr>
+              <a:t>🚫  Single Document Only</a:t>
+            </a:r>
+          </a:p>
+        </p:txBody>
+      </p:sp>
+      <p:sp>
+        <p:nvSpPr>
+          <p:cNvPr id="8" name="TextBox 7"/>
+          <p:cNvSpPr txBox="1"/>
+          <p:nvPr/>
+        </p:nvSpPr>
+        <p:spPr>
+          <a:xfrm>
+            <a:off x="704088" y="2962656"/>
+            <a:ext cx="4892040" cy="2414016"/>
+          </a:xfrm>
+          <a:prstGeom prst="rect">
+            <a:avLst/>
+          </a:prstGeom>
+          <a:noFill/>
+        </p:spPr>
+        <p:txBody>
+          <a:bodyPr wrap="square">
+            <a:spAutoFit/>
+          </a:bodyPr>
+          <a:lstStyle/>
+          <a:p>
+            <a:pPr algn="l"/>
+            <a:r>
+              <a:rPr sz="1250" b="0" i="0">
+                <a:solidFill>
+                  <a:srgbClr val="7C3AED"/>
+                </a:solidFill>
+              </a:rPr>
+              <a:t>One PDF at a time. Uploading a new document wipes the previous one — no multi-doc library or cross-document queries.</a:t>
+            </a:r>
+          </a:p>
+        </p:txBody>
+      </p:sp>
+      <p:sp>
+        <p:nvSpPr>
+          <p:cNvPr id="9" name="Rectangle 8"/>
+          <p:cNvSpPr/>
+          <p:nvPr/>
+        </p:nvSpPr>
+        <p:spPr>
+          <a:xfrm>
+            <a:off x="6117336" y="2185416"/>
+            <a:ext cx="5303520" cy="3447288"/>
+          </a:xfrm>
+          <a:prstGeom prst="rect">
+            <a:avLst/>
+          </a:prstGeom>
+          <a:solidFill>
+            <a:srgbClr val="FFFFFF"/>
+          </a:solidFill>
+          <a:ln w="6350">
+            <a:solidFill>
+              <a:srgbClr val="E2E8F0"/>
+            </a:solidFill>
+          </a:ln>
+        </p:spPr>
+        <p:style>
+          <a:lnRef idx="1">
+            <a:schemeClr val="accent1"/>
+          </a:lnRef>
+          <a:fillRef idx="3">
+            <a:schemeClr val="accent1"/>
+          </a:fillRef>
+          <a:effectRef idx="2">
+            <a:schemeClr val="accent1"/>
+          </a:effectRef>
+          <a:fontRef idx="minor">
+            <a:schemeClr val="lt1"/>
+          </a:fontRef>
+        </p:style>
+        <p:txBody>
+          <a:bodyPr rtlCol="0" anchor="ctr"/>
+          <a:lstStyle/>
+          <a:p>
+            <a:pPr algn="ctr"/>
+          </a:p>
+        </p:txBody>
+      </p:sp>
+      <p:sp>
+        <p:nvSpPr>
+          <p:cNvPr id="10" name="Rectangle 9"/>
+          <p:cNvSpPr/>
+          <p:nvPr/>
+        </p:nvSpPr>
+        <p:spPr>
+          <a:xfrm>
+            <a:off x="6117336" y="2185416"/>
+            <a:ext cx="5303520" cy="64008"/>
+          </a:xfrm>
+          <a:prstGeom prst="rect">
+            <a:avLst/>
+          </a:prstGeom>
+          <a:solidFill>
+            <a:srgbClr val="EF4444"/>
+          </a:solidFill>
+          <a:ln>
+            <a:noFill/>
+          </a:ln>
+        </p:spPr>
+        <p:style>
+          <a:lnRef idx="1">
+            <a:schemeClr val="accent1"/>
+          </a:lnRef>
+          <a:fillRef idx="3">
+            <a:schemeClr val="accent1"/>
+          </a:fillRef>
+          <a:effectRef idx="2">
+            <a:schemeClr val="accent1"/>
+          </a:effectRef>
+          <a:fontRef idx="minor">
+            <a:schemeClr val="lt1"/>
+          </a:fontRef>
+        </p:style>
+        <p:txBody>
+          <a:bodyPr rtlCol="0" anchor="ctr"/>
+          <a:lstStyle/>
+          <a:p>
+            <a:pPr algn="ctr"/>
+          </a:p>
+        </p:txBody>
+      </p:sp>
+      <p:sp>
+        <p:nvSpPr>
+          <p:cNvPr id="11" name="TextBox 10"/>
+          <p:cNvSpPr txBox="1"/>
+          <p:nvPr/>
+        </p:nvSpPr>
+        <p:spPr>
+          <a:xfrm>
+            <a:off x="6419088" y="2359152"/>
+            <a:ext cx="4892040" cy="466344"/>
+          </a:xfrm>
+          <a:prstGeom prst="rect">
+            <a:avLst/>
+          </a:prstGeom>
+          <a:noFill/>
+        </p:spPr>
+        <p:txBody>
+          <a:bodyPr wrap="square">
+            <a:spAutoFit/>
+          </a:bodyPr>
+          <a:lstStyle/>
+          <a:p>
+            <a:pPr algn="l"/>
+            <a:r>
+              <a:rPr sz="1500" b="1" i="0">
+                <a:solidFill>
+                  <a:srgbClr val="4C1D95"/>
+                </a:solidFill>
+              </a:rPr>
+              <a:t>🔍  No Scanned PDF / OCR</a:t>
+            </a:r>
+          </a:p>
+        </p:txBody>
+      </p:sp>
+      <p:sp>
+        <p:nvSpPr>
+          <p:cNvPr id="12" name="TextBox 11"/>
+          <p:cNvSpPr txBox="1"/>
+          <p:nvPr/>
+        </p:nvSpPr>
+        <p:spPr>
+          <a:xfrm>
+            <a:off x="6419088" y="2962656"/>
+            <a:ext cx="4892040" cy="2414016"/>
+          </a:xfrm>
+          <a:prstGeom prst="rect">
+            <a:avLst/>
+          </a:prstGeom>
+          <a:noFill/>
+        </p:spPr>
+        <p:txBody>
+          <a:bodyPr wrap="square">
+            <a:spAutoFit/>
+          </a:bodyPr>
+          <a:lstStyle/>
+          <a:p>
+            <a:pPr algn="l"/>
+            <a:r>
+              <a:rPr sz="1250" b="0" i="0">
+                <a:solidFill>
+                  <a:srgbClr val="7C3AED"/>
+                </a:solidFill>
+              </a:rPr>
+              <a:t>PyMuPDF extracts text from digital PDFs only. Image-based or scanned pages return empty text — no Tesseract / Vision fallback.</a:t>
+            </a:r>
+          </a:p>
+        </p:txBody>
+      </p:sp>
+      <p:sp>
+        <p:nvSpPr>
+          <p:cNvPr id="13" name="Rectangle 12"/>
+          <p:cNvSpPr/>
+          <p:nvPr/>
+        </p:nvSpPr>
+        <p:spPr>
+          <a:xfrm>
+            <a:off x="11832336" y="2185416"/>
+            <a:ext cx="5303520" cy="3447288"/>
+          </a:xfrm>
+          <a:prstGeom prst="rect">
+            <a:avLst/>
+          </a:prstGeom>
+          <a:solidFill>
+            <a:srgbClr val="FFFFFF"/>
+          </a:solidFill>
+          <a:ln w="6350">
+            <a:solidFill>
+              <a:srgbClr val="E2E8F0"/>
+            </a:solidFill>
+          </a:ln>
+        </p:spPr>
+        <p:style>
+          <a:lnRef idx="1">
+            <a:schemeClr val="accent1"/>
+          </a:lnRef>
+          <a:fillRef idx="3">
+            <a:schemeClr val="accent1"/>
+          </a:fillRef>
+          <a:effectRef idx="2">
+            <a:schemeClr val="accent1"/>
+          </a:effectRef>
+          <a:fontRef idx="minor">
+            <a:schemeClr val="lt1"/>
+          </a:fontRef>
+        </p:style>
+        <p:txBody>
+          <a:bodyPr rtlCol="0" anchor="ctr"/>
+          <a:lstStyle/>
+          <a:p>
+            <a:pPr algn="ctr"/>
+          </a:p>
+        </p:txBody>
+      </p:sp>
+      <p:sp>
+        <p:nvSpPr>
+          <p:cNvPr id="14" name="Rectangle 13"/>
+          <p:cNvSpPr/>
+          <p:nvPr/>
+        </p:nvSpPr>
+        <p:spPr>
+          <a:xfrm>
+            <a:off x="11832336" y="2185416"/>
+            <a:ext cx="5303520" cy="64008"/>
+          </a:xfrm>
+          <a:prstGeom prst="rect">
+            <a:avLst/>
+          </a:prstGeom>
+          <a:solidFill>
+            <a:srgbClr val="EF4444"/>
+          </a:solidFill>
+          <a:ln>
+            <a:noFill/>
+          </a:ln>
+        </p:spPr>
+        <p:style>
+          <a:lnRef idx="1">
+            <a:schemeClr val="accent1"/>
+          </a:lnRef>
+          <a:fillRef idx="3">
+            <a:schemeClr val="accent1"/>
+          </a:fillRef>
+          <a:effectRef idx="2">
+            <a:schemeClr val="accent1"/>
+          </a:effectRef>
+          <a:fontRef idx="minor">
+            <a:schemeClr val="lt1"/>
+          </a:fontRef>
+        </p:style>
+        <p:txBody>
+          <a:bodyPr rtlCol="0" anchor="ctr"/>
+          <a:lstStyle/>
+          <a:p>
+            <a:pPr algn="ctr"/>
+          </a:p>
+        </p:txBody>
+      </p:sp>
+      <p:sp>
+        <p:nvSpPr>
+          <p:cNvPr id="15" name="TextBox 14"/>
+          <p:cNvSpPr txBox="1"/>
+          <p:nvPr/>
+        </p:nvSpPr>
+        <p:spPr>
+          <a:xfrm>
+            <a:off x="12134088" y="2359152"/>
+            <a:ext cx="4892040" cy="466344"/>
+          </a:xfrm>
+          <a:prstGeom prst="rect">
+            <a:avLst/>
+          </a:prstGeom>
+          <a:noFill/>
+        </p:spPr>
+        <p:txBody>
+          <a:bodyPr wrap="square">
+            <a:spAutoFit/>
+          </a:bodyPr>
+          <a:lstStyle/>
+          <a:p>
+            <a:pPr algn="l"/>
+            <a:r>
+              <a:rPr sz="1500" b="1" i="0">
+                <a:solidFill>
+                  <a:srgbClr val="4C1D95"/>
+                </a:solidFill>
+              </a:rPr>
+              <a:t>👤  No Auth / Multi-User</a:t>
+            </a:r>
+          </a:p>
+        </p:txBody>
+      </p:sp>
+      <p:sp>
+        <p:nvSpPr>
+          <p:cNvPr id="16" name="TextBox 15"/>
+          <p:cNvSpPr txBox="1"/>
+          <p:nvPr/>
+        </p:nvSpPr>
+        <p:spPr>
+          <a:xfrm>
+            <a:off x="12134088" y="2962656"/>
+            <a:ext cx="4892040" cy="2414016"/>
+          </a:xfrm>
+          <a:prstGeom prst="rect">
+            <a:avLst/>
+          </a:prstGeom>
+          <a:noFill/>
+        </p:spPr>
+        <p:txBody>
+          <a:bodyPr wrap="square">
+            <a:spAutoFit/>
+          </a:bodyPr>
+          <a:lstStyle/>
+          <a:p>
+            <a:pPr algn="l"/>
+            <a:r>
+              <a:rPr sz="1250" b="0" i="0">
+                <a:solidFill>
+                  <a:srgbClr val="7C3AED"/>
+                </a:solidFill>
+              </a:rPr>
+              <a:t>Single shared server state. No session isolation — concurrent users share the same document with no login or permission model.</a:t>
+            </a:r>
+          </a:p>
+        </p:txBody>
+      </p:sp>
+      <p:sp>
+        <p:nvSpPr>
+          <p:cNvPr id="17" name="Rectangle 16"/>
+          <p:cNvSpPr/>
+          <p:nvPr/>
+        </p:nvSpPr>
+        <p:spPr>
+          <a:xfrm>
+            <a:off x="402336" y="5806440"/>
+            <a:ext cx="5303520" cy="3447288"/>
+          </a:xfrm>
+          <a:prstGeom prst="rect">
+            <a:avLst/>
+          </a:prstGeom>
+          <a:solidFill>
+            <a:srgbClr val="FFFFFF"/>
+          </a:solidFill>
+          <a:ln w="6350">
+            <a:solidFill>
+              <a:srgbClr val="E2E8F0"/>
+            </a:solidFill>
+          </a:ln>
+        </p:spPr>
+        <p:style>
+          <a:lnRef idx="1">
+            <a:schemeClr val="accent1"/>
+          </a:lnRef>
+          <a:fillRef idx="3">
+            <a:schemeClr val="accent1"/>
+          </a:fillRef>
+          <a:effectRef idx="2">
+            <a:schemeClr val="accent1"/>
+          </a:effectRef>
+          <a:fontRef idx="minor">
+            <a:schemeClr val="lt1"/>
+          </a:fontRef>
+        </p:style>
+        <p:txBody>
+          <a:bodyPr rtlCol="0" anchor="ctr"/>
+          <a:lstStyle/>
+          <a:p>
+            <a:pPr algn="ctr"/>
+          </a:p>
+        </p:txBody>
+      </p:sp>
+      <p:sp>
+        <p:nvSpPr>
+          <p:cNvPr id="18" name="Rectangle 17"/>
+          <p:cNvSpPr/>
+          <p:nvPr/>
+        </p:nvSpPr>
+        <p:spPr>
+          <a:xfrm>
+            <a:off x="402336" y="5806440"/>
+            <a:ext cx="5303520" cy="64008"/>
+          </a:xfrm>
+          <a:prstGeom prst="rect">
+            <a:avLst/>
+          </a:prstGeom>
+          <a:solidFill>
+            <a:srgbClr val="F59E0B"/>
+          </a:solidFill>
+          <a:ln>
+            <a:noFill/>
+          </a:ln>
+        </p:spPr>
+        <p:style>
+          <a:lnRef idx="1">
+            <a:schemeClr val="accent1"/>
+          </a:lnRef>
+          <a:fillRef idx="3">
+            <a:schemeClr val="accent1"/>
+          </a:fillRef>
+          <a:effectRef idx="2">
+            <a:schemeClr val="accent1"/>
+          </a:effectRef>
+          <a:fontRef idx="minor">
+            <a:schemeClr val="lt1"/>
+          </a:fontRef>
+        </p:style>
+        <p:txBody>
+          <a:bodyPr rtlCol="0" anchor="ctr"/>
+          <a:lstStyle/>
+          <a:p>
+            <a:pPr algn="ctr"/>
+          </a:p>
+        </p:txBody>
+      </p:sp>
+      <p:sp>
+        <p:nvSpPr>
+          <p:cNvPr id="19" name="TextBox 18"/>
+          <p:cNvSpPr txBox="1"/>
+          <p:nvPr/>
+        </p:nvSpPr>
+        <p:spPr>
+          <a:xfrm>
+            <a:off x="704088" y="5980176"/>
+            <a:ext cx="4892040" cy="466344"/>
+          </a:xfrm>
+          <a:prstGeom prst="rect">
+            <a:avLst/>
+          </a:prstGeom>
+          <a:noFill/>
+        </p:spPr>
+        <p:txBody>
+          <a:bodyPr wrap="square">
+            <a:spAutoFit/>
+          </a:bodyPr>
+          <a:lstStyle/>
+          <a:p>
+            <a:pPr algn="l"/>
+            <a:r>
+              <a:rPr sz="1500" b="1" i="0">
+                <a:solidFill>
+                  <a:srgbClr val="4C1D95"/>
+                </a:solidFill>
+              </a:rPr>
+              <a:t>💬  No Persistent Chat History</a:t>
+            </a:r>
+          </a:p>
+        </p:txBody>
+      </p:sp>
+      <p:sp>
+        <p:nvSpPr>
+          <p:cNvPr id="20" name="TextBox 19"/>
+          <p:cNvSpPr txBox="1"/>
+          <p:nvPr/>
+        </p:nvSpPr>
+        <p:spPr>
+          <a:xfrm>
+            <a:off x="704088" y="6583679"/>
+            <a:ext cx="4892040" cy="2414016"/>
+          </a:xfrm>
+          <a:prstGeom prst="rect">
+            <a:avLst/>
+          </a:prstGeom>
+          <a:noFill/>
+        </p:spPr>
+        <p:txBody>
+          <a:bodyPr wrap="square">
+            <a:spAutoFit/>
+          </a:bodyPr>
+          <a:lstStyle/>
+          <a:p>
+            <a:pPr algn="l"/>
+            <a:r>
+              <a:rPr sz="1250" b="0" i="0">
+                <a:solidFill>
+                  <a:srgbClr val="7C3AED"/>
+                </a:solidFill>
+              </a:rPr>
+              <a:t>Conversation context resets on page reload. Follow-up questions cannot reference answers from a previous browsing session.</a:t>
+            </a:r>
+          </a:p>
+        </p:txBody>
+      </p:sp>
+      <p:sp>
+        <p:nvSpPr>
+          <p:cNvPr id="21" name="Rectangle 20"/>
+          <p:cNvSpPr/>
+          <p:nvPr/>
+        </p:nvSpPr>
+        <p:spPr>
+          <a:xfrm>
+            <a:off x="6117336" y="5806440"/>
+            <a:ext cx="5303520" cy="3447288"/>
+          </a:xfrm>
+          <a:prstGeom prst="rect">
+            <a:avLst/>
+          </a:prstGeom>
+          <a:solidFill>
+            <a:srgbClr val="FFFFFF"/>
+          </a:solidFill>
+          <a:ln w="6350">
+            <a:solidFill>
+              <a:srgbClr val="E2E8F0"/>
+            </a:solidFill>
+          </a:ln>
+        </p:spPr>
+        <p:style>
+          <a:lnRef idx="1">
+            <a:schemeClr val="accent1"/>
+          </a:lnRef>
+          <a:fillRef idx="3">
+            <a:schemeClr val="accent1"/>
+          </a:fillRef>
+          <a:effectRef idx="2">
+            <a:schemeClr val="accent1"/>
+          </a:effectRef>
+          <a:fontRef idx="minor">
+            <a:schemeClr val="lt1"/>
+          </a:fontRef>
+        </p:style>
+        <p:txBody>
+          <a:bodyPr rtlCol="0" anchor="ctr"/>
+          <a:lstStyle/>
+          <a:p>
+            <a:pPr algn="ctr"/>
+          </a:p>
+        </p:txBody>
+      </p:sp>
+      <p:sp>
+        <p:nvSpPr>
+          <p:cNvPr id="22" name="Rectangle 21"/>
+          <p:cNvSpPr/>
+          <p:nvPr/>
+        </p:nvSpPr>
+        <p:spPr>
+          <a:xfrm>
+            <a:off x="6117336" y="5806440"/>
+            <a:ext cx="5303520" cy="64008"/>
+          </a:xfrm>
+          <a:prstGeom prst="rect">
+            <a:avLst/>
+          </a:prstGeom>
+          <a:solidFill>
+            <a:srgbClr val="F59E0B"/>
+          </a:solidFill>
+          <a:ln>
+            <a:noFill/>
+          </a:ln>
+        </p:spPr>
+        <p:style>
+          <a:lnRef idx="1">
+            <a:schemeClr val="accent1"/>
+          </a:lnRef>
+          <a:fillRef idx="3">
+            <a:schemeClr val="accent1"/>
+          </a:fillRef>
+          <a:effectRef idx="2">
+            <a:schemeClr val="accent1"/>
+          </a:effectRef>
+          <a:fontRef idx="minor">
+            <a:schemeClr val="lt1"/>
+          </a:fontRef>
+        </p:style>
+        <p:txBody>
+          <a:bodyPr rtlCol="0" anchor="ctr"/>
+          <a:lstStyle/>
+          <a:p>
+            <a:pPr algn="ctr"/>
+          </a:p>
+        </p:txBody>
+      </p:sp>
+      <p:sp>
+        <p:nvSpPr>
+          <p:cNvPr id="23" name="TextBox 22"/>
+          <p:cNvSpPr txBox="1"/>
+          <p:nvPr/>
+        </p:nvSpPr>
+        <p:spPr>
+          <a:xfrm>
+            <a:off x="6419088" y="5980176"/>
+            <a:ext cx="4892040" cy="466344"/>
+          </a:xfrm>
+          <a:prstGeom prst="rect">
+            <a:avLst/>
+          </a:prstGeom>
+          <a:noFill/>
+        </p:spPr>
+        <p:txBody>
+          <a:bodyPr wrap="square">
+            <a:spAutoFit/>
+          </a:bodyPr>
+          <a:lstStyle/>
+          <a:p>
+            <a:pPr algn="l"/>
+            <a:r>
+              <a:rPr sz="1500" b="1" i="0">
+                <a:solidFill>
+                  <a:srgbClr val="4C1D95"/>
+                </a:solidFill>
+              </a:rPr>
+              <a:t>⚡  Gemini API Rate Limits</a:t>
+            </a:r>
+          </a:p>
+        </p:txBody>
+      </p:sp>
+      <p:sp>
+        <p:nvSpPr>
+          <p:cNvPr id="24" name="TextBox 23"/>
+          <p:cNvSpPr txBox="1"/>
+          <p:nvPr/>
+        </p:nvSpPr>
+        <p:spPr>
+          <a:xfrm>
+            <a:off x="6419088" y="6583679"/>
+            <a:ext cx="4892040" cy="2414016"/>
+          </a:xfrm>
+          <a:prstGeom prst="rect">
+            <a:avLst/>
+          </a:prstGeom>
+          <a:noFill/>
+        </p:spPr>
+        <p:txBody>
+          <a:bodyPr wrap="square">
+            <a:spAutoFit/>
+          </a:bodyPr>
+          <a:lstStyle/>
+          <a:p>
+            <a:pPr algn="l"/>
+            <a:r>
+              <a:rPr sz="1250" b="0" i="0">
+                <a:solidFill>
+                  <a:srgbClr val="7C3AED"/>
+                </a:solidFill>
+              </a:rPr>
+              <a:t>Concurrent embedding calls hit 429 limits on large documents. Exponential backoff adds latency for 100+ page PDFs.</a:t>
+            </a:r>
+          </a:p>
+        </p:txBody>
+      </p:sp>
+      <p:sp>
+        <p:nvSpPr>
+          <p:cNvPr id="25" name="Rectangle 24"/>
+          <p:cNvSpPr/>
+          <p:nvPr/>
+        </p:nvSpPr>
+        <p:spPr>
+          <a:xfrm>
+            <a:off x="11832336" y="5806440"/>
+            <a:ext cx="5303520" cy="3447288"/>
+          </a:xfrm>
+          <a:prstGeom prst="rect">
+            <a:avLst/>
+          </a:prstGeom>
+          <a:solidFill>
+            <a:srgbClr val="FFFFFF"/>
+          </a:solidFill>
+          <a:ln w="6350">
+            <a:solidFill>
+              <a:srgbClr val="E2E8F0"/>
+            </a:solidFill>
+          </a:ln>
+        </p:spPr>
+        <p:style>
+          <a:lnRef idx="1">
+            <a:schemeClr val="accent1"/>
+          </a:lnRef>
+          <a:fillRef idx="3">
+            <a:schemeClr val="accent1"/>
+          </a:fillRef>
+          <a:effectRef idx="2">
+            <a:schemeClr val="accent1"/>
+          </a:effectRef>
+          <a:fontRef idx="minor">
+            <a:schemeClr val="lt1"/>
+          </a:fontRef>
+        </p:style>
+        <p:txBody>
+          <a:bodyPr rtlCol="0" anchor="ctr"/>
+          <a:lstStyle/>
+          <a:p>
+            <a:pPr algn="ctr"/>
+          </a:p>
+        </p:txBody>
+      </p:sp>
+      <p:sp>
+        <p:nvSpPr>
+          <p:cNvPr id="26" name="Rectangle 25"/>
+          <p:cNvSpPr/>
+          <p:nvPr/>
+        </p:nvSpPr>
+        <p:spPr>
+          <a:xfrm>
+            <a:off x="11832336" y="5806440"/>
+            <a:ext cx="5303520" cy="64008"/>
+          </a:xfrm>
+          <a:prstGeom prst="rect">
+            <a:avLst/>
+          </a:prstGeom>
+          <a:solidFill>
+            <a:srgbClr val="F59E0B"/>
+          </a:solidFill>
+          <a:ln>
+            <a:noFill/>
+          </a:ln>
+        </p:spPr>
+        <p:style>
+          <a:lnRef idx="1">
+            <a:schemeClr val="accent1"/>
+          </a:lnRef>
+          <a:fillRef idx="3">
+            <a:schemeClr val="accent1"/>
+          </a:fillRef>
+          <a:effectRef idx="2">
+            <a:schemeClr val="accent1"/>
+          </a:effectRef>
+          <a:fontRef idx="minor">
+            <a:schemeClr val="lt1"/>
+          </a:fontRef>
+        </p:style>
+        <p:txBody>
+          <a:bodyPr rtlCol="0" anchor="ctr"/>
+          <a:lstStyle/>
+          <a:p>
+            <a:pPr algn="ctr"/>
+          </a:p>
+        </p:txBody>
+      </p:sp>
+      <p:sp>
+        <p:nvSpPr>
+          <p:cNvPr id="27" name="TextBox 26"/>
+          <p:cNvSpPr txBox="1"/>
+          <p:nvPr/>
+        </p:nvSpPr>
+        <p:spPr>
+          <a:xfrm>
+            <a:off x="12134088" y="5980176"/>
+            <a:ext cx="4892040" cy="466344"/>
+          </a:xfrm>
+          <a:prstGeom prst="rect">
+            <a:avLst/>
+          </a:prstGeom>
+          <a:noFill/>
+        </p:spPr>
+        <p:txBody>
+          <a:bodyPr wrap="square">
+            <a:spAutoFit/>
+          </a:bodyPr>
+          <a:lstStyle/>
+          <a:p>
+            <a:pPr algn="l"/>
+            <a:r>
+              <a:rPr sz="1500" b="1" i="0">
+                <a:solidFill>
+                  <a:srgbClr val="4C1D95"/>
+                </a:solidFill>
+              </a:rPr>
+              <a:t>🔤  PyMuPDF ≠ PDF.js Extraction</a:t>
+            </a:r>
+          </a:p>
+        </p:txBody>
+      </p:sp>
+      <p:sp>
+        <p:nvSpPr>
+          <p:cNvPr id="28" name="TextBox 27"/>
+          <p:cNvSpPr txBox="1"/>
+          <p:nvPr/>
+        </p:nvSpPr>
+        <p:spPr>
+          <a:xfrm>
+            <a:off x="12134088" y="6583679"/>
+            <a:ext cx="4892040" cy="2414016"/>
+          </a:xfrm>
+          <a:prstGeom prst="rect">
+            <a:avLst/>
+          </a:prstGeom>
+          <a:noFill/>
+        </p:spPr>
+        <p:txBody>
+          <a:bodyPr wrap="square">
+            <a:spAutoFit/>
+          </a:bodyPr>
+          <a:lstStyle/>
+          <a:p>
+            <a:pPr algn="l"/>
+            <a:r>
+              <a:rPr sz="1250" b="0" i="0">
+                <a:solidFill>
+                  <a:srgbClr val="7C3AED"/>
+                </a:solidFill>
+              </a:rPr>
+              <a:t>Math and symbols render differently at ingest (PyMuPDF) and in the viewer (PDF.js), requiring fuzzy word-anchor matching for highlighting.</a:t>
+            </a:r>
+          </a:p>
+        </p:txBody>
+      </p:sp>
+    </p:spTree>
+  </p:cSld>
+  <p:clrMapOvr>
+    <a:masterClrMapping/>
+  </p:clrMapOvr>
+</p:sld>
+</file>
+
+<file path=ppt/slides/slide14.xml><?xml version="1.0" encoding="utf-8"?>
+<p:sld xmlns:a="http://schemas.openxmlformats.org/drawingml/2006/main" xmlns:p="http://schemas.openxmlformats.org/presentationml/2006/main" xmlns:r="http://schemas.openxmlformats.org/officeDocument/2006/relationships">
+  <p:cSld>
+    <p:bg>
+      <p:bgPr>
+        <a:solidFill>
+          <a:srgbClr val="FFFFFF"/>
+        </a:solidFill>
+        <a:effectLst/>
+      </p:bgPr>
+    </p:bg>
+    <p:spTree>
+      <p:nvGrpSpPr>
+        <p:cNvPr id="1" name=""/>
+        <p:cNvGrpSpPr/>
+        <p:nvPr/>
+      </p:nvGrpSpPr>
+      <p:grpSpPr/>
+      <p:sp>
+        <p:nvSpPr>
+          <p:cNvPr id="2" name="TextBox 1"/>
+          <p:cNvSpPr txBox="1"/>
+          <p:nvPr/>
+        </p:nvSpPr>
+        <p:spPr>
+          <a:xfrm>
+            <a:off x="914400" y="484632"/>
+            <a:ext cx="16285463" cy="429768"/>
+          </a:xfrm>
+          <a:prstGeom prst="rect">
+            <a:avLst/>
+          </a:prstGeom>
+          <a:noFill/>
+        </p:spPr>
+        <p:txBody>
+          <a:bodyPr wrap="square">
+            <a:spAutoFit/>
+          </a:bodyPr>
+          <a:lstStyle/>
+          <a:p>
+            <a:pPr algn="l"/>
+            <a:r>
+              <a:rPr sz="1400" b="1" i="0">
+                <a:solidFill>
+                  <a:srgbClr val="7C3AED"/>
+                </a:solidFill>
+              </a:rPr>
+              <a:t>SYSTEM DESIGN</a:t>
+            </a:r>
+          </a:p>
+        </p:txBody>
+      </p:sp>
+      <p:sp>
+        <p:nvSpPr>
+          <p:cNvPr id="3" name="TextBox 2"/>
+          <p:cNvSpPr txBox="1"/>
+          <p:nvPr/>
+        </p:nvSpPr>
+        <p:spPr>
+          <a:xfrm>
+            <a:off x="914400" y="987552"/>
+            <a:ext cx="16285463" cy="502920"/>
+          </a:xfrm>
+          <a:prstGeom prst="rect">
+            <a:avLst/>
+          </a:prstGeom>
+          <a:noFill/>
+        </p:spPr>
+        <p:txBody>
+          <a:bodyPr wrap="square">
+            <a:spAutoFit/>
+          </a:bodyPr>
+          <a:lstStyle/>
+          <a:p>
+            <a:pPr algn="l"/>
+            <a:r>
+              <a:rPr sz="2800" b="1" i="0">
+                <a:solidFill>
+                  <a:srgbClr val="4C1D95"/>
+                </a:solidFill>
+              </a:rPr>
+              <a:t>Component architecture &amp; data flow</a:t>
+            </a:r>
+          </a:p>
+        </p:txBody>
+      </p:sp>
+      <p:sp>
+        <p:nvSpPr>
+          <p:cNvPr id="4" name="Rectangle 3"/>
+          <p:cNvSpPr/>
+          <p:nvPr/>
+        </p:nvSpPr>
+        <p:spPr>
+          <a:xfrm>
+            <a:off x="822960" y="1856231"/>
+            <a:ext cx="16651224" cy="54864"/>
+          </a:xfrm>
+          <a:prstGeom prst="rect">
+            <a:avLst/>
+          </a:prstGeom>
+          <a:solidFill>
+            <a:srgbClr val="7C3AED"/>
+          </a:solidFill>
+          <a:ln>
+            <a:noFill/>
+          </a:ln>
+        </p:spPr>
+        <p:style>
+          <a:lnRef idx="1">
+            <a:schemeClr val="accent1"/>
+          </a:lnRef>
+          <a:fillRef idx="3">
+            <a:schemeClr val="accent1"/>
+          </a:fillRef>
+          <a:effectRef idx="2">
+            <a:schemeClr val="accent1"/>
+          </a:effectRef>
+          <a:fontRef idx="minor">
+            <a:schemeClr val="lt1"/>
+          </a:fontRef>
+        </p:style>
+        <p:txBody>
+          <a:bodyPr rtlCol="0" anchor="ctr"/>
+          <a:lstStyle/>
+          <a:p>
+            <a:pPr algn="ctr"/>
+          </a:p>
+        </p:txBody>
+      </p:sp>
+      <p:sp>
+        <p:nvSpPr>
+          <p:cNvPr id="5" name="Rectangle 4"/>
+          <p:cNvSpPr/>
+          <p:nvPr/>
+        </p:nvSpPr>
+        <p:spPr>
+          <a:xfrm>
+            <a:off x="320040" y="3291840"/>
+            <a:ext cx="3474720" cy="3474720"/>
+          </a:xfrm>
+          <a:prstGeom prst="rect">
+            <a:avLst/>
+          </a:prstGeom>
+          <a:solidFill>
+            <a:srgbClr val="FFFFFF"/>
+          </a:solidFill>
+          <a:ln w="19050">
+            <a:solidFill>
+              <a:srgbClr val="7C3AED"/>
+            </a:solidFill>
+          </a:ln>
+        </p:spPr>
+        <p:style>
+          <a:lnRef idx="1">
+            <a:schemeClr val="accent1"/>
+          </a:lnRef>
+          <a:fillRef idx="3">
+            <a:schemeClr val="accent1"/>
+          </a:fillRef>
+          <a:effectRef idx="2">
+            <a:schemeClr val="accent1"/>
+          </a:effectRef>
+          <a:fontRef idx="minor">
+            <a:schemeClr val="lt1"/>
+          </a:fontRef>
+        </p:style>
+        <p:txBody>
+          <a:bodyPr rtlCol="0" anchor="ctr"/>
+          <a:lstStyle/>
+          <a:p>
+            <a:pPr algn="ctr"/>
+          </a:p>
+        </p:txBody>
+      </p:sp>
+      <p:sp>
+        <p:nvSpPr>
+          <p:cNvPr id="6" name="Rectangle 5"/>
+          <p:cNvSpPr/>
+          <p:nvPr/>
+        </p:nvSpPr>
+        <p:spPr>
+          <a:xfrm>
+            <a:off x="320040" y="3291840"/>
+            <a:ext cx="3474720" cy="54864"/>
+          </a:xfrm>
+          <a:prstGeom prst="rect">
+            <a:avLst/>
+          </a:prstGeom>
+          <a:solidFill>
+            <a:srgbClr val="7C3AED"/>
+          </a:solidFill>
+          <a:ln>
+            <a:noFill/>
+          </a:ln>
+        </p:spPr>
+        <p:style>
+          <a:lnRef idx="1">
+            <a:schemeClr val="accent1"/>
+          </a:lnRef>
+          <a:fillRef idx="3">
+            <a:schemeClr val="accent1"/>
+          </a:fillRef>
+          <a:effectRef idx="2">
+            <a:schemeClr val="accent1"/>
+          </a:effectRef>
+          <a:fontRef idx="minor">
+            <a:schemeClr val="lt1"/>
+          </a:fontRef>
+        </p:style>
+        <p:txBody>
+          <a:bodyPr rtlCol="0" anchor="ctr"/>
+          <a:lstStyle/>
+          <a:p>
+            <a:pPr algn="ctr"/>
+          </a:p>
+        </p:txBody>
+      </p:sp>
+      <p:sp>
+        <p:nvSpPr>
+          <p:cNvPr id="7" name="TextBox 6"/>
+          <p:cNvSpPr txBox="1"/>
+          <p:nvPr/>
+        </p:nvSpPr>
+        <p:spPr>
+          <a:xfrm>
+            <a:off x="548640" y="3456432"/>
+            <a:ext cx="3108960" cy="502920"/>
+          </a:xfrm>
+          <a:prstGeom prst="rect">
+            <a:avLst/>
+          </a:prstGeom>
+          <a:noFill/>
+        </p:spPr>
+        <p:txBody>
+          <a:bodyPr wrap="square">
+            <a:spAutoFit/>
+          </a:bodyPr>
+          <a:lstStyle/>
+          <a:p>
+            <a:pPr algn="l"/>
+            <a:r>
+              <a:rPr sz="2200" b="0" i="0">
+                <a:solidFill>
+                  <a:srgbClr val="4C1D95"/>
+                </a:solidFill>
+              </a:rPr>
+              <a:t>🌐</a:t>
+            </a:r>
+          </a:p>
+        </p:txBody>
+      </p:sp>
+      <p:sp>
+        <p:nvSpPr>
+          <p:cNvPr id="8" name="TextBox 7"/>
+          <p:cNvSpPr txBox="1"/>
+          <p:nvPr/>
+        </p:nvSpPr>
+        <p:spPr>
+          <a:xfrm>
+            <a:off x="548640" y="3977639"/>
+            <a:ext cx="3108960" cy="457200"/>
+          </a:xfrm>
+          <a:prstGeom prst="rect">
+            <a:avLst/>
+          </a:prstGeom>
+          <a:noFill/>
+        </p:spPr>
+        <p:txBody>
+          <a:bodyPr wrap="square">
+            <a:spAutoFit/>
+          </a:bodyPr>
+          <a:lstStyle/>
+          <a:p>
+            <a:pPr algn="l"/>
+            <a:r>
+              <a:rPr sz="1600" b="1" i="0">
+                <a:solidFill>
+                  <a:srgbClr val="4C1D95"/>
+                </a:solidFill>
+              </a:rPr>
+              <a:t>Browser</a:t>
+            </a:r>
+          </a:p>
+        </p:txBody>
+      </p:sp>
+      <p:sp>
+        <p:nvSpPr>
+          <p:cNvPr id="9" name="TextBox 8"/>
+          <p:cNvSpPr txBox="1"/>
+          <p:nvPr/>
+        </p:nvSpPr>
+        <p:spPr>
+          <a:xfrm>
+            <a:off x="548640" y="4480560"/>
+            <a:ext cx="3108960" cy="2103120"/>
+          </a:xfrm>
+          <a:prstGeom prst="rect">
+            <a:avLst/>
+          </a:prstGeom>
+          <a:noFill/>
+        </p:spPr>
+        <p:txBody>
+          <a:bodyPr wrap="square">
+            <a:spAutoFit/>
+          </a:bodyPr>
+          <a:lstStyle/>
+          <a:p>
+            <a:pPr algn="l"/>
+            <a:r>
+              <a:rPr sz="1150" b="0" i="0">
+                <a:solidFill>
+                  <a:srgbClr val="7C3AED"/>
+                </a:solidFill>
+              </a:rPr>
+              <a:t>index.html
+PDF.js viewer
+SSE streaming
+citation pills</a:t>
+            </a:r>
+          </a:p>
+        </p:txBody>
+      </p:sp>
+      <p:sp>
+        <p:nvSpPr>
+          <p:cNvPr id="10" name="Rectangle 9"/>
+          <p:cNvSpPr/>
+          <p:nvPr/>
+        </p:nvSpPr>
+        <p:spPr>
+          <a:xfrm>
+            <a:off x="7406640" y="2194560"/>
+            <a:ext cx="3474720" cy="5120640"/>
+          </a:xfrm>
+          <a:prstGeom prst="rect">
+            <a:avLst/>
+          </a:prstGeom>
+          <a:solidFill>
+            <a:srgbClr val="FFFFFF"/>
+          </a:solidFill>
+          <a:ln w="19050">
+            <a:solidFill>
+              <a:srgbClr val="059669"/>
+            </a:solidFill>
+          </a:ln>
+        </p:spPr>
+        <p:style>
+          <a:lnRef idx="1">
+            <a:schemeClr val="accent1"/>
+          </a:lnRef>
+          <a:fillRef idx="3">
+            <a:schemeClr val="accent1"/>
+          </a:fillRef>
+          <a:effectRef idx="2">
+            <a:schemeClr val="accent1"/>
+          </a:effectRef>
+          <a:fontRef idx="minor">
+            <a:schemeClr val="lt1"/>
+          </a:fontRef>
+        </p:style>
+        <p:txBody>
+          <a:bodyPr rtlCol="0" anchor="ctr"/>
+          <a:lstStyle/>
+          <a:p>
+            <a:pPr algn="ctr"/>
+          </a:p>
+        </p:txBody>
+      </p:sp>
+      <p:sp>
+        <p:nvSpPr>
+          <p:cNvPr id="11" name="Rectangle 10"/>
+          <p:cNvSpPr/>
+          <p:nvPr/>
+        </p:nvSpPr>
+        <p:spPr>
+          <a:xfrm>
+            <a:off x="7406640" y="2194560"/>
+            <a:ext cx="3474720" cy="54864"/>
+          </a:xfrm>
+          <a:prstGeom prst="rect">
+            <a:avLst/>
+          </a:prstGeom>
+          <a:solidFill>
+            <a:srgbClr val="059669"/>
+          </a:solidFill>
+          <a:ln>
+            <a:noFill/>
+          </a:ln>
+        </p:spPr>
+        <p:style>
+          <a:lnRef idx="1">
+            <a:schemeClr val="accent1"/>
+          </a:lnRef>
+          <a:fillRef idx="3">
+            <a:schemeClr val="accent1"/>
+          </a:fillRef>
+          <a:effectRef idx="2">
+            <a:schemeClr val="accent1"/>
+          </a:effectRef>
+          <a:fontRef idx="minor">
+            <a:schemeClr val="lt1"/>
+          </a:fontRef>
+        </p:style>
+        <p:txBody>
+          <a:bodyPr rtlCol="0" anchor="ctr"/>
+          <a:lstStyle/>
+          <a:p>
+            <a:pPr algn="ctr"/>
+          </a:p>
+        </p:txBody>
+      </p:sp>
+      <p:sp>
+        <p:nvSpPr>
+          <p:cNvPr id="12" name="TextBox 11"/>
+          <p:cNvSpPr txBox="1"/>
+          <p:nvPr/>
+        </p:nvSpPr>
+        <p:spPr>
+          <a:xfrm>
+            <a:off x="7635240" y="2359152"/>
+            <a:ext cx="3108960" cy="502920"/>
+          </a:xfrm>
+          <a:prstGeom prst="rect">
+            <a:avLst/>
+          </a:prstGeom>
+          <a:noFill/>
+        </p:spPr>
+        <p:txBody>
+          <a:bodyPr wrap="square">
+            <a:spAutoFit/>
+          </a:bodyPr>
+          <a:lstStyle/>
+          <a:p>
+            <a:pPr algn="l"/>
+            <a:r>
+              <a:rPr sz="2200" b="0" i="0">
+                <a:solidFill>
+                  <a:srgbClr val="4C1D95"/>
+                </a:solidFill>
+              </a:rPr>
+              <a:t>⚙️</a:t>
+            </a:r>
+          </a:p>
+        </p:txBody>
+      </p:sp>
+      <p:sp>
+        <p:nvSpPr>
+          <p:cNvPr id="13" name="TextBox 12"/>
+          <p:cNvSpPr txBox="1"/>
+          <p:nvPr/>
+        </p:nvSpPr>
+        <p:spPr>
+          <a:xfrm>
+            <a:off x="7635240" y="2880360"/>
+            <a:ext cx="3108960" cy="457200"/>
+          </a:xfrm>
+          <a:prstGeom prst="rect">
+            <a:avLst/>
+          </a:prstGeom>
+          <a:noFill/>
+        </p:spPr>
+        <p:txBody>
+          <a:bodyPr wrap="square">
+            <a:spAutoFit/>
+          </a:bodyPr>
+          <a:lstStyle/>
+          <a:p>
+            <a:pPr algn="l"/>
+            <a:r>
+              <a:rPr sz="1600" b="1" i="0">
+                <a:solidFill>
+                  <a:srgbClr val="4C1D95"/>
+                </a:solidFill>
+              </a:rPr>
+              <a:t>FastAPI</a:t>
+            </a:r>
+          </a:p>
+        </p:txBody>
+      </p:sp>
+      <p:sp>
+        <p:nvSpPr>
+          <p:cNvPr id="14" name="TextBox 13"/>
+          <p:cNvSpPr txBox="1"/>
+          <p:nvPr/>
+        </p:nvSpPr>
+        <p:spPr>
+          <a:xfrm>
+            <a:off x="7635240" y="3383280"/>
+            <a:ext cx="3108960" cy="3749039"/>
+          </a:xfrm>
+          <a:prstGeom prst="rect">
+            <a:avLst/>
+          </a:prstGeom>
+          <a:noFill/>
+        </p:spPr>
+        <p:txBody>
+          <a:bodyPr wrap="square">
+            <a:spAutoFit/>
+          </a:bodyPr>
+          <a:lstStyle/>
+          <a:p>
+            <a:pPr algn="l"/>
+            <a:r>
+              <a:rPr sz="1150" b="0" i="0">
+                <a:solidFill>
+                  <a:srgbClr val="7C3AED"/>
+                </a:solidFill>
+              </a:rPr>
+              <a:t>POST /ingest
+POST /query
+DELETE /doc
+GET /doc/info
+GET /health
+asyncpg · uvicorn</a:t>
+            </a:r>
+          </a:p>
+        </p:txBody>
+      </p:sp>
+      <p:sp>
+        <p:nvSpPr>
+          <p:cNvPr id="15" name="Rectangle 14"/>
+          <p:cNvSpPr/>
+          <p:nvPr/>
+        </p:nvSpPr>
+        <p:spPr>
+          <a:xfrm>
+            <a:off x="14493240" y="3291840"/>
+            <a:ext cx="3474720" cy="3474720"/>
+          </a:xfrm>
+          <a:prstGeom prst="rect">
+            <a:avLst/>
+          </a:prstGeom>
+          <a:solidFill>
+            <a:srgbClr val="FFFFFF"/>
+          </a:solidFill>
+          <a:ln w="19050">
+            <a:solidFill>
+              <a:srgbClr val="4285F4"/>
+            </a:solidFill>
+          </a:ln>
+        </p:spPr>
+        <p:style>
+          <a:lnRef idx="1">
+            <a:schemeClr val="accent1"/>
+          </a:lnRef>
+          <a:fillRef idx="3">
+            <a:schemeClr val="accent1"/>
+          </a:fillRef>
+          <a:effectRef idx="2">
+            <a:schemeClr val="accent1"/>
+          </a:effectRef>
+          <a:fontRef idx="minor">
+            <a:schemeClr val="lt1"/>
+          </a:fontRef>
+        </p:style>
+        <p:txBody>
+          <a:bodyPr rtlCol="0" anchor="ctr"/>
+          <a:lstStyle/>
+          <a:p>
+            <a:pPr algn="ctr"/>
+          </a:p>
+        </p:txBody>
+      </p:sp>
+      <p:sp>
+        <p:nvSpPr>
+          <p:cNvPr id="16" name="Rectangle 15"/>
+          <p:cNvSpPr/>
+          <p:nvPr/>
+        </p:nvSpPr>
+        <p:spPr>
+          <a:xfrm>
+            <a:off x="14493240" y="3291840"/>
+            <a:ext cx="3474720" cy="54864"/>
+          </a:xfrm>
+          <a:prstGeom prst="rect">
+            <a:avLst/>
+          </a:prstGeom>
+          <a:solidFill>
+            <a:srgbClr val="4285F4"/>
+          </a:solidFill>
+          <a:ln>
+            <a:noFill/>
+          </a:ln>
+        </p:spPr>
+        <p:style>
+          <a:lnRef idx="1">
+            <a:schemeClr val="accent1"/>
+          </a:lnRef>
+          <a:fillRef idx="3">
+            <a:schemeClr val="accent1"/>
+          </a:fillRef>
+          <a:effectRef idx="2">
+            <a:schemeClr val="accent1"/>
+          </a:effectRef>
+          <a:fontRef idx="minor">
+            <a:schemeClr val="lt1"/>
+          </a:fontRef>
+        </p:style>
+        <p:txBody>
+          <a:bodyPr rtlCol="0" anchor="ctr"/>
+          <a:lstStyle/>
+          <a:p>
+            <a:pPr algn="ctr"/>
+          </a:p>
+        </p:txBody>
+      </p:sp>
+      <p:sp>
+        <p:nvSpPr>
+          <p:cNvPr id="17" name="TextBox 16"/>
+          <p:cNvSpPr txBox="1"/>
+          <p:nvPr/>
+        </p:nvSpPr>
+        <p:spPr>
+          <a:xfrm>
+            <a:off x="14721840" y="3456432"/>
+            <a:ext cx="3108960" cy="502920"/>
+          </a:xfrm>
+          <a:prstGeom prst="rect">
+            <a:avLst/>
+          </a:prstGeom>
+          <a:noFill/>
+        </p:spPr>
+        <p:txBody>
+          <a:bodyPr wrap="square">
+            <a:spAutoFit/>
+          </a:bodyPr>
+          <a:lstStyle/>
+          <a:p>
+            <a:pPr algn="l"/>
+            <a:r>
+              <a:rPr sz="2200" b="0" i="0">
+                <a:solidFill>
+                  <a:srgbClr val="4C1D95"/>
+                </a:solidFill>
+              </a:rPr>
+              <a:t>🧠</a:t>
+            </a:r>
+          </a:p>
+        </p:txBody>
+      </p:sp>
+      <p:sp>
+        <p:nvSpPr>
+          <p:cNvPr id="18" name="TextBox 17"/>
+          <p:cNvSpPr txBox="1"/>
+          <p:nvPr/>
+        </p:nvSpPr>
+        <p:spPr>
+          <a:xfrm>
+            <a:off x="14721840" y="3977639"/>
+            <a:ext cx="3108960" cy="457200"/>
+          </a:xfrm>
+          <a:prstGeom prst="rect">
+            <a:avLst/>
+          </a:prstGeom>
+          <a:noFill/>
+        </p:spPr>
+        <p:txBody>
+          <a:bodyPr wrap="square">
+            <a:spAutoFit/>
+          </a:bodyPr>
+          <a:lstStyle/>
+          <a:p>
+            <a:pPr algn="l"/>
+            <a:r>
+              <a:rPr sz="1600" b="1" i="0">
+                <a:solidFill>
+                  <a:srgbClr val="4C1D95"/>
+                </a:solidFill>
+              </a:rPr>
+              <a:t>Gemini API</a:t>
+            </a:r>
+          </a:p>
+        </p:txBody>
+      </p:sp>
+      <p:sp>
+        <p:nvSpPr>
+          <p:cNvPr id="19" name="TextBox 18"/>
+          <p:cNvSpPr txBox="1"/>
+          <p:nvPr/>
+        </p:nvSpPr>
+        <p:spPr>
+          <a:xfrm>
+            <a:off x="14721840" y="4480560"/>
+            <a:ext cx="3108960" cy="2103120"/>
+          </a:xfrm>
+          <a:prstGeom prst="rect">
+            <a:avLst/>
+          </a:prstGeom>
+          <a:noFill/>
+        </p:spPr>
+        <p:txBody>
+          <a:bodyPr wrap="square">
+            <a:spAutoFit/>
+          </a:bodyPr>
+          <a:lstStyle/>
+          <a:p>
+            <a:pPr algn="l"/>
+            <a:r>
+              <a:rPr sz="1150" b="0" i="0">
+                <a:solidFill>
+                  <a:srgbClr val="7C3AED"/>
+                </a:solidFill>
+              </a:rPr>
+              <a:t>embedding-2 (768-dim)
+RETRIEVAL_DOCUMENT/QUERY
+2.5-flash rerank
+2.5-flash answer (SSE)</a:t>
+            </a:r>
+          </a:p>
+        </p:txBody>
+      </p:sp>
+      <p:sp>
+        <p:nvSpPr>
+          <p:cNvPr id="20" name="Rectangle 19"/>
+          <p:cNvSpPr/>
+          <p:nvPr/>
+        </p:nvSpPr>
+        <p:spPr>
+          <a:xfrm>
+            <a:off x="7406640" y="7863840"/>
+            <a:ext cx="3474720" cy="2103120"/>
+          </a:xfrm>
+          <a:prstGeom prst="rect">
+            <a:avLst/>
+          </a:prstGeom>
+          <a:solidFill>
+            <a:srgbClr val="FFFFFF"/>
+          </a:solidFill>
+          <a:ln w="19050">
+            <a:solidFill>
+              <a:srgbClr val="336791"/>
+            </a:solidFill>
+          </a:ln>
+        </p:spPr>
+        <p:style>
+          <a:lnRef idx="1">
+            <a:schemeClr val="accent1"/>
+          </a:lnRef>
+          <a:fillRef idx="3">
+            <a:schemeClr val="accent1"/>
+          </a:fillRef>
+          <a:effectRef idx="2">
+            <a:schemeClr val="accent1"/>
+          </a:effectRef>
+          <a:fontRef idx="minor">
+            <a:schemeClr val="lt1"/>
+          </a:fontRef>
+        </p:style>
+        <p:txBody>
+          <a:bodyPr rtlCol="0" anchor="ctr"/>
+          <a:lstStyle/>
+          <a:p>
+            <a:pPr algn="ctr"/>
+          </a:p>
+        </p:txBody>
+      </p:sp>
+      <p:sp>
+        <p:nvSpPr>
+          <p:cNvPr id="21" name="Rectangle 20"/>
+          <p:cNvSpPr/>
+          <p:nvPr/>
+        </p:nvSpPr>
+        <p:spPr>
+          <a:xfrm>
+            <a:off x="7406640" y="7863840"/>
+            <a:ext cx="3474720" cy="54864"/>
+          </a:xfrm>
+          <a:prstGeom prst="rect">
+            <a:avLst/>
+          </a:prstGeom>
+          <a:solidFill>
+            <a:srgbClr val="336791"/>
+          </a:solidFill>
+          <a:ln>
+            <a:noFill/>
+          </a:ln>
+        </p:spPr>
+        <p:style>
+          <a:lnRef idx="1">
+            <a:schemeClr val="accent1"/>
+          </a:lnRef>
+          <a:fillRef idx="3">
+            <a:schemeClr val="accent1"/>
+          </a:fillRef>
+          <a:effectRef idx="2">
+            <a:schemeClr val="accent1"/>
+          </a:effectRef>
+          <a:fontRef idx="minor">
+            <a:schemeClr val="lt1"/>
+          </a:fontRef>
+        </p:style>
+        <p:txBody>
+          <a:bodyPr rtlCol="0" anchor="ctr"/>
+          <a:lstStyle/>
+          <a:p>
+            <a:pPr algn="ctr"/>
+          </a:p>
+        </p:txBody>
+      </p:sp>
+      <p:sp>
+        <p:nvSpPr>
+          <p:cNvPr id="22" name="TextBox 21"/>
+          <p:cNvSpPr txBox="1"/>
+          <p:nvPr/>
+        </p:nvSpPr>
+        <p:spPr>
+          <a:xfrm>
+            <a:off x="7635240" y="8028431"/>
+            <a:ext cx="3108960" cy="502920"/>
+          </a:xfrm>
+          <a:prstGeom prst="rect">
+            <a:avLst/>
+          </a:prstGeom>
+          <a:noFill/>
+        </p:spPr>
+        <p:txBody>
+          <a:bodyPr wrap="square">
+            <a:spAutoFit/>
+          </a:bodyPr>
+          <a:lstStyle/>
+          <a:p>
+            <a:pPr algn="l"/>
+            <a:r>
+              <a:rPr sz="2200" b="0" i="0">
+                <a:solidFill>
+                  <a:srgbClr val="4C1D95"/>
+                </a:solidFill>
+              </a:rPr>
+              <a:t>🗄️</a:t>
+            </a:r>
+          </a:p>
+        </p:txBody>
+      </p:sp>
+      <p:sp>
+        <p:nvSpPr>
+          <p:cNvPr id="23" name="TextBox 22"/>
+          <p:cNvSpPr txBox="1"/>
+          <p:nvPr/>
+        </p:nvSpPr>
+        <p:spPr>
+          <a:xfrm>
+            <a:off x="7635240" y="8549640"/>
+            <a:ext cx="3108960" cy="457200"/>
+          </a:xfrm>
+          <a:prstGeom prst="rect">
+            <a:avLst/>
+          </a:prstGeom>
+          <a:noFill/>
+        </p:spPr>
+        <p:txBody>
+          <a:bodyPr wrap="square">
+            <a:spAutoFit/>
+          </a:bodyPr>
+          <a:lstStyle/>
+          <a:p>
+            <a:pPr algn="l"/>
+            <a:r>
+              <a:rPr sz="1600" b="1" i="0">
+                <a:solidFill>
+                  <a:srgbClr val="4C1D95"/>
+                </a:solidFill>
+              </a:rPr>
+              <a:t>PostgreSQL + pgvector</a:t>
+            </a:r>
+          </a:p>
+        </p:txBody>
+      </p:sp>
+      <p:sp>
+        <p:nvSpPr>
+          <p:cNvPr id="24" name="TextBox 23"/>
+          <p:cNvSpPr txBox="1"/>
+          <p:nvPr/>
+        </p:nvSpPr>
+        <p:spPr>
+          <a:xfrm>
+            <a:off x="7635240" y="9052560"/>
+            <a:ext cx="3108960" cy="731519"/>
+          </a:xfrm>
+          <a:prstGeom prst="rect">
+            <a:avLst/>
+          </a:prstGeom>
+          <a:noFill/>
+        </p:spPr>
+        <p:txBody>
+          <a:bodyPr wrap="square">
+            <a:spAutoFit/>
+          </a:bodyPr>
+          <a:lstStyle/>
+          <a:p>
+            <a:pPr algn="l"/>
+            <a:r>
+              <a:rPr sz="1150" b="0" i="0">
+                <a:solidFill>
+                  <a:srgbClr val="7C3AED"/>
+                </a:solidFill>
+              </a:rPr>
+              <a:t>chunks · doc_meta
+HNSW cosine · tsvector BM25
+RRF fusion</a:t>
+            </a:r>
+          </a:p>
+        </p:txBody>
+      </p:sp>
+      <p:cxnSp>
+        <p:nvCxnSpPr>
+          <p:cNvPr id="25" name="Connector 24"/>
+          <p:cNvCxnSpPr/>
+          <p:nvPr/>
+        </p:nvCxnSpPr>
+        <p:spPr>
+          <a:xfrm>
+            <a:off x="3794759" y="4297680"/>
+            <a:ext cx="3611881" cy="0"/>
+          </a:xfrm>
+          <a:prstGeom prst="line">
+            <a:avLst/>
+          </a:prstGeom>
+          <a:ln w="25400">
+            <a:solidFill>
+              <a:srgbClr val="7C3AED"/>
+            </a:solidFill>
+            <a:tailEnd type="arrow" w="med" len="med"/>
+          </a:ln>
+        </p:spPr>
+        <p:style>
+          <a:lnRef idx="2">
+            <a:schemeClr val="accent1"/>
+          </a:lnRef>
+          <a:fillRef idx="0">
+            <a:schemeClr val="accent1"/>
+          </a:fillRef>
+          <a:effectRef idx="1">
+            <a:schemeClr val="accent1"/>
+          </a:effectRef>
+          <a:fontRef idx="minor">
+            <a:schemeClr val="tx1"/>
+          </a:fontRef>
+        </p:style>
+      </p:cxnSp>
+      <p:sp>
+        <p:nvSpPr>
+          <p:cNvPr id="26" name="TextBox 25"/>
+          <p:cNvSpPr txBox="1"/>
+          <p:nvPr/>
+        </p:nvSpPr>
+        <p:spPr>
+          <a:xfrm>
+            <a:off x="3840479" y="3977640"/>
+            <a:ext cx="3520440" cy="292608"/>
+          </a:xfrm>
+          <a:prstGeom prst="rect">
+            <a:avLst/>
+          </a:prstGeom>
+          <a:noFill/>
+        </p:spPr>
+        <p:txBody>
+          <a:bodyPr wrap="square">
+            <a:spAutoFit/>
+          </a:bodyPr>
+          <a:lstStyle/>
+          <a:p>
+            <a:pPr algn="ctr"/>
+            <a:r>
+              <a:rPr sz="1000" b="0" i="1">
+                <a:solidFill>
+                  <a:srgbClr val="64748B"/>
+                </a:solidFill>
+              </a:rPr>
+              <a:t>upload PDF / query</a:t>
+            </a:r>
+          </a:p>
+        </p:txBody>
+      </p:sp>
+      <p:cxnSp>
+        <p:nvCxnSpPr>
+          <p:cNvPr id="27" name="Connector 26"/>
+          <p:cNvCxnSpPr/>
+          <p:nvPr/>
+        </p:nvCxnSpPr>
+        <p:spPr>
+          <a:xfrm flipH="1">
+            <a:off x="3794759" y="5486400"/>
+            <a:ext cx="3611881" cy="0"/>
+          </a:xfrm>
+          <a:prstGeom prst="line">
+            <a:avLst/>
+          </a:prstGeom>
+          <a:ln w="25400">
+            <a:solidFill>
+              <a:srgbClr val="059669"/>
+            </a:solidFill>
+            <a:tailEnd type="arrow" w="med" len="med"/>
+          </a:ln>
+        </p:spPr>
+        <p:style>
+          <a:lnRef idx="2">
+            <a:schemeClr val="accent1"/>
+          </a:lnRef>
+          <a:fillRef idx="0">
+            <a:schemeClr val="accent1"/>
+          </a:fillRef>
+          <a:effectRef idx="1">
+            <a:schemeClr val="accent1"/>
+          </a:effectRef>
+          <a:fontRef idx="minor">
+            <a:schemeClr val="tx1"/>
+          </a:fontRef>
+        </p:style>
+      </p:cxnSp>
+      <p:sp>
+        <p:nvSpPr>
+          <p:cNvPr id="28" name="TextBox 27"/>
+          <p:cNvSpPr txBox="1"/>
+          <p:nvPr/>
+        </p:nvSpPr>
+        <p:spPr>
+          <a:xfrm>
+            <a:off x="3840479" y="5559552"/>
+            <a:ext cx="3520440" cy="292608"/>
+          </a:xfrm>
+          <a:prstGeom prst="rect">
+            <a:avLst/>
+          </a:prstGeom>
+          <a:noFill/>
+        </p:spPr>
+        <p:txBody>
+          <a:bodyPr wrap="square">
+            <a:spAutoFit/>
+          </a:bodyPr>
+          <a:lstStyle/>
+          <a:p>
+            <a:pPr algn="ctr"/>
+            <a:r>
+              <a:rPr sz="1000" b="0" i="1">
+                <a:solidFill>
+                  <a:srgbClr val="64748B"/>
+                </a:solidFill>
+              </a:rPr>
+              <a:t>SSE stream</a:t>
+            </a:r>
+          </a:p>
+        </p:txBody>
+      </p:sp>
+      <p:cxnSp>
+        <p:nvCxnSpPr>
+          <p:cNvPr id="29" name="Connector 28"/>
+          <p:cNvCxnSpPr/>
+          <p:nvPr/>
+        </p:nvCxnSpPr>
+        <p:spPr>
+          <a:xfrm>
+            <a:off x="10881359" y="4297680"/>
+            <a:ext cx="3611881" cy="0"/>
+          </a:xfrm>
+          <a:prstGeom prst="line">
+            <a:avLst/>
+          </a:prstGeom>
+          <a:ln w="25400">
+            <a:solidFill>
+              <a:srgbClr val="4285F4"/>
+            </a:solidFill>
+            <a:tailEnd type="arrow" w="med" len="med"/>
+          </a:ln>
+        </p:spPr>
+        <p:style>
+          <a:lnRef idx="2">
+            <a:schemeClr val="accent1"/>
+          </a:lnRef>
+          <a:fillRef idx="0">
+            <a:schemeClr val="accent1"/>
+          </a:fillRef>
+          <a:effectRef idx="1">
+            <a:schemeClr val="accent1"/>
+          </a:effectRef>
+          <a:fontRef idx="minor">
+            <a:schemeClr val="tx1"/>
+          </a:fontRef>
+        </p:style>
+      </p:cxnSp>
+      <p:sp>
+        <p:nvSpPr>
+          <p:cNvPr id="30" name="TextBox 29"/>
+          <p:cNvSpPr txBox="1"/>
+          <p:nvPr/>
+        </p:nvSpPr>
+        <p:spPr>
+          <a:xfrm>
+            <a:off x="10927080" y="3977640"/>
+            <a:ext cx="3520440" cy="292608"/>
+          </a:xfrm>
+          <a:prstGeom prst="rect">
+            <a:avLst/>
+          </a:prstGeom>
+          <a:noFill/>
+        </p:spPr>
+        <p:txBody>
+          <a:bodyPr wrap="square">
+            <a:spAutoFit/>
+          </a:bodyPr>
+          <a:lstStyle/>
+          <a:p>
+            <a:pPr algn="ctr"/>
+            <a:r>
+              <a:rPr sz="1000" b="0" i="1">
+                <a:solidFill>
+                  <a:srgbClr val="64748B"/>
+                </a:solidFill>
+              </a:rPr>
+              <a:t>embed / rerank / answer</a:t>
+            </a:r>
+          </a:p>
+        </p:txBody>
+      </p:sp>
+      <p:cxnSp>
+        <p:nvCxnSpPr>
+          <p:cNvPr id="31" name="Connector 30"/>
+          <p:cNvCxnSpPr/>
+          <p:nvPr/>
+        </p:nvCxnSpPr>
+        <p:spPr>
+          <a:xfrm flipH="1">
+            <a:off x="10881359" y="5577840"/>
+            <a:ext cx="3611881" cy="0"/>
+          </a:xfrm>
+          <a:prstGeom prst="line">
+            <a:avLst/>
+          </a:prstGeom>
+          <a:ln w="25400">
+            <a:solidFill>
+              <a:srgbClr val="4285F4"/>
+            </a:solidFill>
+            <a:tailEnd type="arrow" w="med" len="med"/>
+          </a:ln>
+        </p:spPr>
+        <p:style>
+          <a:lnRef idx="2">
+            <a:schemeClr val="accent1"/>
+          </a:lnRef>
+          <a:fillRef idx="0">
+            <a:schemeClr val="accent1"/>
+          </a:fillRef>
+          <a:effectRef idx="1">
+            <a:schemeClr val="accent1"/>
+          </a:effectRef>
+          <a:fontRef idx="minor">
+            <a:schemeClr val="tx1"/>
+          </a:fontRef>
+        </p:style>
+      </p:cxnSp>
+      <p:sp>
+        <p:nvSpPr>
+          <p:cNvPr id="32" name="TextBox 31"/>
+          <p:cNvSpPr txBox="1"/>
+          <p:nvPr/>
+        </p:nvSpPr>
+        <p:spPr>
+          <a:xfrm>
+            <a:off x="10927080" y="5650992"/>
+            <a:ext cx="3520440" cy="292608"/>
+          </a:xfrm>
+          <a:prstGeom prst="rect">
+            <a:avLst/>
+          </a:prstGeom>
+          <a:noFill/>
+        </p:spPr>
+        <p:txBody>
+          <a:bodyPr wrap="square">
+            <a:spAutoFit/>
+          </a:bodyPr>
+          <a:lstStyle/>
+          <a:p>
+            <a:pPr algn="ctr"/>
+            <a:r>
+              <a:rPr sz="1000" b="0" i="1">
+                <a:solidFill>
+                  <a:srgbClr val="64748B"/>
+                </a:solidFill>
+              </a:rPr>
+              <a:t>vectors / rankings / tokens</a:t>
+            </a:r>
+          </a:p>
+        </p:txBody>
+      </p:sp>
+      <p:cxnSp>
+        <p:nvCxnSpPr>
+          <p:cNvPr id="33" name="Connector 32"/>
+          <p:cNvCxnSpPr/>
+          <p:nvPr/>
+        </p:nvCxnSpPr>
+        <p:spPr>
+          <a:xfrm>
+            <a:off x="9144000" y="7315200"/>
+            <a:ext cx="0" cy="548640"/>
+          </a:xfrm>
+          <a:prstGeom prst="line">
+            <a:avLst/>
+          </a:prstGeom>
+          <a:ln w="25400">
+            <a:solidFill>
+              <a:srgbClr val="336791"/>
+            </a:solidFill>
+            <a:tailEnd type="arrow" w="med" len="med"/>
+          </a:ln>
+        </p:spPr>
+        <p:style>
+          <a:lnRef idx="2">
+            <a:schemeClr val="accent1"/>
+          </a:lnRef>
+          <a:fillRef idx="0">
+            <a:schemeClr val="accent1"/>
+          </a:fillRef>
+          <a:effectRef idx="1">
+            <a:schemeClr val="accent1"/>
+          </a:effectRef>
+          <a:fontRef idx="minor">
+            <a:schemeClr val="tx1"/>
+          </a:fontRef>
+        </p:style>
+      </p:cxnSp>
+      <p:sp>
+        <p:nvSpPr>
+          <p:cNvPr id="34" name="TextBox 33"/>
+          <p:cNvSpPr txBox="1"/>
+          <p:nvPr/>
+        </p:nvSpPr>
+        <p:spPr>
+          <a:xfrm>
+            <a:off x="9235440" y="7424928"/>
+            <a:ext cx="2011680" cy="329184"/>
+          </a:xfrm>
+          <a:prstGeom prst="rect">
+            <a:avLst/>
+          </a:prstGeom>
+          <a:noFill/>
+        </p:spPr>
+        <p:txBody>
+          <a:bodyPr wrap="square">
+            <a:spAutoFit/>
+          </a:bodyPr>
+          <a:lstStyle/>
+          <a:p>
+            <a:pPr algn="l"/>
+            <a:r>
+              <a:rPr sz="1000" b="0" i="1">
+                <a:solidFill>
+                  <a:srgbClr val="64748B"/>
+                </a:solidFill>
+              </a:rPr>
+              <a:t>store &amp; retrieve</a:t>
+            </a:r>
+          </a:p>
+        </p:txBody>
+      </p:sp>
+      <p:sp>
+        <p:nvSpPr>
+          <p:cNvPr id="35" name="TextBox 34"/>
+          <p:cNvSpPr txBox="1"/>
+          <p:nvPr/>
+        </p:nvSpPr>
+        <p:spPr>
+          <a:xfrm>
+            <a:off x="457200" y="10058400"/>
+            <a:ext cx="17373600" cy="274320"/>
+          </a:xfrm>
+          <a:prstGeom prst="rect">
+            <a:avLst/>
+          </a:prstGeom>
+          <a:noFill/>
+        </p:spPr>
+        <p:txBody>
+          <a:bodyPr wrap="none">
+            <a:spAutoFit/>
+          </a:bodyPr>
+          <a:lstStyle/>
+          <a:p>
+            <a:pPr algn="l"/>
+            <a:r>
+              <a:rPr sz="900" b="0" i="0">
+                <a:solidFill>
+                  <a:srgbClr val="94A3B8"/>
+                </a:solidFill>
+              </a:rPr>
+              <a:t>Ingest flow: Browser → FastAPI → Gemini (embed) → Postgres (store)     Query flow: Browser → FastAPI → Postgres (hybrid search) → Gemini (rerank+answer) → Browser (SSE)</a:t>
+            </a:r>
+          </a:p>
+        </p:txBody>
+      </p:sp>
+    </p:spTree>
+  </p:cSld>
+  <p:clrMapOvr>
+    <a:masterClrMapping/>
+  </p:clrMapOvr>
+</p:sld>
+</file>
+
 <file path=ppt/slides/slide2.xml><?xml version="1.0" encoding="utf-8"?>
 <p:sld xmlns:p="http://schemas.openxmlformats.org/presentationml/2006/main" xmlns:a="http://schemas.openxmlformats.org/drawingml/2006/main">
   <p:cSld>

</xml_diff>

<commit_message>
docs: reflect status indicator, live streaming, and rerank removal
Update README design decisions and usage flow; remove re-ranking step
from both system design slides in the PPTX.

Co-Authored-By: Claude Sonnet 4.6 <noreply@anthropic.com>
</commit_message>
<xml_diff>
--- a/NYMBL-DOCRAG.pptx
+++ b/NYMBL-DOCRAG.pptx
@@ -6928,6 +6928,2370 @@
 </file>
 
 <file path=ppt/slides/slide12.xml><?xml version="1.0" encoding="utf-8"?>
+<p:sld xmlns:a="http://schemas.openxmlformats.org/drawingml/2006/main" xmlns:p="http://schemas.openxmlformats.org/presentationml/2006/main" xmlns:r="http://schemas.openxmlformats.org/officeDocument/2006/relationships">
+  <p:cSld>
+    <p:bg>
+      <p:bgPr>
+        <a:solidFill>
+          <a:srgbClr val="FFFFFF"/>
+        </a:solidFill>
+        <a:effectLst/>
+      </p:bgPr>
+    </p:bg>
+    <p:spTree>
+      <p:nvGrpSpPr>
+        <p:cNvPr id="1" name=""/>
+        <p:cNvGrpSpPr/>
+        <p:nvPr/>
+      </p:nvGrpSpPr>
+      <p:grpSpPr/>
+      <p:sp>
+        <p:nvSpPr>
+          <p:cNvPr id="2" name="TextBox 1"/>
+          <p:cNvSpPr txBox="1"/>
+          <p:nvPr/>
+        </p:nvSpPr>
+        <p:spPr>
+          <a:xfrm>
+            <a:off x="914400" y="484632"/>
+            <a:ext cx="16285463" cy="429768"/>
+          </a:xfrm>
+          <a:prstGeom prst="rect">
+            <a:avLst/>
+          </a:prstGeom>
+          <a:noFill/>
+        </p:spPr>
+        <p:txBody>
+          <a:bodyPr wrap="square">
+            <a:spAutoFit/>
+          </a:bodyPr>
+          <a:lstStyle/>
+          <a:p>
+            <a:pPr algn="l"/>
+            <a:r>
+              <a:rPr sz="1400" b="1" i="0">
+                <a:solidFill>
+                  <a:srgbClr val="7C3AED"/>
+                </a:solidFill>
+              </a:rPr>
+              <a:t>LIMITATIONS</a:t>
+            </a:r>
+          </a:p>
+        </p:txBody>
+      </p:sp>
+      <p:sp>
+        <p:nvSpPr>
+          <p:cNvPr id="3" name="TextBox 2"/>
+          <p:cNvSpPr txBox="1"/>
+          <p:nvPr/>
+        </p:nvSpPr>
+        <p:spPr>
+          <a:xfrm>
+            <a:off x="914400" y="987552"/>
+            <a:ext cx="16285463" cy="502920"/>
+          </a:xfrm>
+          <a:prstGeom prst="rect">
+            <a:avLst/>
+          </a:prstGeom>
+          <a:noFill/>
+        </p:spPr>
+        <p:txBody>
+          <a:bodyPr wrap="square">
+            <a:spAutoFit/>
+          </a:bodyPr>
+          <a:lstStyle/>
+          <a:p>
+            <a:pPr algn="l"/>
+            <a:r>
+              <a:rPr sz="2800" b="1" i="0">
+                <a:solidFill>
+                  <a:srgbClr val="4C1D95"/>
+                </a:solidFill>
+              </a:rPr>
+              <a:t>Current scope — known constraints</a:t>
+            </a:r>
+          </a:p>
+        </p:txBody>
+      </p:sp>
+      <p:sp>
+        <p:nvSpPr>
+          <p:cNvPr id="4" name="Rectangle 3"/>
+          <p:cNvSpPr/>
+          <p:nvPr/>
+        </p:nvSpPr>
+        <p:spPr>
+          <a:xfrm>
+            <a:off x="822960" y="1856231"/>
+            <a:ext cx="16651224" cy="54864"/>
+          </a:xfrm>
+          <a:prstGeom prst="rect">
+            <a:avLst/>
+          </a:prstGeom>
+          <a:solidFill>
+            <a:srgbClr val="EF4444"/>
+          </a:solidFill>
+          <a:ln>
+            <a:noFill/>
+          </a:ln>
+        </p:spPr>
+        <p:style>
+          <a:lnRef idx="1">
+            <a:schemeClr val="accent1"/>
+          </a:lnRef>
+          <a:fillRef idx="3">
+            <a:schemeClr val="accent1"/>
+          </a:fillRef>
+          <a:effectRef idx="2">
+            <a:schemeClr val="accent1"/>
+          </a:effectRef>
+          <a:fontRef idx="minor">
+            <a:schemeClr val="lt1"/>
+          </a:fontRef>
+        </p:style>
+        <p:txBody>
+          <a:bodyPr rtlCol="0" anchor="ctr"/>
+          <a:lstStyle/>
+          <a:p>
+            <a:pPr algn="ctr"/>
+          </a:p>
+        </p:txBody>
+      </p:sp>
+      <p:sp>
+        <p:nvSpPr>
+          <p:cNvPr id="5" name="Rectangle 4"/>
+          <p:cNvSpPr/>
+          <p:nvPr/>
+        </p:nvSpPr>
+        <p:spPr>
+          <a:xfrm>
+            <a:off x="402336" y="2185416"/>
+            <a:ext cx="5303520" cy="3447288"/>
+          </a:xfrm>
+          <a:prstGeom prst="rect">
+            <a:avLst/>
+          </a:prstGeom>
+          <a:solidFill>
+            <a:srgbClr val="FFFFFF"/>
+          </a:solidFill>
+          <a:ln w="6350">
+            <a:solidFill>
+              <a:srgbClr val="E2E8F0"/>
+            </a:solidFill>
+          </a:ln>
+        </p:spPr>
+        <p:style>
+          <a:lnRef idx="1">
+            <a:schemeClr val="accent1"/>
+          </a:lnRef>
+          <a:fillRef idx="3">
+            <a:schemeClr val="accent1"/>
+          </a:fillRef>
+          <a:effectRef idx="2">
+            <a:schemeClr val="accent1"/>
+          </a:effectRef>
+          <a:fontRef idx="minor">
+            <a:schemeClr val="lt1"/>
+          </a:fontRef>
+        </p:style>
+        <p:txBody>
+          <a:bodyPr rtlCol="0" anchor="ctr"/>
+          <a:lstStyle/>
+          <a:p>
+            <a:pPr algn="ctr"/>
+          </a:p>
+        </p:txBody>
+      </p:sp>
+      <p:sp>
+        <p:nvSpPr>
+          <p:cNvPr id="6" name="Rectangle 5"/>
+          <p:cNvSpPr/>
+          <p:nvPr/>
+        </p:nvSpPr>
+        <p:spPr>
+          <a:xfrm>
+            <a:off x="402336" y="2185416"/>
+            <a:ext cx="5303520" cy="64008"/>
+          </a:xfrm>
+          <a:prstGeom prst="rect">
+            <a:avLst/>
+          </a:prstGeom>
+          <a:solidFill>
+            <a:srgbClr val="EF4444"/>
+          </a:solidFill>
+          <a:ln>
+            <a:noFill/>
+          </a:ln>
+        </p:spPr>
+        <p:style>
+          <a:lnRef idx="1">
+            <a:schemeClr val="accent1"/>
+          </a:lnRef>
+          <a:fillRef idx="3">
+            <a:schemeClr val="accent1"/>
+          </a:fillRef>
+          <a:effectRef idx="2">
+            <a:schemeClr val="accent1"/>
+          </a:effectRef>
+          <a:fontRef idx="minor">
+            <a:schemeClr val="lt1"/>
+          </a:fontRef>
+        </p:style>
+        <p:txBody>
+          <a:bodyPr rtlCol="0" anchor="ctr"/>
+          <a:lstStyle/>
+          <a:p>
+            <a:pPr algn="ctr"/>
+          </a:p>
+        </p:txBody>
+      </p:sp>
+      <p:sp>
+        <p:nvSpPr>
+          <p:cNvPr id="7" name="TextBox 6"/>
+          <p:cNvSpPr txBox="1"/>
+          <p:nvPr/>
+        </p:nvSpPr>
+        <p:spPr>
+          <a:xfrm>
+            <a:off x="704088" y="2359152"/>
+            <a:ext cx="4892040" cy="466344"/>
+          </a:xfrm>
+          <a:prstGeom prst="rect">
+            <a:avLst/>
+          </a:prstGeom>
+          <a:noFill/>
+        </p:spPr>
+        <p:txBody>
+          <a:bodyPr wrap="square">
+            <a:spAutoFit/>
+          </a:bodyPr>
+          <a:lstStyle/>
+          <a:p>
+            <a:pPr algn="l"/>
+            <a:r>
+              <a:rPr sz="1500" b="1" i="0">
+                <a:solidFill>
+                  <a:srgbClr val="4C1D95"/>
+                </a:solidFill>
+              </a:rPr>
+              <a:t>🚫  Single Document Only</a:t>
+            </a:r>
+          </a:p>
+        </p:txBody>
+      </p:sp>
+      <p:sp>
+        <p:nvSpPr>
+          <p:cNvPr id="8" name="TextBox 7"/>
+          <p:cNvSpPr txBox="1"/>
+          <p:nvPr/>
+        </p:nvSpPr>
+        <p:spPr>
+          <a:xfrm>
+            <a:off x="704088" y="2962656"/>
+            <a:ext cx="4892040" cy="2414016"/>
+          </a:xfrm>
+          <a:prstGeom prst="rect">
+            <a:avLst/>
+          </a:prstGeom>
+          <a:noFill/>
+        </p:spPr>
+        <p:txBody>
+          <a:bodyPr wrap="square">
+            <a:spAutoFit/>
+          </a:bodyPr>
+          <a:lstStyle/>
+          <a:p>
+            <a:pPr algn="l"/>
+            <a:r>
+              <a:rPr sz="1250" b="0" i="0">
+                <a:solidFill>
+                  <a:srgbClr val="7C3AED"/>
+                </a:solidFill>
+              </a:rPr>
+              <a:t>One PDF at a time. Uploading a new document wipes the previous one — no multi-doc library or cross-document queries.</a:t>
+            </a:r>
+          </a:p>
+        </p:txBody>
+      </p:sp>
+      <p:sp>
+        <p:nvSpPr>
+          <p:cNvPr id="9" name="Rectangle 8"/>
+          <p:cNvSpPr/>
+          <p:nvPr/>
+        </p:nvSpPr>
+        <p:spPr>
+          <a:xfrm>
+            <a:off x="6117336" y="2185416"/>
+            <a:ext cx="5303520" cy="3447288"/>
+          </a:xfrm>
+          <a:prstGeom prst="rect">
+            <a:avLst/>
+          </a:prstGeom>
+          <a:solidFill>
+            <a:srgbClr val="FFFFFF"/>
+          </a:solidFill>
+          <a:ln w="6350">
+            <a:solidFill>
+              <a:srgbClr val="E2E8F0"/>
+            </a:solidFill>
+          </a:ln>
+        </p:spPr>
+        <p:style>
+          <a:lnRef idx="1">
+            <a:schemeClr val="accent1"/>
+          </a:lnRef>
+          <a:fillRef idx="3">
+            <a:schemeClr val="accent1"/>
+          </a:fillRef>
+          <a:effectRef idx="2">
+            <a:schemeClr val="accent1"/>
+          </a:effectRef>
+          <a:fontRef idx="minor">
+            <a:schemeClr val="lt1"/>
+          </a:fontRef>
+        </p:style>
+        <p:txBody>
+          <a:bodyPr rtlCol="0" anchor="ctr"/>
+          <a:lstStyle/>
+          <a:p>
+            <a:pPr algn="ctr"/>
+          </a:p>
+        </p:txBody>
+      </p:sp>
+      <p:sp>
+        <p:nvSpPr>
+          <p:cNvPr id="10" name="Rectangle 9"/>
+          <p:cNvSpPr/>
+          <p:nvPr/>
+        </p:nvSpPr>
+        <p:spPr>
+          <a:xfrm>
+            <a:off x="6117336" y="2185416"/>
+            <a:ext cx="5303520" cy="64008"/>
+          </a:xfrm>
+          <a:prstGeom prst="rect">
+            <a:avLst/>
+          </a:prstGeom>
+          <a:solidFill>
+            <a:srgbClr val="EF4444"/>
+          </a:solidFill>
+          <a:ln>
+            <a:noFill/>
+          </a:ln>
+        </p:spPr>
+        <p:style>
+          <a:lnRef idx="1">
+            <a:schemeClr val="accent1"/>
+          </a:lnRef>
+          <a:fillRef idx="3">
+            <a:schemeClr val="accent1"/>
+          </a:fillRef>
+          <a:effectRef idx="2">
+            <a:schemeClr val="accent1"/>
+          </a:effectRef>
+          <a:fontRef idx="minor">
+            <a:schemeClr val="lt1"/>
+          </a:fontRef>
+        </p:style>
+        <p:txBody>
+          <a:bodyPr rtlCol="0" anchor="ctr"/>
+          <a:lstStyle/>
+          <a:p>
+            <a:pPr algn="ctr"/>
+          </a:p>
+        </p:txBody>
+      </p:sp>
+      <p:sp>
+        <p:nvSpPr>
+          <p:cNvPr id="11" name="TextBox 10"/>
+          <p:cNvSpPr txBox="1"/>
+          <p:nvPr/>
+        </p:nvSpPr>
+        <p:spPr>
+          <a:xfrm>
+            <a:off x="6419088" y="2359152"/>
+            <a:ext cx="4892040" cy="466344"/>
+          </a:xfrm>
+          <a:prstGeom prst="rect">
+            <a:avLst/>
+          </a:prstGeom>
+          <a:noFill/>
+        </p:spPr>
+        <p:txBody>
+          <a:bodyPr wrap="square">
+            <a:spAutoFit/>
+          </a:bodyPr>
+          <a:lstStyle/>
+          <a:p>
+            <a:pPr algn="l"/>
+            <a:r>
+              <a:rPr sz="1500" b="1" i="0">
+                <a:solidFill>
+                  <a:srgbClr val="4C1D95"/>
+                </a:solidFill>
+              </a:rPr>
+              <a:t>🔍  No Scanned PDF / OCR</a:t>
+            </a:r>
+          </a:p>
+        </p:txBody>
+      </p:sp>
+      <p:sp>
+        <p:nvSpPr>
+          <p:cNvPr id="12" name="TextBox 11"/>
+          <p:cNvSpPr txBox="1"/>
+          <p:nvPr/>
+        </p:nvSpPr>
+        <p:spPr>
+          <a:xfrm>
+            <a:off x="6419088" y="2962656"/>
+            <a:ext cx="4892040" cy="2414016"/>
+          </a:xfrm>
+          <a:prstGeom prst="rect">
+            <a:avLst/>
+          </a:prstGeom>
+          <a:noFill/>
+        </p:spPr>
+        <p:txBody>
+          <a:bodyPr wrap="square">
+            <a:spAutoFit/>
+          </a:bodyPr>
+          <a:lstStyle/>
+          <a:p>
+            <a:pPr algn="l"/>
+            <a:r>
+              <a:rPr sz="1250" b="0" i="0">
+                <a:solidFill>
+                  <a:srgbClr val="7C3AED"/>
+                </a:solidFill>
+              </a:rPr>
+              <a:t>PyMuPDF extracts text from digital PDFs only. Image-based or scanned pages return empty text — no Tesseract / Vision fallback.</a:t>
+            </a:r>
+          </a:p>
+        </p:txBody>
+      </p:sp>
+      <p:sp>
+        <p:nvSpPr>
+          <p:cNvPr id="13" name="Rectangle 12"/>
+          <p:cNvSpPr/>
+          <p:nvPr/>
+        </p:nvSpPr>
+        <p:spPr>
+          <a:xfrm>
+            <a:off x="11832336" y="2185416"/>
+            <a:ext cx="5303520" cy="3447288"/>
+          </a:xfrm>
+          <a:prstGeom prst="rect">
+            <a:avLst/>
+          </a:prstGeom>
+          <a:solidFill>
+            <a:srgbClr val="FFFFFF"/>
+          </a:solidFill>
+          <a:ln w="6350">
+            <a:solidFill>
+              <a:srgbClr val="E2E8F0"/>
+            </a:solidFill>
+          </a:ln>
+        </p:spPr>
+        <p:style>
+          <a:lnRef idx="1">
+            <a:schemeClr val="accent1"/>
+          </a:lnRef>
+          <a:fillRef idx="3">
+            <a:schemeClr val="accent1"/>
+          </a:fillRef>
+          <a:effectRef idx="2">
+            <a:schemeClr val="accent1"/>
+          </a:effectRef>
+          <a:fontRef idx="minor">
+            <a:schemeClr val="lt1"/>
+          </a:fontRef>
+        </p:style>
+        <p:txBody>
+          <a:bodyPr rtlCol="0" anchor="ctr"/>
+          <a:lstStyle/>
+          <a:p>
+            <a:pPr algn="ctr"/>
+          </a:p>
+        </p:txBody>
+      </p:sp>
+      <p:sp>
+        <p:nvSpPr>
+          <p:cNvPr id="14" name="Rectangle 13"/>
+          <p:cNvSpPr/>
+          <p:nvPr/>
+        </p:nvSpPr>
+        <p:spPr>
+          <a:xfrm>
+            <a:off x="11832336" y="2185416"/>
+            <a:ext cx="5303520" cy="64008"/>
+          </a:xfrm>
+          <a:prstGeom prst="rect">
+            <a:avLst/>
+          </a:prstGeom>
+          <a:solidFill>
+            <a:srgbClr val="EF4444"/>
+          </a:solidFill>
+          <a:ln>
+            <a:noFill/>
+          </a:ln>
+        </p:spPr>
+        <p:style>
+          <a:lnRef idx="1">
+            <a:schemeClr val="accent1"/>
+          </a:lnRef>
+          <a:fillRef idx="3">
+            <a:schemeClr val="accent1"/>
+          </a:fillRef>
+          <a:effectRef idx="2">
+            <a:schemeClr val="accent1"/>
+          </a:effectRef>
+          <a:fontRef idx="minor">
+            <a:schemeClr val="lt1"/>
+          </a:fontRef>
+        </p:style>
+        <p:txBody>
+          <a:bodyPr rtlCol="0" anchor="ctr"/>
+          <a:lstStyle/>
+          <a:p>
+            <a:pPr algn="ctr"/>
+          </a:p>
+        </p:txBody>
+      </p:sp>
+      <p:sp>
+        <p:nvSpPr>
+          <p:cNvPr id="15" name="TextBox 14"/>
+          <p:cNvSpPr txBox="1"/>
+          <p:nvPr/>
+        </p:nvSpPr>
+        <p:spPr>
+          <a:xfrm>
+            <a:off x="12134088" y="2359152"/>
+            <a:ext cx="4892040" cy="466344"/>
+          </a:xfrm>
+          <a:prstGeom prst="rect">
+            <a:avLst/>
+          </a:prstGeom>
+          <a:noFill/>
+        </p:spPr>
+        <p:txBody>
+          <a:bodyPr wrap="square">
+            <a:spAutoFit/>
+          </a:bodyPr>
+          <a:lstStyle/>
+          <a:p>
+            <a:pPr algn="l"/>
+            <a:r>
+              <a:rPr sz="1500" b="1" i="0">
+                <a:solidFill>
+                  <a:srgbClr val="4C1D95"/>
+                </a:solidFill>
+              </a:rPr>
+              <a:t>👤  No Auth / Multi-User</a:t>
+            </a:r>
+          </a:p>
+        </p:txBody>
+      </p:sp>
+      <p:sp>
+        <p:nvSpPr>
+          <p:cNvPr id="16" name="TextBox 15"/>
+          <p:cNvSpPr txBox="1"/>
+          <p:nvPr/>
+        </p:nvSpPr>
+        <p:spPr>
+          <a:xfrm>
+            <a:off x="12134088" y="2962656"/>
+            <a:ext cx="4892040" cy="2414016"/>
+          </a:xfrm>
+          <a:prstGeom prst="rect">
+            <a:avLst/>
+          </a:prstGeom>
+          <a:noFill/>
+        </p:spPr>
+        <p:txBody>
+          <a:bodyPr wrap="square">
+            <a:spAutoFit/>
+          </a:bodyPr>
+          <a:lstStyle/>
+          <a:p>
+            <a:pPr algn="l"/>
+            <a:r>
+              <a:rPr sz="1250" b="0" i="0">
+                <a:solidFill>
+                  <a:srgbClr val="7C3AED"/>
+                </a:solidFill>
+              </a:rPr>
+              <a:t>Single shared server state. No session isolation — concurrent users share the same document with no login or permission model.</a:t>
+            </a:r>
+          </a:p>
+        </p:txBody>
+      </p:sp>
+      <p:sp>
+        <p:nvSpPr>
+          <p:cNvPr id="17" name="Rectangle 16"/>
+          <p:cNvSpPr/>
+          <p:nvPr/>
+        </p:nvSpPr>
+        <p:spPr>
+          <a:xfrm>
+            <a:off x="402336" y="5806440"/>
+            <a:ext cx="5303520" cy="3447288"/>
+          </a:xfrm>
+          <a:prstGeom prst="rect">
+            <a:avLst/>
+          </a:prstGeom>
+          <a:solidFill>
+            <a:srgbClr val="FFFFFF"/>
+          </a:solidFill>
+          <a:ln w="6350">
+            <a:solidFill>
+              <a:srgbClr val="E2E8F0"/>
+            </a:solidFill>
+          </a:ln>
+        </p:spPr>
+        <p:style>
+          <a:lnRef idx="1">
+            <a:schemeClr val="accent1"/>
+          </a:lnRef>
+          <a:fillRef idx="3">
+            <a:schemeClr val="accent1"/>
+          </a:fillRef>
+          <a:effectRef idx="2">
+            <a:schemeClr val="accent1"/>
+          </a:effectRef>
+          <a:fontRef idx="minor">
+            <a:schemeClr val="lt1"/>
+          </a:fontRef>
+        </p:style>
+        <p:txBody>
+          <a:bodyPr rtlCol="0" anchor="ctr"/>
+          <a:lstStyle/>
+          <a:p>
+            <a:pPr algn="ctr"/>
+          </a:p>
+        </p:txBody>
+      </p:sp>
+      <p:sp>
+        <p:nvSpPr>
+          <p:cNvPr id="18" name="Rectangle 17"/>
+          <p:cNvSpPr/>
+          <p:nvPr/>
+        </p:nvSpPr>
+        <p:spPr>
+          <a:xfrm>
+            <a:off x="402336" y="5806440"/>
+            <a:ext cx="5303520" cy="64008"/>
+          </a:xfrm>
+          <a:prstGeom prst="rect">
+            <a:avLst/>
+          </a:prstGeom>
+          <a:solidFill>
+            <a:srgbClr val="F59E0B"/>
+          </a:solidFill>
+          <a:ln>
+            <a:noFill/>
+          </a:ln>
+        </p:spPr>
+        <p:style>
+          <a:lnRef idx="1">
+            <a:schemeClr val="accent1"/>
+          </a:lnRef>
+          <a:fillRef idx="3">
+            <a:schemeClr val="accent1"/>
+          </a:fillRef>
+          <a:effectRef idx="2">
+            <a:schemeClr val="accent1"/>
+          </a:effectRef>
+          <a:fontRef idx="minor">
+            <a:schemeClr val="lt1"/>
+          </a:fontRef>
+        </p:style>
+        <p:txBody>
+          <a:bodyPr rtlCol="0" anchor="ctr"/>
+          <a:lstStyle/>
+          <a:p>
+            <a:pPr algn="ctr"/>
+          </a:p>
+        </p:txBody>
+      </p:sp>
+      <p:sp>
+        <p:nvSpPr>
+          <p:cNvPr id="19" name="TextBox 18"/>
+          <p:cNvSpPr txBox="1"/>
+          <p:nvPr/>
+        </p:nvSpPr>
+        <p:spPr>
+          <a:xfrm>
+            <a:off x="704088" y="5980176"/>
+            <a:ext cx="4892040" cy="466344"/>
+          </a:xfrm>
+          <a:prstGeom prst="rect">
+            <a:avLst/>
+          </a:prstGeom>
+          <a:noFill/>
+        </p:spPr>
+        <p:txBody>
+          <a:bodyPr wrap="square">
+            <a:spAutoFit/>
+          </a:bodyPr>
+          <a:lstStyle/>
+          <a:p>
+            <a:pPr algn="l"/>
+            <a:r>
+              <a:rPr sz="1500" b="1" i="0">
+                <a:solidFill>
+                  <a:srgbClr val="4C1D95"/>
+                </a:solidFill>
+              </a:rPr>
+              <a:t>💬  No Persistent Chat History</a:t>
+            </a:r>
+          </a:p>
+        </p:txBody>
+      </p:sp>
+      <p:sp>
+        <p:nvSpPr>
+          <p:cNvPr id="20" name="TextBox 19"/>
+          <p:cNvSpPr txBox="1"/>
+          <p:nvPr/>
+        </p:nvSpPr>
+        <p:spPr>
+          <a:xfrm>
+            <a:off x="704088" y="6583679"/>
+            <a:ext cx="4892040" cy="2414016"/>
+          </a:xfrm>
+          <a:prstGeom prst="rect">
+            <a:avLst/>
+          </a:prstGeom>
+          <a:noFill/>
+        </p:spPr>
+        <p:txBody>
+          <a:bodyPr wrap="square">
+            <a:spAutoFit/>
+          </a:bodyPr>
+          <a:lstStyle/>
+          <a:p>
+            <a:pPr algn="l"/>
+            <a:r>
+              <a:rPr sz="1250" b="0" i="0">
+                <a:solidFill>
+                  <a:srgbClr val="7C3AED"/>
+                </a:solidFill>
+              </a:rPr>
+              <a:t>Conversation context resets on page reload. Follow-up questions cannot reference answers from a previous browsing session.</a:t>
+            </a:r>
+          </a:p>
+        </p:txBody>
+      </p:sp>
+      <p:sp>
+        <p:nvSpPr>
+          <p:cNvPr id="21" name="Rectangle 20"/>
+          <p:cNvSpPr/>
+          <p:nvPr/>
+        </p:nvSpPr>
+        <p:spPr>
+          <a:xfrm>
+            <a:off x="6117336" y="5806440"/>
+            <a:ext cx="5303520" cy="3447288"/>
+          </a:xfrm>
+          <a:prstGeom prst="rect">
+            <a:avLst/>
+          </a:prstGeom>
+          <a:solidFill>
+            <a:srgbClr val="FFFFFF"/>
+          </a:solidFill>
+          <a:ln w="6350">
+            <a:solidFill>
+              <a:srgbClr val="E2E8F0"/>
+            </a:solidFill>
+          </a:ln>
+        </p:spPr>
+        <p:style>
+          <a:lnRef idx="1">
+            <a:schemeClr val="accent1"/>
+          </a:lnRef>
+          <a:fillRef idx="3">
+            <a:schemeClr val="accent1"/>
+          </a:fillRef>
+          <a:effectRef idx="2">
+            <a:schemeClr val="accent1"/>
+          </a:effectRef>
+          <a:fontRef idx="minor">
+            <a:schemeClr val="lt1"/>
+          </a:fontRef>
+        </p:style>
+        <p:txBody>
+          <a:bodyPr rtlCol="0" anchor="ctr"/>
+          <a:lstStyle/>
+          <a:p>
+            <a:pPr algn="ctr"/>
+          </a:p>
+        </p:txBody>
+      </p:sp>
+      <p:sp>
+        <p:nvSpPr>
+          <p:cNvPr id="22" name="Rectangle 21"/>
+          <p:cNvSpPr/>
+          <p:nvPr/>
+        </p:nvSpPr>
+        <p:spPr>
+          <a:xfrm>
+            <a:off x="6117336" y="5806440"/>
+            <a:ext cx="5303520" cy="64008"/>
+          </a:xfrm>
+          <a:prstGeom prst="rect">
+            <a:avLst/>
+          </a:prstGeom>
+          <a:solidFill>
+            <a:srgbClr val="F59E0B"/>
+          </a:solidFill>
+          <a:ln>
+            <a:noFill/>
+          </a:ln>
+        </p:spPr>
+        <p:style>
+          <a:lnRef idx="1">
+            <a:schemeClr val="accent1"/>
+          </a:lnRef>
+          <a:fillRef idx="3">
+            <a:schemeClr val="accent1"/>
+          </a:fillRef>
+          <a:effectRef idx="2">
+            <a:schemeClr val="accent1"/>
+          </a:effectRef>
+          <a:fontRef idx="minor">
+            <a:schemeClr val="lt1"/>
+          </a:fontRef>
+        </p:style>
+        <p:txBody>
+          <a:bodyPr rtlCol="0" anchor="ctr"/>
+          <a:lstStyle/>
+          <a:p>
+            <a:pPr algn="ctr"/>
+          </a:p>
+        </p:txBody>
+      </p:sp>
+      <p:sp>
+        <p:nvSpPr>
+          <p:cNvPr id="23" name="TextBox 22"/>
+          <p:cNvSpPr txBox="1"/>
+          <p:nvPr/>
+        </p:nvSpPr>
+        <p:spPr>
+          <a:xfrm>
+            <a:off x="6419088" y="5980176"/>
+            <a:ext cx="4892040" cy="466344"/>
+          </a:xfrm>
+          <a:prstGeom prst="rect">
+            <a:avLst/>
+          </a:prstGeom>
+          <a:noFill/>
+        </p:spPr>
+        <p:txBody>
+          <a:bodyPr wrap="square">
+            <a:spAutoFit/>
+          </a:bodyPr>
+          <a:lstStyle/>
+          <a:p>
+            <a:pPr algn="l"/>
+            <a:r>
+              <a:rPr sz="1500" b="1" i="0">
+                <a:solidFill>
+                  <a:srgbClr val="4C1D95"/>
+                </a:solidFill>
+              </a:rPr>
+              <a:t>⚡  Gemini API Rate Limits</a:t>
+            </a:r>
+          </a:p>
+        </p:txBody>
+      </p:sp>
+      <p:sp>
+        <p:nvSpPr>
+          <p:cNvPr id="24" name="TextBox 23"/>
+          <p:cNvSpPr txBox="1"/>
+          <p:nvPr/>
+        </p:nvSpPr>
+        <p:spPr>
+          <a:xfrm>
+            <a:off x="6419088" y="6583679"/>
+            <a:ext cx="4892040" cy="2414016"/>
+          </a:xfrm>
+          <a:prstGeom prst="rect">
+            <a:avLst/>
+          </a:prstGeom>
+          <a:noFill/>
+        </p:spPr>
+        <p:txBody>
+          <a:bodyPr wrap="square">
+            <a:spAutoFit/>
+          </a:bodyPr>
+          <a:lstStyle/>
+          <a:p>
+            <a:pPr algn="l"/>
+            <a:r>
+              <a:rPr sz="1250" b="0" i="0">
+                <a:solidFill>
+                  <a:srgbClr val="7C3AED"/>
+                </a:solidFill>
+              </a:rPr>
+              <a:t>Concurrent embedding calls hit 429 limits on large documents. Exponential backoff adds latency for 100+ page PDFs.</a:t>
+            </a:r>
+          </a:p>
+        </p:txBody>
+      </p:sp>
+      <p:sp>
+        <p:nvSpPr>
+          <p:cNvPr id="25" name="Rectangle 24"/>
+          <p:cNvSpPr/>
+          <p:nvPr/>
+        </p:nvSpPr>
+        <p:spPr>
+          <a:xfrm>
+            <a:off x="11832336" y="5806440"/>
+            <a:ext cx="5303520" cy="3447288"/>
+          </a:xfrm>
+          <a:prstGeom prst="rect">
+            <a:avLst/>
+          </a:prstGeom>
+          <a:solidFill>
+            <a:srgbClr val="FFFFFF"/>
+          </a:solidFill>
+          <a:ln w="6350">
+            <a:solidFill>
+              <a:srgbClr val="E2E8F0"/>
+            </a:solidFill>
+          </a:ln>
+        </p:spPr>
+        <p:style>
+          <a:lnRef idx="1">
+            <a:schemeClr val="accent1"/>
+          </a:lnRef>
+          <a:fillRef idx="3">
+            <a:schemeClr val="accent1"/>
+          </a:fillRef>
+          <a:effectRef idx="2">
+            <a:schemeClr val="accent1"/>
+          </a:effectRef>
+          <a:fontRef idx="minor">
+            <a:schemeClr val="lt1"/>
+          </a:fontRef>
+        </p:style>
+        <p:txBody>
+          <a:bodyPr rtlCol="0" anchor="ctr"/>
+          <a:lstStyle/>
+          <a:p>
+            <a:pPr algn="ctr"/>
+          </a:p>
+        </p:txBody>
+      </p:sp>
+      <p:sp>
+        <p:nvSpPr>
+          <p:cNvPr id="26" name="Rectangle 25"/>
+          <p:cNvSpPr/>
+          <p:nvPr/>
+        </p:nvSpPr>
+        <p:spPr>
+          <a:xfrm>
+            <a:off x="11832336" y="5806440"/>
+            <a:ext cx="5303520" cy="64008"/>
+          </a:xfrm>
+          <a:prstGeom prst="rect">
+            <a:avLst/>
+          </a:prstGeom>
+          <a:solidFill>
+            <a:srgbClr val="F59E0B"/>
+          </a:solidFill>
+          <a:ln>
+            <a:noFill/>
+          </a:ln>
+        </p:spPr>
+        <p:style>
+          <a:lnRef idx="1">
+            <a:schemeClr val="accent1"/>
+          </a:lnRef>
+          <a:fillRef idx="3">
+            <a:schemeClr val="accent1"/>
+          </a:fillRef>
+          <a:effectRef idx="2">
+            <a:schemeClr val="accent1"/>
+          </a:effectRef>
+          <a:fontRef idx="minor">
+            <a:schemeClr val="lt1"/>
+          </a:fontRef>
+        </p:style>
+        <p:txBody>
+          <a:bodyPr rtlCol="0" anchor="ctr"/>
+          <a:lstStyle/>
+          <a:p>
+            <a:pPr algn="ctr"/>
+          </a:p>
+        </p:txBody>
+      </p:sp>
+      <p:sp>
+        <p:nvSpPr>
+          <p:cNvPr id="27" name="TextBox 26"/>
+          <p:cNvSpPr txBox="1"/>
+          <p:nvPr/>
+        </p:nvSpPr>
+        <p:spPr>
+          <a:xfrm>
+            <a:off x="12134088" y="5980176"/>
+            <a:ext cx="4892040" cy="466344"/>
+          </a:xfrm>
+          <a:prstGeom prst="rect">
+            <a:avLst/>
+          </a:prstGeom>
+          <a:noFill/>
+        </p:spPr>
+        <p:txBody>
+          <a:bodyPr wrap="square">
+            <a:spAutoFit/>
+          </a:bodyPr>
+          <a:lstStyle/>
+          <a:p>
+            <a:pPr algn="l"/>
+            <a:r>
+              <a:rPr sz="1500" b="1" i="0">
+                <a:solidFill>
+                  <a:srgbClr val="4C1D95"/>
+                </a:solidFill>
+              </a:rPr>
+              <a:t>🔤  PyMuPDF ≠ PDF.js Extraction</a:t>
+            </a:r>
+          </a:p>
+        </p:txBody>
+      </p:sp>
+      <p:sp>
+        <p:nvSpPr>
+          <p:cNvPr id="28" name="TextBox 27"/>
+          <p:cNvSpPr txBox="1"/>
+          <p:nvPr/>
+        </p:nvSpPr>
+        <p:spPr>
+          <a:xfrm>
+            <a:off x="12134088" y="6583679"/>
+            <a:ext cx="4892040" cy="2414016"/>
+          </a:xfrm>
+          <a:prstGeom prst="rect">
+            <a:avLst/>
+          </a:prstGeom>
+          <a:noFill/>
+        </p:spPr>
+        <p:txBody>
+          <a:bodyPr wrap="square">
+            <a:spAutoFit/>
+          </a:bodyPr>
+          <a:lstStyle/>
+          <a:p>
+            <a:pPr algn="l"/>
+            <a:r>
+              <a:rPr sz="1250" b="0" i="0">
+                <a:solidFill>
+                  <a:srgbClr val="7C3AED"/>
+                </a:solidFill>
+              </a:rPr>
+              <a:t>Math and symbols render differently at ingest (PyMuPDF) and in the viewer (PDF.js), requiring fuzzy word-anchor matching for highlighting.</a:t>
+            </a:r>
+          </a:p>
+        </p:txBody>
+      </p:sp>
+    </p:spTree>
+  </p:cSld>
+  <p:clrMapOvr>
+    <a:masterClrMapping/>
+  </p:clrMapOvr>
+</p:sld>
+</file>
+
+<file path=ppt/slides/slide13.xml><?xml version="1.0" encoding="utf-8"?>
+<p:sld xmlns:a="http://schemas.openxmlformats.org/drawingml/2006/main" xmlns:p="http://schemas.openxmlformats.org/presentationml/2006/main" xmlns:r="http://schemas.openxmlformats.org/officeDocument/2006/relationships">
+  <p:cSld>
+    <p:bg>
+      <p:bgPr>
+        <a:solidFill>
+          <a:srgbClr val="FFFFFF"/>
+        </a:solidFill>
+        <a:effectLst/>
+      </p:bgPr>
+    </p:bg>
+    <p:spTree>
+      <p:nvGrpSpPr>
+        <p:cNvPr id="1" name=""/>
+        <p:cNvGrpSpPr/>
+        <p:nvPr/>
+      </p:nvGrpSpPr>
+      <p:grpSpPr/>
+      <p:sp>
+        <p:nvSpPr>
+          <p:cNvPr id="2" name="TextBox 1"/>
+          <p:cNvSpPr txBox="1"/>
+          <p:nvPr/>
+        </p:nvSpPr>
+        <p:spPr>
+          <a:xfrm>
+            <a:off x="914400" y="484632"/>
+            <a:ext cx="16285463" cy="429768"/>
+          </a:xfrm>
+          <a:prstGeom prst="rect">
+            <a:avLst/>
+          </a:prstGeom>
+          <a:noFill/>
+        </p:spPr>
+        <p:txBody>
+          <a:bodyPr wrap="square">
+            <a:spAutoFit/>
+          </a:bodyPr>
+          <a:lstStyle/>
+          <a:p>
+            <a:pPr algn="l"/>
+            <a:r>
+              <a:rPr sz="1400" b="1" i="0">
+                <a:solidFill>
+                  <a:srgbClr val="7C3AED"/>
+                </a:solidFill>
+              </a:rPr>
+              <a:t>SYSTEM DESIGN</a:t>
+            </a:r>
+          </a:p>
+        </p:txBody>
+      </p:sp>
+      <p:sp>
+        <p:nvSpPr>
+          <p:cNvPr id="3" name="TextBox 2"/>
+          <p:cNvSpPr txBox="1"/>
+          <p:nvPr/>
+        </p:nvSpPr>
+        <p:spPr>
+          <a:xfrm>
+            <a:off x="914400" y="987552"/>
+            <a:ext cx="16285463" cy="502920"/>
+          </a:xfrm>
+          <a:prstGeom prst="rect">
+            <a:avLst/>
+          </a:prstGeom>
+          <a:noFill/>
+        </p:spPr>
+        <p:txBody>
+          <a:bodyPr wrap="square">
+            <a:spAutoFit/>
+          </a:bodyPr>
+          <a:lstStyle/>
+          <a:p>
+            <a:pPr algn="l"/>
+            <a:r>
+              <a:rPr sz="2800" b="1" i="0">
+                <a:solidFill>
+                  <a:srgbClr val="4C1D95"/>
+                </a:solidFill>
+              </a:rPr>
+              <a:t>Component architecture &amp; data flow</a:t>
+            </a:r>
+          </a:p>
+        </p:txBody>
+      </p:sp>
+      <p:sp>
+        <p:nvSpPr>
+          <p:cNvPr id="4" name="Rectangle 3"/>
+          <p:cNvSpPr/>
+          <p:nvPr/>
+        </p:nvSpPr>
+        <p:spPr>
+          <a:xfrm>
+            <a:off x="822960" y="1856231"/>
+            <a:ext cx="16651224" cy="54864"/>
+          </a:xfrm>
+          <a:prstGeom prst="rect">
+            <a:avLst/>
+          </a:prstGeom>
+          <a:solidFill>
+            <a:srgbClr val="7C3AED"/>
+          </a:solidFill>
+          <a:ln>
+            <a:noFill/>
+          </a:ln>
+        </p:spPr>
+        <p:style>
+          <a:lnRef idx="1">
+            <a:schemeClr val="accent1"/>
+          </a:lnRef>
+          <a:fillRef idx="3">
+            <a:schemeClr val="accent1"/>
+          </a:fillRef>
+          <a:effectRef idx="2">
+            <a:schemeClr val="accent1"/>
+          </a:effectRef>
+          <a:fontRef idx="minor">
+            <a:schemeClr val="lt1"/>
+          </a:fontRef>
+        </p:style>
+        <p:txBody>
+          <a:bodyPr rtlCol="0" anchor="ctr"/>
+          <a:lstStyle/>
+          <a:p>
+            <a:pPr algn="ctr"/>
+          </a:p>
+        </p:txBody>
+      </p:sp>
+      <p:sp>
+        <p:nvSpPr>
+          <p:cNvPr id="5" name="Rectangle 4"/>
+          <p:cNvSpPr/>
+          <p:nvPr/>
+        </p:nvSpPr>
+        <p:spPr>
+          <a:xfrm>
+            <a:off x="320040" y="3291840"/>
+            <a:ext cx="3474720" cy="3474720"/>
+          </a:xfrm>
+          <a:prstGeom prst="rect">
+            <a:avLst/>
+          </a:prstGeom>
+          <a:solidFill>
+            <a:srgbClr val="FFFFFF"/>
+          </a:solidFill>
+          <a:ln w="19050">
+            <a:solidFill>
+              <a:srgbClr val="7C3AED"/>
+            </a:solidFill>
+          </a:ln>
+        </p:spPr>
+        <p:style>
+          <a:lnRef idx="1">
+            <a:schemeClr val="accent1"/>
+          </a:lnRef>
+          <a:fillRef idx="3">
+            <a:schemeClr val="accent1"/>
+          </a:fillRef>
+          <a:effectRef idx="2">
+            <a:schemeClr val="accent1"/>
+          </a:effectRef>
+          <a:fontRef idx="minor">
+            <a:schemeClr val="lt1"/>
+          </a:fontRef>
+        </p:style>
+        <p:txBody>
+          <a:bodyPr rtlCol="0" anchor="ctr"/>
+          <a:lstStyle/>
+          <a:p>
+            <a:pPr algn="ctr"/>
+          </a:p>
+        </p:txBody>
+      </p:sp>
+      <p:sp>
+        <p:nvSpPr>
+          <p:cNvPr id="6" name="Rectangle 5"/>
+          <p:cNvSpPr/>
+          <p:nvPr/>
+        </p:nvSpPr>
+        <p:spPr>
+          <a:xfrm>
+            <a:off x="320040" y="3291840"/>
+            <a:ext cx="3474720" cy="54864"/>
+          </a:xfrm>
+          <a:prstGeom prst="rect">
+            <a:avLst/>
+          </a:prstGeom>
+          <a:solidFill>
+            <a:srgbClr val="7C3AED"/>
+          </a:solidFill>
+          <a:ln>
+            <a:noFill/>
+          </a:ln>
+        </p:spPr>
+        <p:style>
+          <a:lnRef idx="1">
+            <a:schemeClr val="accent1"/>
+          </a:lnRef>
+          <a:fillRef idx="3">
+            <a:schemeClr val="accent1"/>
+          </a:fillRef>
+          <a:effectRef idx="2">
+            <a:schemeClr val="accent1"/>
+          </a:effectRef>
+          <a:fontRef idx="minor">
+            <a:schemeClr val="lt1"/>
+          </a:fontRef>
+        </p:style>
+        <p:txBody>
+          <a:bodyPr rtlCol="0" anchor="ctr"/>
+          <a:lstStyle/>
+          <a:p>
+            <a:pPr algn="ctr"/>
+          </a:p>
+        </p:txBody>
+      </p:sp>
+      <p:sp>
+        <p:nvSpPr>
+          <p:cNvPr id="7" name="TextBox 6"/>
+          <p:cNvSpPr txBox="1"/>
+          <p:nvPr/>
+        </p:nvSpPr>
+        <p:spPr>
+          <a:xfrm>
+            <a:off x="548640" y="3456432"/>
+            <a:ext cx="3108960" cy="502920"/>
+          </a:xfrm>
+          <a:prstGeom prst="rect">
+            <a:avLst/>
+          </a:prstGeom>
+          <a:noFill/>
+        </p:spPr>
+        <p:txBody>
+          <a:bodyPr wrap="square">
+            <a:spAutoFit/>
+          </a:bodyPr>
+          <a:lstStyle/>
+          <a:p>
+            <a:pPr algn="l"/>
+            <a:r>
+              <a:rPr sz="2200" b="0" i="0">
+                <a:solidFill>
+                  <a:srgbClr val="4C1D95"/>
+                </a:solidFill>
+              </a:rPr>
+              <a:t>🌐</a:t>
+            </a:r>
+          </a:p>
+        </p:txBody>
+      </p:sp>
+      <p:sp>
+        <p:nvSpPr>
+          <p:cNvPr id="8" name="TextBox 7"/>
+          <p:cNvSpPr txBox="1"/>
+          <p:nvPr/>
+        </p:nvSpPr>
+        <p:spPr>
+          <a:xfrm>
+            <a:off x="548640" y="3977639"/>
+            <a:ext cx="3108960" cy="457200"/>
+          </a:xfrm>
+          <a:prstGeom prst="rect">
+            <a:avLst/>
+          </a:prstGeom>
+          <a:noFill/>
+        </p:spPr>
+        <p:txBody>
+          <a:bodyPr wrap="square">
+            <a:spAutoFit/>
+          </a:bodyPr>
+          <a:lstStyle/>
+          <a:p>
+            <a:pPr algn="l"/>
+            <a:r>
+              <a:rPr sz="1600" b="1" i="0">
+                <a:solidFill>
+                  <a:srgbClr val="4C1D95"/>
+                </a:solidFill>
+              </a:rPr>
+              <a:t>Browser</a:t>
+            </a:r>
+          </a:p>
+        </p:txBody>
+      </p:sp>
+      <p:sp>
+        <p:nvSpPr>
+          <p:cNvPr id="9" name="TextBox 8"/>
+          <p:cNvSpPr txBox="1"/>
+          <p:nvPr/>
+        </p:nvSpPr>
+        <p:spPr>
+          <a:xfrm>
+            <a:off x="548640" y="4480560"/>
+            <a:ext cx="3108960" cy="2103120"/>
+          </a:xfrm>
+          <a:prstGeom prst="rect">
+            <a:avLst/>
+          </a:prstGeom>
+          <a:noFill/>
+        </p:spPr>
+        <p:txBody>
+          <a:bodyPr wrap="square">
+            <a:spAutoFit/>
+          </a:bodyPr>
+          <a:lstStyle/>
+          <a:p>
+            <a:pPr algn="l"/>
+            <a:r>
+              <a:rPr sz="1150" b="0" i="0">
+                <a:solidFill>
+                  <a:srgbClr val="7C3AED"/>
+                </a:solidFill>
+              </a:rPr>
+              <a:t>index.html
+PDF.js viewer
+SSE streaming
+citation pills</a:t>
+            </a:r>
+          </a:p>
+        </p:txBody>
+      </p:sp>
+      <p:sp>
+        <p:nvSpPr>
+          <p:cNvPr id="10" name="Rectangle 9"/>
+          <p:cNvSpPr/>
+          <p:nvPr/>
+        </p:nvSpPr>
+        <p:spPr>
+          <a:xfrm>
+            <a:off x="7406640" y="2194560"/>
+            <a:ext cx="3474720" cy="5120640"/>
+          </a:xfrm>
+          <a:prstGeom prst="rect">
+            <a:avLst/>
+          </a:prstGeom>
+          <a:solidFill>
+            <a:srgbClr val="FFFFFF"/>
+          </a:solidFill>
+          <a:ln w="19050">
+            <a:solidFill>
+              <a:srgbClr val="059669"/>
+            </a:solidFill>
+          </a:ln>
+        </p:spPr>
+        <p:style>
+          <a:lnRef idx="1">
+            <a:schemeClr val="accent1"/>
+          </a:lnRef>
+          <a:fillRef idx="3">
+            <a:schemeClr val="accent1"/>
+          </a:fillRef>
+          <a:effectRef idx="2">
+            <a:schemeClr val="accent1"/>
+          </a:effectRef>
+          <a:fontRef idx="minor">
+            <a:schemeClr val="lt1"/>
+          </a:fontRef>
+        </p:style>
+        <p:txBody>
+          <a:bodyPr rtlCol="0" anchor="ctr"/>
+          <a:lstStyle/>
+          <a:p>
+            <a:pPr algn="ctr"/>
+          </a:p>
+        </p:txBody>
+      </p:sp>
+      <p:sp>
+        <p:nvSpPr>
+          <p:cNvPr id="11" name="Rectangle 10"/>
+          <p:cNvSpPr/>
+          <p:nvPr/>
+        </p:nvSpPr>
+        <p:spPr>
+          <a:xfrm>
+            <a:off x="7406640" y="2194560"/>
+            <a:ext cx="3474720" cy="54864"/>
+          </a:xfrm>
+          <a:prstGeom prst="rect">
+            <a:avLst/>
+          </a:prstGeom>
+          <a:solidFill>
+            <a:srgbClr val="059669"/>
+          </a:solidFill>
+          <a:ln>
+            <a:noFill/>
+          </a:ln>
+        </p:spPr>
+        <p:style>
+          <a:lnRef idx="1">
+            <a:schemeClr val="accent1"/>
+          </a:lnRef>
+          <a:fillRef idx="3">
+            <a:schemeClr val="accent1"/>
+          </a:fillRef>
+          <a:effectRef idx="2">
+            <a:schemeClr val="accent1"/>
+          </a:effectRef>
+          <a:fontRef idx="minor">
+            <a:schemeClr val="lt1"/>
+          </a:fontRef>
+        </p:style>
+        <p:txBody>
+          <a:bodyPr rtlCol="0" anchor="ctr"/>
+          <a:lstStyle/>
+          <a:p>
+            <a:pPr algn="ctr"/>
+          </a:p>
+        </p:txBody>
+      </p:sp>
+      <p:sp>
+        <p:nvSpPr>
+          <p:cNvPr id="12" name="TextBox 11"/>
+          <p:cNvSpPr txBox="1"/>
+          <p:nvPr/>
+        </p:nvSpPr>
+        <p:spPr>
+          <a:xfrm>
+            <a:off x="7635240" y="2359152"/>
+            <a:ext cx="3108960" cy="502920"/>
+          </a:xfrm>
+          <a:prstGeom prst="rect">
+            <a:avLst/>
+          </a:prstGeom>
+          <a:noFill/>
+        </p:spPr>
+        <p:txBody>
+          <a:bodyPr wrap="square">
+            <a:spAutoFit/>
+          </a:bodyPr>
+          <a:lstStyle/>
+          <a:p>
+            <a:pPr algn="l"/>
+            <a:r>
+              <a:rPr sz="2200" b="0" i="0">
+                <a:solidFill>
+                  <a:srgbClr val="4C1D95"/>
+                </a:solidFill>
+              </a:rPr>
+              <a:t>⚙️</a:t>
+            </a:r>
+          </a:p>
+        </p:txBody>
+      </p:sp>
+      <p:sp>
+        <p:nvSpPr>
+          <p:cNvPr id="13" name="TextBox 12"/>
+          <p:cNvSpPr txBox="1"/>
+          <p:nvPr/>
+        </p:nvSpPr>
+        <p:spPr>
+          <a:xfrm>
+            <a:off x="7635240" y="2880360"/>
+            <a:ext cx="3108960" cy="457200"/>
+          </a:xfrm>
+          <a:prstGeom prst="rect">
+            <a:avLst/>
+          </a:prstGeom>
+          <a:noFill/>
+        </p:spPr>
+        <p:txBody>
+          <a:bodyPr wrap="square">
+            <a:spAutoFit/>
+          </a:bodyPr>
+          <a:lstStyle/>
+          <a:p>
+            <a:pPr algn="l"/>
+            <a:r>
+              <a:rPr sz="1600" b="1" i="0">
+                <a:solidFill>
+                  <a:srgbClr val="4C1D95"/>
+                </a:solidFill>
+              </a:rPr>
+              <a:t>FastAPI</a:t>
+            </a:r>
+          </a:p>
+        </p:txBody>
+      </p:sp>
+      <p:sp>
+        <p:nvSpPr>
+          <p:cNvPr id="14" name="TextBox 13"/>
+          <p:cNvSpPr txBox="1"/>
+          <p:nvPr/>
+        </p:nvSpPr>
+        <p:spPr>
+          <a:xfrm>
+            <a:off x="7635240" y="3383280"/>
+            <a:ext cx="3108960" cy="3749039"/>
+          </a:xfrm>
+          <a:prstGeom prst="rect">
+            <a:avLst/>
+          </a:prstGeom>
+          <a:noFill/>
+        </p:spPr>
+        <p:txBody>
+          <a:bodyPr wrap="square">
+            <a:spAutoFit/>
+          </a:bodyPr>
+          <a:lstStyle/>
+          <a:p>
+            <a:pPr algn="l"/>
+            <a:r>
+              <a:rPr sz="1150" b="0" i="0">
+                <a:solidFill>
+                  <a:srgbClr val="7C3AED"/>
+                </a:solidFill>
+              </a:rPr>
+              <a:t>POST /ingest
+POST /query
+DELETE /doc
+GET /doc/info
+GET /health
+asyncpg · uvicorn</a:t>
+            </a:r>
+          </a:p>
+        </p:txBody>
+      </p:sp>
+      <p:sp>
+        <p:nvSpPr>
+          <p:cNvPr id="15" name="Rectangle 14"/>
+          <p:cNvSpPr/>
+          <p:nvPr/>
+        </p:nvSpPr>
+        <p:spPr>
+          <a:xfrm>
+            <a:off x="14493240" y="3291840"/>
+            <a:ext cx="3474720" cy="3474720"/>
+          </a:xfrm>
+          <a:prstGeom prst="rect">
+            <a:avLst/>
+          </a:prstGeom>
+          <a:solidFill>
+            <a:srgbClr val="FFFFFF"/>
+          </a:solidFill>
+          <a:ln w="19050">
+            <a:solidFill>
+              <a:srgbClr val="4285F4"/>
+            </a:solidFill>
+          </a:ln>
+        </p:spPr>
+        <p:style>
+          <a:lnRef idx="1">
+            <a:schemeClr val="accent1"/>
+          </a:lnRef>
+          <a:fillRef idx="3">
+            <a:schemeClr val="accent1"/>
+          </a:fillRef>
+          <a:effectRef idx="2">
+            <a:schemeClr val="accent1"/>
+          </a:effectRef>
+          <a:fontRef idx="minor">
+            <a:schemeClr val="lt1"/>
+          </a:fontRef>
+        </p:style>
+        <p:txBody>
+          <a:bodyPr rtlCol="0" anchor="ctr"/>
+          <a:lstStyle/>
+          <a:p>
+            <a:pPr algn="ctr"/>
+          </a:p>
+        </p:txBody>
+      </p:sp>
+      <p:sp>
+        <p:nvSpPr>
+          <p:cNvPr id="16" name="Rectangle 15"/>
+          <p:cNvSpPr/>
+          <p:nvPr/>
+        </p:nvSpPr>
+        <p:spPr>
+          <a:xfrm>
+            <a:off x="14493240" y="3291840"/>
+            <a:ext cx="3474720" cy="54864"/>
+          </a:xfrm>
+          <a:prstGeom prst="rect">
+            <a:avLst/>
+          </a:prstGeom>
+          <a:solidFill>
+            <a:srgbClr val="4285F4"/>
+          </a:solidFill>
+          <a:ln>
+            <a:noFill/>
+          </a:ln>
+        </p:spPr>
+        <p:style>
+          <a:lnRef idx="1">
+            <a:schemeClr val="accent1"/>
+          </a:lnRef>
+          <a:fillRef idx="3">
+            <a:schemeClr val="accent1"/>
+          </a:fillRef>
+          <a:effectRef idx="2">
+            <a:schemeClr val="accent1"/>
+          </a:effectRef>
+          <a:fontRef idx="minor">
+            <a:schemeClr val="lt1"/>
+          </a:fontRef>
+        </p:style>
+        <p:txBody>
+          <a:bodyPr rtlCol="0" anchor="ctr"/>
+          <a:lstStyle/>
+          <a:p>
+            <a:pPr algn="ctr"/>
+          </a:p>
+        </p:txBody>
+      </p:sp>
+      <p:sp>
+        <p:nvSpPr>
+          <p:cNvPr id="17" name="TextBox 16"/>
+          <p:cNvSpPr txBox="1"/>
+          <p:nvPr/>
+        </p:nvSpPr>
+        <p:spPr>
+          <a:xfrm>
+            <a:off x="14721840" y="3456432"/>
+            <a:ext cx="3108960" cy="502920"/>
+          </a:xfrm>
+          <a:prstGeom prst="rect">
+            <a:avLst/>
+          </a:prstGeom>
+          <a:noFill/>
+        </p:spPr>
+        <p:txBody>
+          <a:bodyPr wrap="square">
+            <a:spAutoFit/>
+          </a:bodyPr>
+          <a:lstStyle/>
+          <a:p>
+            <a:pPr algn="l"/>
+            <a:r>
+              <a:rPr sz="2200" b="0" i="0">
+                <a:solidFill>
+                  <a:srgbClr val="4C1D95"/>
+                </a:solidFill>
+              </a:rPr>
+              <a:t>🧠</a:t>
+            </a:r>
+          </a:p>
+        </p:txBody>
+      </p:sp>
+      <p:sp>
+        <p:nvSpPr>
+          <p:cNvPr id="18" name="TextBox 17"/>
+          <p:cNvSpPr txBox="1"/>
+          <p:nvPr/>
+        </p:nvSpPr>
+        <p:spPr>
+          <a:xfrm>
+            <a:off x="14721840" y="3977639"/>
+            <a:ext cx="3108960" cy="457200"/>
+          </a:xfrm>
+          <a:prstGeom prst="rect">
+            <a:avLst/>
+          </a:prstGeom>
+          <a:noFill/>
+        </p:spPr>
+        <p:txBody>
+          <a:bodyPr wrap="square">
+            <a:spAutoFit/>
+          </a:bodyPr>
+          <a:lstStyle/>
+          <a:p>
+            <a:pPr algn="l"/>
+            <a:r>
+              <a:rPr sz="1600" b="1" i="0">
+                <a:solidFill>
+                  <a:srgbClr val="4C1D95"/>
+                </a:solidFill>
+              </a:rPr>
+              <a:t>Gemini API</a:t>
+            </a:r>
+          </a:p>
+        </p:txBody>
+      </p:sp>
+      <p:sp>
+        <p:nvSpPr>
+          <p:cNvPr id="19" name="TextBox 18"/>
+          <p:cNvSpPr txBox="1"/>
+          <p:nvPr/>
+        </p:nvSpPr>
+        <p:spPr>
+          <a:xfrm>
+            <a:off x="14721840" y="4480560"/>
+            <a:ext cx="3108960" cy="2103120"/>
+          </a:xfrm>
+          <a:prstGeom prst="rect">
+            <a:avLst/>
+          </a:prstGeom>
+          <a:noFill/>
+        </p:spPr>
+        <p:txBody>
+          <a:bodyPr wrap="square">
+            <a:spAutoFit/>
+          </a:bodyPr>
+          <a:lstStyle/>
+          <a:p>
+            <a:pPr algn="l"/>
+            <a:r>
+              <a:rPr sz="1150" b="0" i="0">
+                <a:solidFill>
+                  <a:srgbClr val="7C3AED"/>
+                </a:solidFill>
+              </a:rPr>
+              <a:t/>
+            </a:r>
+          </a:p>
+        </p:txBody>
+      </p:sp>
+      <p:sp>
+        <p:nvSpPr>
+          <p:cNvPr id="20" name="Rectangle 19"/>
+          <p:cNvSpPr/>
+          <p:nvPr/>
+        </p:nvSpPr>
+        <p:spPr>
+          <a:xfrm>
+            <a:off x="7406640" y="7863840"/>
+            <a:ext cx="3474720" cy="2103120"/>
+          </a:xfrm>
+          <a:prstGeom prst="rect">
+            <a:avLst/>
+          </a:prstGeom>
+          <a:solidFill>
+            <a:srgbClr val="FFFFFF"/>
+          </a:solidFill>
+          <a:ln w="19050">
+            <a:solidFill>
+              <a:srgbClr val="336791"/>
+            </a:solidFill>
+          </a:ln>
+        </p:spPr>
+        <p:style>
+          <a:lnRef idx="1">
+            <a:schemeClr val="accent1"/>
+          </a:lnRef>
+          <a:fillRef idx="3">
+            <a:schemeClr val="accent1"/>
+          </a:fillRef>
+          <a:effectRef idx="2">
+            <a:schemeClr val="accent1"/>
+          </a:effectRef>
+          <a:fontRef idx="minor">
+            <a:schemeClr val="lt1"/>
+          </a:fontRef>
+        </p:style>
+        <p:txBody>
+          <a:bodyPr rtlCol="0" anchor="ctr"/>
+          <a:lstStyle/>
+          <a:p>
+            <a:pPr algn="ctr"/>
+          </a:p>
+        </p:txBody>
+      </p:sp>
+      <p:sp>
+        <p:nvSpPr>
+          <p:cNvPr id="21" name="Rectangle 20"/>
+          <p:cNvSpPr/>
+          <p:nvPr/>
+        </p:nvSpPr>
+        <p:spPr>
+          <a:xfrm>
+            <a:off x="7406640" y="7863840"/>
+            <a:ext cx="3474720" cy="54864"/>
+          </a:xfrm>
+          <a:prstGeom prst="rect">
+            <a:avLst/>
+          </a:prstGeom>
+          <a:solidFill>
+            <a:srgbClr val="336791"/>
+          </a:solidFill>
+          <a:ln>
+            <a:noFill/>
+          </a:ln>
+        </p:spPr>
+        <p:style>
+          <a:lnRef idx="1">
+            <a:schemeClr val="accent1"/>
+          </a:lnRef>
+          <a:fillRef idx="3">
+            <a:schemeClr val="accent1"/>
+          </a:fillRef>
+          <a:effectRef idx="2">
+            <a:schemeClr val="accent1"/>
+          </a:effectRef>
+          <a:fontRef idx="minor">
+            <a:schemeClr val="lt1"/>
+          </a:fontRef>
+        </p:style>
+        <p:txBody>
+          <a:bodyPr rtlCol="0" anchor="ctr"/>
+          <a:lstStyle/>
+          <a:p>
+            <a:pPr algn="ctr"/>
+          </a:p>
+        </p:txBody>
+      </p:sp>
+      <p:sp>
+        <p:nvSpPr>
+          <p:cNvPr id="22" name="TextBox 21"/>
+          <p:cNvSpPr txBox="1"/>
+          <p:nvPr/>
+        </p:nvSpPr>
+        <p:spPr>
+          <a:xfrm>
+            <a:off x="7635240" y="8028431"/>
+            <a:ext cx="3108960" cy="502920"/>
+          </a:xfrm>
+          <a:prstGeom prst="rect">
+            <a:avLst/>
+          </a:prstGeom>
+          <a:noFill/>
+        </p:spPr>
+        <p:txBody>
+          <a:bodyPr wrap="square">
+            <a:spAutoFit/>
+          </a:bodyPr>
+          <a:lstStyle/>
+          <a:p>
+            <a:pPr algn="l"/>
+            <a:r>
+              <a:rPr sz="2200" b="0" i="0">
+                <a:solidFill>
+                  <a:srgbClr val="4C1D95"/>
+                </a:solidFill>
+              </a:rPr>
+              <a:t>🗄️</a:t>
+            </a:r>
+          </a:p>
+        </p:txBody>
+      </p:sp>
+      <p:sp>
+        <p:nvSpPr>
+          <p:cNvPr id="23" name="TextBox 22"/>
+          <p:cNvSpPr txBox="1"/>
+          <p:nvPr/>
+        </p:nvSpPr>
+        <p:spPr>
+          <a:xfrm>
+            <a:off x="7635240" y="8549640"/>
+            <a:ext cx="3108960" cy="457200"/>
+          </a:xfrm>
+          <a:prstGeom prst="rect">
+            <a:avLst/>
+          </a:prstGeom>
+          <a:noFill/>
+        </p:spPr>
+        <p:txBody>
+          <a:bodyPr wrap="square">
+            <a:spAutoFit/>
+          </a:bodyPr>
+          <a:lstStyle/>
+          <a:p>
+            <a:pPr algn="l"/>
+            <a:r>
+              <a:rPr sz="1600" b="1" i="0">
+                <a:solidFill>
+                  <a:srgbClr val="4C1D95"/>
+                </a:solidFill>
+              </a:rPr>
+              <a:t>PostgreSQL + pgvector</a:t>
+            </a:r>
+          </a:p>
+        </p:txBody>
+      </p:sp>
+      <p:sp>
+        <p:nvSpPr>
+          <p:cNvPr id="24" name="TextBox 23"/>
+          <p:cNvSpPr txBox="1"/>
+          <p:nvPr/>
+        </p:nvSpPr>
+        <p:spPr>
+          <a:xfrm>
+            <a:off x="7635240" y="9052560"/>
+            <a:ext cx="3108960" cy="731519"/>
+          </a:xfrm>
+          <a:prstGeom prst="rect">
+            <a:avLst/>
+          </a:prstGeom>
+          <a:noFill/>
+        </p:spPr>
+        <p:txBody>
+          <a:bodyPr wrap="square">
+            <a:spAutoFit/>
+          </a:bodyPr>
+          <a:lstStyle/>
+          <a:p>
+            <a:pPr algn="l"/>
+            <a:r>
+              <a:rPr sz="1150" b="0" i="0">
+                <a:solidFill>
+                  <a:srgbClr val="7C3AED"/>
+                </a:solidFill>
+              </a:rPr>
+              <a:t>chunks · doc_meta
+HNSW cosine · tsvector BM25
+RRF fusion</a:t>
+            </a:r>
+          </a:p>
+        </p:txBody>
+      </p:sp>
+      <p:cxnSp>
+        <p:nvCxnSpPr>
+          <p:cNvPr id="25" name="Connector 24"/>
+          <p:cNvCxnSpPr/>
+          <p:nvPr/>
+        </p:nvCxnSpPr>
+        <p:spPr>
+          <a:xfrm>
+            <a:off x="3794759" y="4297680"/>
+            <a:ext cx="3611881" cy="0"/>
+          </a:xfrm>
+          <a:prstGeom prst="line">
+            <a:avLst/>
+          </a:prstGeom>
+          <a:ln w="25400">
+            <a:solidFill>
+              <a:srgbClr val="7C3AED"/>
+            </a:solidFill>
+            <a:tailEnd type="arrow" w="med" len="med"/>
+          </a:ln>
+        </p:spPr>
+        <p:style>
+          <a:lnRef idx="2">
+            <a:schemeClr val="accent1"/>
+          </a:lnRef>
+          <a:fillRef idx="0">
+            <a:schemeClr val="accent1"/>
+          </a:fillRef>
+          <a:effectRef idx="1">
+            <a:schemeClr val="accent1"/>
+          </a:effectRef>
+          <a:fontRef idx="minor">
+            <a:schemeClr val="tx1"/>
+          </a:fontRef>
+        </p:style>
+      </p:cxnSp>
+      <p:sp>
+        <p:nvSpPr>
+          <p:cNvPr id="26" name="TextBox 25"/>
+          <p:cNvSpPr txBox="1"/>
+          <p:nvPr/>
+        </p:nvSpPr>
+        <p:spPr>
+          <a:xfrm>
+            <a:off x="3840479" y="3977640"/>
+            <a:ext cx="3520440" cy="292608"/>
+          </a:xfrm>
+          <a:prstGeom prst="rect">
+            <a:avLst/>
+          </a:prstGeom>
+          <a:noFill/>
+        </p:spPr>
+        <p:txBody>
+          <a:bodyPr wrap="square">
+            <a:spAutoFit/>
+          </a:bodyPr>
+          <a:lstStyle/>
+          <a:p>
+            <a:pPr algn="ctr"/>
+            <a:r>
+              <a:rPr sz="1000" b="0" i="1">
+                <a:solidFill>
+                  <a:srgbClr val="64748B"/>
+                </a:solidFill>
+              </a:rPr>
+              <a:t>upload PDF / query</a:t>
+            </a:r>
+          </a:p>
+        </p:txBody>
+      </p:sp>
+      <p:cxnSp>
+        <p:nvCxnSpPr>
+          <p:cNvPr id="27" name="Connector 26"/>
+          <p:cNvCxnSpPr/>
+          <p:nvPr/>
+        </p:nvCxnSpPr>
+        <p:spPr>
+          <a:xfrm flipH="1">
+            <a:off x="3794759" y="5486400"/>
+            <a:ext cx="3611881" cy="0"/>
+          </a:xfrm>
+          <a:prstGeom prst="line">
+            <a:avLst/>
+          </a:prstGeom>
+          <a:ln w="25400">
+            <a:solidFill>
+              <a:srgbClr val="059669"/>
+            </a:solidFill>
+            <a:tailEnd type="arrow" w="med" len="med"/>
+          </a:ln>
+        </p:spPr>
+        <p:style>
+          <a:lnRef idx="2">
+            <a:schemeClr val="accent1"/>
+          </a:lnRef>
+          <a:fillRef idx="0">
+            <a:schemeClr val="accent1"/>
+          </a:fillRef>
+          <a:effectRef idx="1">
+            <a:schemeClr val="accent1"/>
+          </a:effectRef>
+          <a:fontRef idx="minor">
+            <a:schemeClr val="tx1"/>
+          </a:fontRef>
+        </p:style>
+      </p:cxnSp>
+      <p:sp>
+        <p:nvSpPr>
+          <p:cNvPr id="28" name="TextBox 27"/>
+          <p:cNvSpPr txBox="1"/>
+          <p:nvPr/>
+        </p:nvSpPr>
+        <p:spPr>
+          <a:xfrm>
+            <a:off x="3840479" y="5559552"/>
+            <a:ext cx="3520440" cy="292608"/>
+          </a:xfrm>
+          <a:prstGeom prst="rect">
+            <a:avLst/>
+          </a:prstGeom>
+          <a:noFill/>
+        </p:spPr>
+        <p:txBody>
+          <a:bodyPr wrap="square">
+            <a:spAutoFit/>
+          </a:bodyPr>
+          <a:lstStyle/>
+          <a:p>
+            <a:pPr algn="ctr"/>
+            <a:r>
+              <a:rPr sz="1000" b="0" i="1">
+                <a:solidFill>
+                  <a:srgbClr val="64748B"/>
+                </a:solidFill>
+              </a:rPr>
+              <a:t>SSE stream</a:t>
+            </a:r>
+          </a:p>
+        </p:txBody>
+      </p:sp>
+      <p:cxnSp>
+        <p:nvCxnSpPr>
+          <p:cNvPr id="29" name="Connector 28"/>
+          <p:cNvCxnSpPr/>
+          <p:nvPr/>
+        </p:nvCxnSpPr>
+        <p:spPr>
+          <a:xfrm>
+            <a:off x="10881359" y="4297680"/>
+            <a:ext cx="3611881" cy="0"/>
+          </a:xfrm>
+          <a:prstGeom prst="line">
+            <a:avLst/>
+          </a:prstGeom>
+          <a:ln w="25400">
+            <a:solidFill>
+              <a:srgbClr val="4285F4"/>
+            </a:solidFill>
+            <a:tailEnd type="arrow" w="med" len="med"/>
+          </a:ln>
+        </p:spPr>
+        <p:style>
+          <a:lnRef idx="2">
+            <a:schemeClr val="accent1"/>
+          </a:lnRef>
+          <a:fillRef idx="0">
+            <a:schemeClr val="accent1"/>
+          </a:fillRef>
+          <a:effectRef idx="1">
+            <a:schemeClr val="accent1"/>
+          </a:effectRef>
+          <a:fontRef idx="minor">
+            <a:schemeClr val="tx1"/>
+          </a:fontRef>
+        </p:style>
+      </p:cxnSp>
+      <p:sp>
+        <p:nvSpPr>
+          <p:cNvPr id="30" name="TextBox 29"/>
+          <p:cNvSpPr txBox="1"/>
+          <p:nvPr/>
+        </p:nvSpPr>
+        <p:spPr>
+          <a:xfrm>
+            <a:off x="10927080" y="3977640"/>
+            <a:ext cx="3520440" cy="292608"/>
+          </a:xfrm>
+          <a:prstGeom prst="rect">
+            <a:avLst/>
+          </a:prstGeom>
+          <a:noFill/>
+        </p:spPr>
+        <p:txBody>
+          <a:bodyPr wrap="square">
+            <a:spAutoFit/>
+          </a:bodyPr>
+          <a:lstStyle/>
+          <a:p>
+            <a:pPr algn="ctr"/>
+            <a:r>
+              <a:rPr sz="1000" b="0" i="1">
+                <a:solidFill>
+                  <a:srgbClr val="64748B"/>
+                </a:solidFill>
+              </a:rPr>
+              <a:t>embed / answer</a:t>
+            </a:r>
+          </a:p>
+        </p:txBody>
+      </p:sp>
+      <p:cxnSp>
+        <p:nvCxnSpPr>
+          <p:cNvPr id="31" name="Connector 30"/>
+          <p:cNvCxnSpPr/>
+          <p:nvPr/>
+        </p:nvCxnSpPr>
+        <p:spPr>
+          <a:xfrm flipH="1">
+            <a:off x="10881359" y="5577840"/>
+            <a:ext cx="3611881" cy="0"/>
+          </a:xfrm>
+          <a:prstGeom prst="line">
+            <a:avLst/>
+          </a:prstGeom>
+          <a:ln w="25400">
+            <a:solidFill>
+              <a:srgbClr val="4285F4"/>
+            </a:solidFill>
+            <a:tailEnd type="arrow" w="med" len="med"/>
+          </a:ln>
+        </p:spPr>
+        <p:style>
+          <a:lnRef idx="2">
+            <a:schemeClr val="accent1"/>
+          </a:lnRef>
+          <a:fillRef idx="0">
+            <a:schemeClr val="accent1"/>
+          </a:fillRef>
+          <a:effectRef idx="1">
+            <a:schemeClr val="accent1"/>
+          </a:effectRef>
+          <a:fontRef idx="minor">
+            <a:schemeClr val="tx1"/>
+          </a:fontRef>
+        </p:style>
+      </p:cxnSp>
+      <p:sp>
+        <p:nvSpPr>
+          <p:cNvPr id="32" name="TextBox 31"/>
+          <p:cNvSpPr txBox="1"/>
+          <p:nvPr/>
+        </p:nvSpPr>
+        <p:spPr>
+          <a:xfrm>
+            <a:off x="10927080" y="5650992"/>
+            <a:ext cx="3520440" cy="292608"/>
+          </a:xfrm>
+          <a:prstGeom prst="rect">
+            <a:avLst/>
+          </a:prstGeom>
+          <a:noFill/>
+        </p:spPr>
+        <p:txBody>
+          <a:bodyPr wrap="square">
+            <a:spAutoFit/>
+          </a:bodyPr>
+          <a:lstStyle/>
+          <a:p>
+            <a:pPr algn="ctr"/>
+            <a:r>
+              <a:rPr sz="1000" b="0" i="1">
+                <a:solidFill>
+                  <a:srgbClr val="64748B"/>
+                </a:solidFill>
+              </a:rPr>
+              <a:t>embeddings / tokens</a:t>
+            </a:r>
+          </a:p>
+        </p:txBody>
+      </p:sp>
+      <p:cxnSp>
+        <p:nvCxnSpPr>
+          <p:cNvPr id="33" name="Connector 32"/>
+          <p:cNvCxnSpPr/>
+          <p:nvPr/>
+        </p:nvCxnSpPr>
+        <p:spPr>
+          <a:xfrm>
+            <a:off x="9144000" y="7315200"/>
+            <a:ext cx="0" cy="548640"/>
+          </a:xfrm>
+          <a:prstGeom prst="line">
+            <a:avLst/>
+          </a:prstGeom>
+          <a:ln w="25400">
+            <a:solidFill>
+              <a:srgbClr val="336791"/>
+            </a:solidFill>
+            <a:tailEnd type="arrow" w="med" len="med"/>
+          </a:ln>
+        </p:spPr>
+        <p:style>
+          <a:lnRef idx="2">
+            <a:schemeClr val="accent1"/>
+          </a:lnRef>
+          <a:fillRef idx="0">
+            <a:schemeClr val="accent1"/>
+          </a:fillRef>
+          <a:effectRef idx="1">
+            <a:schemeClr val="accent1"/>
+          </a:effectRef>
+          <a:fontRef idx="minor">
+            <a:schemeClr val="tx1"/>
+          </a:fontRef>
+        </p:style>
+      </p:cxnSp>
+      <p:sp>
+        <p:nvSpPr>
+          <p:cNvPr id="34" name="TextBox 33"/>
+          <p:cNvSpPr txBox="1"/>
+          <p:nvPr/>
+        </p:nvSpPr>
+        <p:spPr>
+          <a:xfrm>
+            <a:off x="9235440" y="7424928"/>
+            <a:ext cx="2011680" cy="329184"/>
+          </a:xfrm>
+          <a:prstGeom prst="rect">
+            <a:avLst/>
+          </a:prstGeom>
+          <a:noFill/>
+        </p:spPr>
+        <p:txBody>
+          <a:bodyPr wrap="square">
+            <a:spAutoFit/>
+          </a:bodyPr>
+          <a:lstStyle/>
+          <a:p>
+            <a:pPr algn="l"/>
+            <a:r>
+              <a:rPr sz="1000" b="0" i="1">
+                <a:solidFill>
+                  <a:srgbClr val="64748B"/>
+                </a:solidFill>
+              </a:rPr>
+              <a:t>store &amp; retrieve</a:t>
+            </a:r>
+          </a:p>
+        </p:txBody>
+      </p:sp>
+      <p:sp>
+        <p:nvSpPr>
+          <p:cNvPr id="35" name="TextBox 34"/>
+          <p:cNvSpPr txBox="1"/>
+          <p:nvPr/>
+        </p:nvSpPr>
+        <p:spPr>
+          <a:xfrm>
+            <a:off x="457200" y="10058400"/>
+            <a:ext cx="17373600" cy="274320"/>
+          </a:xfrm>
+          <a:prstGeom prst="rect">
+            <a:avLst/>
+          </a:prstGeom>
+          <a:noFill/>
+        </p:spPr>
+        <p:txBody>
+          <a:bodyPr wrap="none">
+            <a:spAutoFit/>
+          </a:bodyPr>
+          <a:lstStyle/>
+          <a:p>
+            <a:pPr algn="l"/>
+            <a:r>
+              <a:rPr sz="900" b="0" i="0">
+                <a:solidFill>
+                  <a:srgbClr val="94A3B8"/>
+                </a:solidFill>
+              </a:rPr>
+              <a:t>Ingest flow: Browser → FastAPI → Gemini (embed) → Postgres (store)   Query flow: Browser → FastAPI → Postgres (hybrid search) → Gemini (+answer) → Browser (SSE)</a:t>
+            </a:r>
+          </a:p>
+        </p:txBody>
+      </p:sp>
+    </p:spTree>
+  </p:cSld>
+  <p:clrMapOvr>
+    <a:masterClrMapping/>
+  </p:clrMapOvr>
+</p:sld>
+</file>
+
+<file path=ppt/slides/slide14.xml><?xml version="1.0" encoding="utf-8"?>
 <p:sld xmlns:p="http://schemas.openxmlformats.org/presentationml/2006/main" xmlns:a="http://schemas.openxmlformats.org/drawingml/2006/main">
   <p:cSld>
     <p:spTree>
@@ -7437,2373 +9801,6 @@
 </p:sld>
 </file>
 
-<file path=ppt/slides/slide13.xml><?xml version="1.0" encoding="utf-8"?>
-<p:sld xmlns:a="http://schemas.openxmlformats.org/drawingml/2006/main" xmlns:p="http://schemas.openxmlformats.org/presentationml/2006/main" xmlns:r="http://schemas.openxmlformats.org/officeDocument/2006/relationships">
-  <p:cSld>
-    <p:bg>
-      <p:bgPr>
-        <a:solidFill>
-          <a:srgbClr val="FFFFFF"/>
-        </a:solidFill>
-        <a:effectLst/>
-      </p:bgPr>
-    </p:bg>
-    <p:spTree>
-      <p:nvGrpSpPr>
-        <p:cNvPr id="1" name=""/>
-        <p:cNvGrpSpPr/>
-        <p:nvPr/>
-      </p:nvGrpSpPr>
-      <p:grpSpPr/>
-      <p:sp>
-        <p:nvSpPr>
-          <p:cNvPr id="2" name="TextBox 1"/>
-          <p:cNvSpPr txBox="1"/>
-          <p:nvPr/>
-        </p:nvSpPr>
-        <p:spPr>
-          <a:xfrm>
-            <a:off x="914400" y="484632"/>
-            <a:ext cx="16285463" cy="429768"/>
-          </a:xfrm>
-          <a:prstGeom prst="rect">
-            <a:avLst/>
-          </a:prstGeom>
-          <a:noFill/>
-        </p:spPr>
-        <p:txBody>
-          <a:bodyPr wrap="square">
-            <a:spAutoFit/>
-          </a:bodyPr>
-          <a:lstStyle/>
-          <a:p>
-            <a:pPr algn="l"/>
-            <a:r>
-              <a:rPr sz="1400" b="1" i="0">
-                <a:solidFill>
-                  <a:srgbClr val="7C3AED"/>
-                </a:solidFill>
-              </a:rPr>
-              <a:t>LIMITATIONS</a:t>
-            </a:r>
-          </a:p>
-        </p:txBody>
-      </p:sp>
-      <p:sp>
-        <p:nvSpPr>
-          <p:cNvPr id="3" name="TextBox 2"/>
-          <p:cNvSpPr txBox="1"/>
-          <p:nvPr/>
-        </p:nvSpPr>
-        <p:spPr>
-          <a:xfrm>
-            <a:off x="914400" y="987552"/>
-            <a:ext cx="16285463" cy="502920"/>
-          </a:xfrm>
-          <a:prstGeom prst="rect">
-            <a:avLst/>
-          </a:prstGeom>
-          <a:noFill/>
-        </p:spPr>
-        <p:txBody>
-          <a:bodyPr wrap="square">
-            <a:spAutoFit/>
-          </a:bodyPr>
-          <a:lstStyle/>
-          <a:p>
-            <a:pPr algn="l"/>
-            <a:r>
-              <a:rPr sz="2800" b="1" i="0">
-                <a:solidFill>
-                  <a:srgbClr val="4C1D95"/>
-                </a:solidFill>
-              </a:rPr>
-              <a:t>Current scope — known constraints</a:t>
-            </a:r>
-          </a:p>
-        </p:txBody>
-      </p:sp>
-      <p:sp>
-        <p:nvSpPr>
-          <p:cNvPr id="4" name="Rectangle 3"/>
-          <p:cNvSpPr/>
-          <p:nvPr/>
-        </p:nvSpPr>
-        <p:spPr>
-          <a:xfrm>
-            <a:off x="822960" y="1856231"/>
-            <a:ext cx="16651224" cy="54864"/>
-          </a:xfrm>
-          <a:prstGeom prst="rect">
-            <a:avLst/>
-          </a:prstGeom>
-          <a:solidFill>
-            <a:srgbClr val="EF4444"/>
-          </a:solidFill>
-          <a:ln>
-            <a:noFill/>
-          </a:ln>
-        </p:spPr>
-        <p:style>
-          <a:lnRef idx="1">
-            <a:schemeClr val="accent1"/>
-          </a:lnRef>
-          <a:fillRef idx="3">
-            <a:schemeClr val="accent1"/>
-          </a:fillRef>
-          <a:effectRef idx="2">
-            <a:schemeClr val="accent1"/>
-          </a:effectRef>
-          <a:fontRef idx="minor">
-            <a:schemeClr val="lt1"/>
-          </a:fontRef>
-        </p:style>
-        <p:txBody>
-          <a:bodyPr rtlCol="0" anchor="ctr"/>
-          <a:lstStyle/>
-          <a:p>
-            <a:pPr algn="ctr"/>
-          </a:p>
-        </p:txBody>
-      </p:sp>
-      <p:sp>
-        <p:nvSpPr>
-          <p:cNvPr id="5" name="Rectangle 4"/>
-          <p:cNvSpPr/>
-          <p:nvPr/>
-        </p:nvSpPr>
-        <p:spPr>
-          <a:xfrm>
-            <a:off x="402336" y="2185416"/>
-            <a:ext cx="5303520" cy="3447288"/>
-          </a:xfrm>
-          <a:prstGeom prst="rect">
-            <a:avLst/>
-          </a:prstGeom>
-          <a:solidFill>
-            <a:srgbClr val="FFFFFF"/>
-          </a:solidFill>
-          <a:ln w="6350">
-            <a:solidFill>
-              <a:srgbClr val="E2E8F0"/>
-            </a:solidFill>
-          </a:ln>
-        </p:spPr>
-        <p:style>
-          <a:lnRef idx="1">
-            <a:schemeClr val="accent1"/>
-          </a:lnRef>
-          <a:fillRef idx="3">
-            <a:schemeClr val="accent1"/>
-          </a:fillRef>
-          <a:effectRef idx="2">
-            <a:schemeClr val="accent1"/>
-          </a:effectRef>
-          <a:fontRef idx="minor">
-            <a:schemeClr val="lt1"/>
-          </a:fontRef>
-        </p:style>
-        <p:txBody>
-          <a:bodyPr rtlCol="0" anchor="ctr"/>
-          <a:lstStyle/>
-          <a:p>
-            <a:pPr algn="ctr"/>
-          </a:p>
-        </p:txBody>
-      </p:sp>
-      <p:sp>
-        <p:nvSpPr>
-          <p:cNvPr id="6" name="Rectangle 5"/>
-          <p:cNvSpPr/>
-          <p:nvPr/>
-        </p:nvSpPr>
-        <p:spPr>
-          <a:xfrm>
-            <a:off x="402336" y="2185416"/>
-            <a:ext cx="5303520" cy="64008"/>
-          </a:xfrm>
-          <a:prstGeom prst="rect">
-            <a:avLst/>
-          </a:prstGeom>
-          <a:solidFill>
-            <a:srgbClr val="EF4444"/>
-          </a:solidFill>
-          <a:ln>
-            <a:noFill/>
-          </a:ln>
-        </p:spPr>
-        <p:style>
-          <a:lnRef idx="1">
-            <a:schemeClr val="accent1"/>
-          </a:lnRef>
-          <a:fillRef idx="3">
-            <a:schemeClr val="accent1"/>
-          </a:fillRef>
-          <a:effectRef idx="2">
-            <a:schemeClr val="accent1"/>
-          </a:effectRef>
-          <a:fontRef idx="minor">
-            <a:schemeClr val="lt1"/>
-          </a:fontRef>
-        </p:style>
-        <p:txBody>
-          <a:bodyPr rtlCol="0" anchor="ctr"/>
-          <a:lstStyle/>
-          <a:p>
-            <a:pPr algn="ctr"/>
-          </a:p>
-        </p:txBody>
-      </p:sp>
-      <p:sp>
-        <p:nvSpPr>
-          <p:cNvPr id="7" name="TextBox 6"/>
-          <p:cNvSpPr txBox="1"/>
-          <p:nvPr/>
-        </p:nvSpPr>
-        <p:spPr>
-          <a:xfrm>
-            <a:off x="704088" y="2359152"/>
-            <a:ext cx="4892040" cy="466344"/>
-          </a:xfrm>
-          <a:prstGeom prst="rect">
-            <a:avLst/>
-          </a:prstGeom>
-          <a:noFill/>
-        </p:spPr>
-        <p:txBody>
-          <a:bodyPr wrap="square">
-            <a:spAutoFit/>
-          </a:bodyPr>
-          <a:lstStyle/>
-          <a:p>
-            <a:pPr algn="l"/>
-            <a:r>
-              <a:rPr sz="1500" b="1" i="0">
-                <a:solidFill>
-                  <a:srgbClr val="4C1D95"/>
-                </a:solidFill>
-              </a:rPr>
-              <a:t>🚫  Single Document Only</a:t>
-            </a:r>
-          </a:p>
-        </p:txBody>
-      </p:sp>
-      <p:sp>
-        <p:nvSpPr>
-          <p:cNvPr id="8" name="TextBox 7"/>
-          <p:cNvSpPr txBox="1"/>
-          <p:nvPr/>
-        </p:nvSpPr>
-        <p:spPr>
-          <a:xfrm>
-            <a:off x="704088" y="2962656"/>
-            <a:ext cx="4892040" cy="2414016"/>
-          </a:xfrm>
-          <a:prstGeom prst="rect">
-            <a:avLst/>
-          </a:prstGeom>
-          <a:noFill/>
-        </p:spPr>
-        <p:txBody>
-          <a:bodyPr wrap="square">
-            <a:spAutoFit/>
-          </a:bodyPr>
-          <a:lstStyle/>
-          <a:p>
-            <a:pPr algn="l"/>
-            <a:r>
-              <a:rPr sz="1250" b="0" i="0">
-                <a:solidFill>
-                  <a:srgbClr val="7C3AED"/>
-                </a:solidFill>
-              </a:rPr>
-              <a:t>One PDF at a time. Uploading a new document wipes the previous one — no multi-doc library or cross-document queries.</a:t>
-            </a:r>
-          </a:p>
-        </p:txBody>
-      </p:sp>
-      <p:sp>
-        <p:nvSpPr>
-          <p:cNvPr id="9" name="Rectangle 8"/>
-          <p:cNvSpPr/>
-          <p:nvPr/>
-        </p:nvSpPr>
-        <p:spPr>
-          <a:xfrm>
-            <a:off x="6117336" y="2185416"/>
-            <a:ext cx="5303520" cy="3447288"/>
-          </a:xfrm>
-          <a:prstGeom prst="rect">
-            <a:avLst/>
-          </a:prstGeom>
-          <a:solidFill>
-            <a:srgbClr val="FFFFFF"/>
-          </a:solidFill>
-          <a:ln w="6350">
-            <a:solidFill>
-              <a:srgbClr val="E2E8F0"/>
-            </a:solidFill>
-          </a:ln>
-        </p:spPr>
-        <p:style>
-          <a:lnRef idx="1">
-            <a:schemeClr val="accent1"/>
-          </a:lnRef>
-          <a:fillRef idx="3">
-            <a:schemeClr val="accent1"/>
-          </a:fillRef>
-          <a:effectRef idx="2">
-            <a:schemeClr val="accent1"/>
-          </a:effectRef>
-          <a:fontRef idx="minor">
-            <a:schemeClr val="lt1"/>
-          </a:fontRef>
-        </p:style>
-        <p:txBody>
-          <a:bodyPr rtlCol="0" anchor="ctr"/>
-          <a:lstStyle/>
-          <a:p>
-            <a:pPr algn="ctr"/>
-          </a:p>
-        </p:txBody>
-      </p:sp>
-      <p:sp>
-        <p:nvSpPr>
-          <p:cNvPr id="10" name="Rectangle 9"/>
-          <p:cNvSpPr/>
-          <p:nvPr/>
-        </p:nvSpPr>
-        <p:spPr>
-          <a:xfrm>
-            <a:off x="6117336" y="2185416"/>
-            <a:ext cx="5303520" cy="64008"/>
-          </a:xfrm>
-          <a:prstGeom prst="rect">
-            <a:avLst/>
-          </a:prstGeom>
-          <a:solidFill>
-            <a:srgbClr val="EF4444"/>
-          </a:solidFill>
-          <a:ln>
-            <a:noFill/>
-          </a:ln>
-        </p:spPr>
-        <p:style>
-          <a:lnRef idx="1">
-            <a:schemeClr val="accent1"/>
-          </a:lnRef>
-          <a:fillRef idx="3">
-            <a:schemeClr val="accent1"/>
-          </a:fillRef>
-          <a:effectRef idx="2">
-            <a:schemeClr val="accent1"/>
-          </a:effectRef>
-          <a:fontRef idx="minor">
-            <a:schemeClr val="lt1"/>
-          </a:fontRef>
-        </p:style>
-        <p:txBody>
-          <a:bodyPr rtlCol="0" anchor="ctr"/>
-          <a:lstStyle/>
-          <a:p>
-            <a:pPr algn="ctr"/>
-          </a:p>
-        </p:txBody>
-      </p:sp>
-      <p:sp>
-        <p:nvSpPr>
-          <p:cNvPr id="11" name="TextBox 10"/>
-          <p:cNvSpPr txBox="1"/>
-          <p:nvPr/>
-        </p:nvSpPr>
-        <p:spPr>
-          <a:xfrm>
-            <a:off x="6419088" y="2359152"/>
-            <a:ext cx="4892040" cy="466344"/>
-          </a:xfrm>
-          <a:prstGeom prst="rect">
-            <a:avLst/>
-          </a:prstGeom>
-          <a:noFill/>
-        </p:spPr>
-        <p:txBody>
-          <a:bodyPr wrap="square">
-            <a:spAutoFit/>
-          </a:bodyPr>
-          <a:lstStyle/>
-          <a:p>
-            <a:pPr algn="l"/>
-            <a:r>
-              <a:rPr sz="1500" b="1" i="0">
-                <a:solidFill>
-                  <a:srgbClr val="4C1D95"/>
-                </a:solidFill>
-              </a:rPr>
-              <a:t>🔍  No Scanned PDF / OCR</a:t>
-            </a:r>
-          </a:p>
-        </p:txBody>
-      </p:sp>
-      <p:sp>
-        <p:nvSpPr>
-          <p:cNvPr id="12" name="TextBox 11"/>
-          <p:cNvSpPr txBox="1"/>
-          <p:nvPr/>
-        </p:nvSpPr>
-        <p:spPr>
-          <a:xfrm>
-            <a:off x="6419088" y="2962656"/>
-            <a:ext cx="4892040" cy="2414016"/>
-          </a:xfrm>
-          <a:prstGeom prst="rect">
-            <a:avLst/>
-          </a:prstGeom>
-          <a:noFill/>
-        </p:spPr>
-        <p:txBody>
-          <a:bodyPr wrap="square">
-            <a:spAutoFit/>
-          </a:bodyPr>
-          <a:lstStyle/>
-          <a:p>
-            <a:pPr algn="l"/>
-            <a:r>
-              <a:rPr sz="1250" b="0" i="0">
-                <a:solidFill>
-                  <a:srgbClr val="7C3AED"/>
-                </a:solidFill>
-              </a:rPr>
-              <a:t>PyMuPDF extracts text from digital PDFs only. Image-based or scanned pages return empty text — no Tesseract / Vision fallback.</a:t>
-            </a:r>
-          </a:p>
-        </p:txBody>
-      </p:sp>
-      <p:sp>
-        <p:nvSpPr>
-          <p:cNvPr id="13" name="Rectangle 12"/>
-          <p:cNvSpPr/>
-          <p:nvPr/>
-        </p:nvSpPr>
-        <p:spPr>
-          <a:xfrm>
-            <a:off x="11832336" y="2185416"/>
-            <a:ext cx="5303520" cy="3447288"/>
-          </a:xfrm>
-          <a:prstGeom prst="rect">
-            <a:avLst/>
-          </a:prstGeom>
-          <a:solidFill>
-            <a:srgbClr val="FFFFFF"/>
-          </a:solidFill>
-          <a:ln w="6350">
-            <a:solidFill>
-              <a:srgbClr val="E2E8F0"/>
-            </a:solidFill>
-          </a:ln>
-        </p:spPr>
-        <p:style>
-          <a:lnRef idx="1">
-            <a:schemeClr val="accent1"/>
-          </a:lnRef>
-          <a:fillRef idx="3">
-            <a:schemeClr val="accent1"/>
-          </a:fillRef>
-          <a:effectRef idx="2">
-            <a:schemeClr val="accent1"/>
-          </a:effectRef>
-          <a:fontRef idx="minor">
-            <a:schemeClr val="lt1"/>
-          </a:fontRef>
-        </p:style>
-        <p:txBody>
-          <a:bodyPr rtlCol="0" anchor="ctr"/>
-          <a:lstStyle/>
-          <a:p>
-            <a:pPr algn="ctr"/>
-          </a:p>
-        </p:txBody>
-      </p:sp>
-      <p:sp>
-        <p:nvSpPr>
-          <p:cNvPr id="14" name="Rectangle 13"/>
-          <p:cNvSpPr/>
-          <p:nvPr/>
-        </p:nvSpPr>
-        <p:spPr>
-          <a:xfrm>
-            <a:off x="11832336" y="2185416"/>
-            <a:ext cx="5303520" cy="64008"/>
-          </a:xfrm>
-          <a:prstGeom prst="rect">
-            <a:avLst/>
-          </a:prstGeom>
-          <a:solidFill>
-            <a:srgbClr val="EF4444"/>
-          </a:solidFill>
-          <a:ln>
-            <a:noFill/>
-          </a:ln>
-        </p:spPr>
-        <p:style>
-          <a:lnRef idx="1">
-            <a:schemeClr val="accent1"/>
-          </a:lnRef>
-          <a:fillRef idx="3">
-            <a:schemeClr val="accent1"/>
-          </a:fillRef>
-          <a:effectRef idx="2">
-            <a:schemeClr val="accent1"/>
-          </a:effectRef>
-          <a:fontRef idx="minor">
-            <a:schemeClr val="lt1"/>
-          </a:fontRef>
-        </p:style>
-        <p:txBody>
-          <a:bodyPr rtlCol="0" anchor="ctr"/>
-          <a:lstStyle/>
-          <a:p>
-            <a:pPr algn="ctr"/>
-          </a:p>
-        </p:txBody>
-      </p:sp>
-      <p:sp>
-        <p:nvSpPr>
-          <p:cNvPr id="15" name="TextBox 14"/>
-          <p:cNvSpPr txBox="1"/>
-          <p:nvPr/>
-        </p:nvSpPr>
-        <p:spPr>
-          <a:xfrm>
-            <a:off x="12134088" y="2359152"/>
-            <a:ext cx="4892040" cy="466344"/>
-          </a:xfrm>
-          <a:prstGeom prst="rect">
-            <a:avLst/>
-          </a:prstGeom>
-          <a:noFill/>
-        </p:spPr>
-        <p:txBody>
-          <a:bodyPr wrap="square">
-            <a:spAutoFit/>
-          </a:bodyPr>
-          <a:lstStyle/>
-          <a:p>
-            <a:pPr algn="l"/>
-            <a:r>
-              <a:rPr sz="1500" b="1" i="0">
-                <a:solidFill>
-                  <a:srgbClr val="4C1D95"/>
-                </a:solidFill>
-              </a:rPr>
-              <a:t>👤  No Auth / Multi-User</a:t>
-            </a:r>
-          </a:p>
-        </p:txBody>
-      </p:sp>
-      <p:sp>
-        <p:nvSpPr>
-          <p:cNvPr id="16" name="TextBox 15"/>
-          <p:cNvSpPr txBox="1"/>
-          <p:nvPr/>
-        </p:nvSpPr>
-        <p:spPr>
-          <a:xfrm>
-            <a:off x="12134088" y="2962656"/>
-            <a:ext cx="4892040" cy="2414016"/>
-          </a:xfrm>
-          <a:prstGeom prst="rect">
-            <a:avLst/>
-          </a:prstGeom>
-          <a:noFill/>
-        </p:spPr>
-        <p:txBody>
-          <a:bodyPr wrap="square">
-            <a:spAutoFit/>
-          </a:bodyPr>
-          <a:lstStyle/>
-          <a:p>
-            <a:pPr algn="l"/>
-            <a:r>
-              <a:rPr sz="1250" b="0" i="0">
-                <a:solidFill>
-                  <a:srgbClr val="7C3AED"/>
-                </a:solidFill>
-              </a:rPr>
-              <a:t>Single shared server state. No session isolation — concurrent users share the same document with no login or permission model.</a:t>
-            </a:r>
-          </a:p>
-        </p:txBody>
-      </p:sp>
-      <p:sp>
-        <p:nvSpPr>
-          <p:cNvPr id="17" name="Rectangle 16"/>
-          <p:cNvSpPr/>
-          <p:nvPr/>
-        </p:nvSpPr>
-        <p:spPr>
-          <a:xfrm>
-            <a:off x="402336" y="5806440"/>
-            <a:ext cx="5303520" cy="3447288"/>
-          </a:xfrm>
-          <a:prstGeom prst="rect">
-            <a:avLst/>
-          </a:prstGeom>
-          <a:solidFill>
-            <a:srgbClr val="FFFFFF"/>
-          </a:solidFill>
-          <a:ln w="6350">
-            <a:solidFill>
-              <a:srgbClr val="E2E8F0"/>
-            </a:solidFill>
-          </a:ln>
-        </p:spPr>
-        <p:style>
-          <a:lnRef idx="1">
-            <a:schemeClr val="accent1"/>
-          </a:lnRef>
-          <a:fillRef idx="3">
-            <a:schemeClr val="accent1"/>
-          </a:fillRef>
-          <a:effectRef idx="2">
-            <a:schemeClr val="accent1"/>
-          </a:effectRef>
-          <a:fontRef idx="minor">
-            <a:schemeClr val="lt1"/>
-          </a:fontRef>
-        </p:style>
-        <p:txBody>
-          <a:bodyPr rtlCol="0" anchor="ctr"/>
-          <a:lstStyle/>
-          <a:p>
-            <a:pPr algn="ctr"/>
-          </a:p>
-        </p:txBody>
-      </p:sp>
-      <p:sp>
-        <p:nvSpPr>
-          <p:cNvPr id="18" name="Rectangle 17"/>
-          <p:cNvSpPr/>
-          <p:nvPr/>
-        </p:nvSpPr>
-        <p:spPr>
-          <a:xfrm>
-            <a:off x="402336" y="5806440"/>
-            <a:ext cx="5303520" cy="64008"/>
-          </a:xfrm>
-          <a:prstGeom prst="rect">
-            <a:avLst/>
-          </a:prstGeom>
-          <a:solidFill>
-            <a:srgbClr val="F59E0B"/>
-          </a:solidFill>
-          <a:ln>
-            <a:noFill/>
-          </a:ln>
-        </p:spPr>
-        <p:style>
-          <a:lnRef idx="1">
-            <a:schemeClr val="accent1"/>
-          </a:lnRef>
-          <a:fillRef idx="3">
-            <a:schemeClr val="accent1"/>
-          </a:fillRef>
-          <a:effectRef idx="2">
-            <a:schemeClr val="accent1"/>
-          </a:effectRef>
-          <a:fontRef idx="minor">
-            <a:schemeClr val="lt1"/>
-          </a:fontRef>
-        </p:style>
-        <p:txBody>
-          <a:bodyPr rtlCol="0" anchor="ctr"/>
-          <a:lstStyle/>
-          <a:p>
-            <a:pPr algn="ctr"/>
-          </a:p>
-        </p:txBody>
-      </p:sp>
-      <p:sp>
-        <p:nvSpPr>
-          <p:cNvPr id="19" name="TextBox 18"/>
-          <p:cNvSpPr txBox="1"/>
-          <p:nvPr/>
-        </p:nvSpPr>
-        <p:spPr>
-          <a:xfrm>
-            <a:off x="704088" y="5980176"/>
-            <a:ext cx="4892040" cy="466344"/>
-          </a:xfrm>
-          <a:prstGeom prst="rect">
-            <a:avLst/>
-          </a:prstGeom>
-          <a:noFill/>
-        </p:spPr>
-        <p:txBody>
-          <a:bodyPr wrap="square">
-            <a:spAutoFit/>
-          </a:bodyPr>
-          <a:lstStyle/>
-          <a:p>
-            <a:pPr algn="l"/>
-            <a:r>
-              <a:rPr sz="1500" b="1" i="0">
-                <a:solidFill>
-                  <a:srgbClr val="4C1D95"/>
-                </a:solidFill>
-              </a:rPr>
-              <a:t>💬  No Persistent Chat History</a:t>
-            </a:r>
-          </a:p>
-        </p:txBody>
-      </p:sp>
-      <p:sp>
-        <p:nvSpPr>
-          <p:cNvPr id="20" name="TextBox 19"/>
-          <p:cNvSpPr txBox="1"/>
-          <p:nvPr/>
-        </p:nvSpPr>
-        <p:spPr>
-          <a:xfrm>
-            <a:off x="704088" y="6583679"/>
-            <a:ext cx="4892040" cy="2414016"/>
-          </a:xfrm>
-          <a:prstGeom prst="rect">
-            <a:avLst/>
-          </a:prstGeom>
-          <a:noFill/>
-        </p:spPr>
-        <p:txBody>
-          <a:bodyPr wrap="square">
-            <a:spAutoFit/>
-          </a:bodyPr>
-          <a:lstStyle/>
-          <a:p>
-            <a:pPr algn="l"/>
-            <a:r>
-              <a:rPr sz="1250" b="0" i="0">
-                <a:solidFill>
-                  <a:srgbClr val="7C3AED"/>
-                </a:solidFill>
-              </a:rPr>
-              <a:t>Conversation context resets on page reload. Follow-up questions cannot reference answers from a previous browsing session.</a:t>
-            </a:r>
-          </a:p>
-        </p:txBody>
-      </p:sp>
-      <p:sp>
-        <p:nvSpPr>
-          <p:cNvPr id="21" name="Rectangle 20"/>
-          <p:cNvSpPr/>
-          <p:nvPr/>
-        </p:nvSpPr>
-        <p:spPr>
-          <a:xfrm>
-            <a:off x="6117336" y="5806440"/>
-            <a:ext cx="5303520" cy="3447288"/>
-          </a:xfrm>
-          <a:prstGeom prst="rect">
-            <a:avLst/>
-          </a:prstGeom>
-          <a:solidFill>
-            <a:srgbClr val="FFFFFF"/>
-          </a:solidFill>
-          <a:ln w="6350">
-            <a:solidFill>
-              <a:srgbClr val="E2E8F0"/>
-            </a:solidFill>
-          </a:ln>
-        </p:spPr>
-        <p:style>
-          <a:lnRef idx="1">
-            <a:schemeClr val="accent1"/>
-          </a:lnRef>
-          <a:fillRef idx="3">
-            <a:schemeClr val="accent1"/>
-          </a:fillRef>
-          <a:effectRef idx="2">
-            <a:schemeClr val="accent1"/>
-          </a:effectRef>
-          <a:fontRef idx="minor">
-            <a:schemeClr val="lt1"/>
-          </a:fontRef>
-        </p:style>
-        <p:txBody>
-          <a:bodyPr rtlCol="0" anchor="ctr"/>
-          <a:lstStyle/>
-          <a:p>
-            <a:pPr algn="ctr"/>
-          </a:p>
-        </p:txBody>
-      </p:sp>
-      <p:sp>
-        <p:nvSpPr>
-          <p:cNvPr id="22" name="Rectangle 21"/>
-          <p:cNvSpPr/>
-          <p:nvPr/>
-        </p:nvSpPr>
-        <p:spPr>
-          <a:xfrm>
-            <a:off x="6117336" y="5806440"/>
-            <a:ext cx="5303520" cy="64008"/>
-          </a:xfrm>
-          <a:prstGeom prst="rect">
-            <a:avLst/>
-          </a:prstGeom>
-          <a:solidFill>
-            <a:srgbClr val="F59E0B"/>
-          </a:solidFill>
-          <a:ln>
-            <a:noFill/>
-          </a:ln>
-        </p:spPr>
-        <p:style>
-          <a:lnRef idx="1">
-            <a:schemeClr val="accent1"/>
-          </a:lnRef>
-          <a:fillRef idx="3">
-            <a:schemeClr val="accent1"/>
-          </a:fillRef>
-          <a:effectRef idx="2">
-            <a:schemeClr val="accent1"/>
-          </a:effectRef>
-          <a:fontRef idx="minor">
-            <a:schemeClr val="lt1"/>
-          </a:fontRef>
-        </p:style>
-        <p:txBody>
-          <a:bodyPr rtlCol="0" anchor="ctr"/>
-          <a:lstStyle/>
-          <a:p>
-            <a:pPr algn="ctr"/>
-          </a:p>
-        </p:txBody>
-      </p:sp>
-      <p:sp>
-        <p:nvSpPr>
-          <p:cNvPr id="23" name="TextBox 22"/>
-          <p:cNvSpPr txBox="1"/>
-          <p:nvPr/>
-        </p:nvSpPr>
-        <p:spPr>
-          <a:xfrm>
-            <a:off x="6419088" y="5980176"/>
-            <a:ext cx="4892040" cy="466344"/>
-          </a:xfrm>
-          <a:prstGeom prst="rect">
-            <a:avLst/>
-          </a:prstGeom>
-          <a:noFill/>
-        </p:spPr>
-        <p:txBody>
-          <a:bodyPr wrap="square">
-            <a:spAutoFit/>
-          </a:bodyPr>
-          <a:lstStyle/>
-          <a:p>
-            <a:pPr algn="l"/>
-            <a:r>
-              <a:rPr sz="1500" b="1" i="0">
-                <a:solidFill>
-                  <a:srgbClr val="4C1D95"/>
-                </a:solidFill>
-              </a:rPr>
-              <a:t>⚡  Gemini API Rate Limits</a:t>
-            </a:r>
-          </a:p>
-        </p:txBody>
-      </p:sp>
-      <p:sp>
-        <p:nvSpPr>
-          <p:cNvPr id="24" name="TextBox 23"/>
-          <p:cNvSpPr txBox="1"/>
-          <p:nvPr/>
-        </p:nvSpPr>
-        <p:spPr>
-          <a:xfrm>
-            <a:off x="6419088" y="6583679"/>
-            <a:ext cx="4892040" cy="2414016"/>
-          </a:xfrm>
-          <a:prstGeom prst="rect">
-            <a:avLst/>
-          </a:prstGeom>
-          <a:noFill/>
-        </p:spPr>
-        <p:txBody>
-          <a:bodyPr wrap="square">
-            <a:spAutoFit/>
-          </a:bodyPr>
-          <a:lstStyle/>
-          <a:p>
-            <a:pPr algn="l"/>
-            <a:r>
-              <a:rPr sz="1250" b="0" i="0">
-                <a:solidFill>
-                  <a:srgbClr val="7C3AED"/>
-                </a:solidFill>
-              </a:rPr>
-              <a:t>Concurrent embedding calls hit 429 limits on large documents. Exponential backoff adds latency for 100+ page PDFs.</a:t>
-            </a:r>
-          </a:p>
-        </p:txBody>
-      </p:sp>
-      <p:sp>
-        <p:nvSpPr>
-          <p:cNvPr id="25" name="Rectangle 24"/>
-          <p:cNvSpPr/>
-          <p:nvPr/>
-        </p:nvSpPr>
-        <p:spPr>
-          <a:xfrm>
-            <a:off x="11832336" y="5806440"/>
-            <a:ext cx="5303520" cy="3447288"/>
-          </a:xfrm>
-          <a:prstGeom prst="rect">
-            <a:avLst/>
-          </a:prstGeom>
-          <a:solidFill>
-            <a:srgbClr val="FFFFFF"/>
-          </a:solidFill>
-          <a:ln w="6350">
-            <a:solidFill>
-              <a:srgbClr val="E2E8F0"/>
-            </a:solidFill>
-          </a:ln>
-        </p:spPr>
-        <p:style>
-          <a:lnRef idx="1">
-            <a:schemeClr val="accent1"/>
-          </a:lnRef>
-          <a:fillRef idx="3">
-            <a:schemeClr val="accent1"/>
-          </a:fillRef>
-          <a:effectRef idx="2">
-            <a:schemeClr val="accent1"/>
-          </a:effectRef>
-          <a:fontRef idx="minor">
-            <a:schemeClr val="lt1"/>
-          </a:fontRef>
-        </p:style>
-        <p:txBody>
-          <a:bodyPr rtlCol="0" anchor="ctr"/>
-          <a:lstStyle/>
-          <a:p>
-            <a:pPr algn="ctr"/>
-          </a:p>
-        </p:txBody>
-      </p:sp>
-      <p:sp>
-        <p:nvSpPr>
-          <p:cNvPr id="26" name="Rectangle 25"/>
-          <p:cNvSpPr/>
-          <p:nvPr/>
-        </p:nvSpPr>
-        <p:spPr>
-          <a:xfrm>
-            <a:off x="11832336" y="5806440"/>
-            <a:ext cx="5303520" cy="64008"/>
-          </a:xfrm>
-          <a:prstGeom prst="rect">
-            <a:avLst/>
-          </a:prstGeom>
-          <a:solidFill>
-            <a:srgbClr val="F59E0B"/>
-          </a:solidFill>
-          <a:ln>
-            <a:noFill/>
-          </a:ln>
-        </p:spPr>
-        <p:style>
-          <a:lnRef idx="1">
-            <a:schemeClr val="accent1"/>
-          </a:lnRef>
-          <a:fillRef idx="3">
-            <a:schemeClr val="accent1"/>
-          </a:fillRef>
-          <a:effectRef idx="2">
-            <a:schemeClr val="accent1"/>
-          </a:effectRef>
-          <a:fontRef idx="minor">
-            <a:schemeClr val="lt1"/>
-          </a:fontRef>
-        </p:style>
-        <p:txBody>
-          <a:bodyPr rtlCol="0" anchor="ctr"/>
-          <a:lstStyle/>
-          <a:p>
-            <a:pPr algn="ctr"/>
-          </a:p>
-        </p:txBody>
-      </p:sp>
-      <p:sp>
-        <p:nvSpPr>
-          <p:cNvPr id="27" name="TextBox 26"/>
-          <p:cNvSpPr txBox="1"/>
-          <p:nvPr/>
-        </p:nvSpPr>
-        <p:spPr>
-          <a:xfrm>
-            <a:off x="12134088" y="5980176"/>
-            <a:ext cx="4892040" cy="466344"/>
-          </a:xfrm>
-          <a:prstGeom prst="rect">
-            <a:avLst/>
-          </a:prstGeom>
-          <a:noFill/>
-        </p:spPr>
-        <p:txBody>
-          <a:bodyPr wrap="square">
-            <a:spAutoFit/>
-          </a:bodyPr>
-          <a:lstStyle/>
-          <a:p>
-            <a:pPr algn="l"/>
-            <a:r>
-              <a:rPr sz="1500" b="1" i="0">
-                <a:solidFill>
-                  <a:srgbClr val="4C1D95"/>
-                </a:solidFill>
-              </a:rPr>
-              <a:t>🔤  PyMuPDF ≠ PDF.js Extraction</a:t>
-            </a:r>
-          </a:p>
-        </p:txBody>
-      </p:sp>
-      <p:sp>
-        <p:nvSpPr>
-          <p:cNvPr id="28" name="TextBox 27"/>
-          <p:cNvSpPr txBox="1"/>
-          <p:nvPr/>
-        </p:nvSpPr>
-        <p:spPr>
-          <a:xfrm>
-            <a:off x="12134088" y="6583679"/>
-            <a:ext cx="4892040" cy="2414016"/>
-          </a:xfrm>
-          <a:prstGeom prst="rect">
-            <a:avLst/>
-          </a:prstGeom>
-          <a:noFill/>
-        </p:spPr>
-        <p:txBody>
-          <a:bodyPr wrap="square">
-            <a:spAutoFit/>
-          </a:bodyPr>
-          <a:lstStyle/>
-          <a:p>
-            <a:pPr algn="l"/>
-            <a:r>
-              <a:rPr sz="1250" b="0" i="0">
-                <a:solidFill>
-                  <a:srgbClr val="7C3AED"/>
-                </a:solidFill>
-              </a:rPr>
-              <a:t>Math and symbols render differently at ingest (PyMuPDF) and in the viewer (PDF.js), requiring fuzzy word-anchor matching for highlighting.</a:t>
-            </a:r>
-          </a:p>
-        </p:txBody>
-      </p:sp>
-    </p:spTree>
-  </p:cSld>
-  <p:clrMapOvr>
-    <a:masterClrMapping/>
-  </p:clrMapOvr>
-</p:sld>
-</file>
-
-<file path=ppt/slides/slide14.xml><?xml version="1.0" encoding="utf-8"?>
-<p:sld xmlns:a="http://schemas.openxmlformats.org/drawingml/2006/main" xmlns:p="http://schemas.openxmlformats.org/presentationml/2006/main" xmlns:r="http://schemas.openxmlformats.org/officeDocument/2006/relationships">
-  <p:cSld>
-    <p:bg>
-      <p:bgPr>
-        <a:solidFill>
-          <a:srgbClr val="FFFFFF"/>
-        </a:solidFill>
-        <a:effectLst/>
-      </p:bgPr>
-    </p:bg>
-    <p:spTree>
-      <p:nvGrpSpPr>
-        <p:cNvPr id="1" name=""/>
-        <p:cNvGrpSpPr/>
-        <p:nvPr/>
-      </p:nvGrpSpPr>
-      <p:grpSpPr/>
-      <p:sp>
-        <p:nvSpPr>
-          <p:cNvPr id="2" name="TextBox 1"/>
-          <p:cNvSpPr txBox="1"/>
-          <p:nvPr/>
-        </p:nvSpPr>
-        <p:spPr>
-          <a:xfrm>
-            <a:off x="914400" y="484632"/>
-            <a:ext cx="16285463" cy="429768"/>
-          </a:xfrm>
-          <a:prstGeom prst="rect">
-            <a:avLst/>
-          </a:prstGeom>
-          <a:noFill/>
-        </p:spPr>
-        <p:txBody>
-          <a:bodyPr wrap="square">
-            <a:spAutoFit/>
-          </a:bodyPr>
-          <a:lstStyle/>
-          <a:p>
-            <a:pPr algn="l"/>
-            <a:r>
-              <a:rPr sz="1400" b="1" i="0">
-                <a:solidFill>
-                  <a:srgbClr val="7C3AED"/>
-                </a:solidFill>
-              </a:rPr>
-              <a:t>SYSTEM DESIGN</a:t>
-            </a:r>
-          </a:p>
-        </p:txBody>
-      </p:sp>
-      <p:sp>
-        <p:nvSpPr>
-          <p:cNvPr id="3" name="TextBox 2"/>
-          <p:cNvSpPr txBox="1"/>
-          <p:nvPr/>
-        </p:nvSpPr>
-        <p:spPr>
-          <a:xfrm>
-            <a:off x="914400" y="987552"/>
-            <a:ext cx="16285463" cy="502920"/>
-          </a:xfrm>
-          <a:prstGeom prst="rect">
-            <a:avLst/>
-          </a:prstGeom>
-          <a:noFill/>
-        </p:spPr>
-        <p:txBody>
-          <a:bodyPr wrap="square">
-            <a:spAutoFit/>
-          </a:bodyPr>
-          <a:lstStyle/>
-          <a:p>
-            <a:pPr algn="l"/>
-            <a:r>
-              <a:rPr sz="2800" b="1" i="0">
-                <a:solidFill>
-                  <a:srgbClr val="4C1D95"/>
-                </a:solidFill>
-              </a:rPr>
-              <a:t>Component architecture &amp; data flow</a:t>
-            </a:r>
-          </a:p>
-        </p:txBody>
-      </p:sp>
-      <p:sp>
-        <p:nvSpPr>
-          <p:cNvPr id="4" name="Rectangle 3"/>
-          <p:cNvSpPr/>
-          <p:nvPr/>
-        </p:nvSpPr>
-        <p:spPr>
-          <a:xfrm>
-            <a:off x="822960" y="1856231"/>
-            <a:ext cx="16651224" cy="54864"/>
-          </a:xfrm>
-          <a:prstGeom prst="rect">
-            <a:avLst/>
-          </a:prstGeom>
-          <a:solidFill>
-            <a:srgbClr val="7C3AED"/>
-          </a:solidFill>
-          <a:ln>
-            <a:noFill/>
-          </a:ln>
-        </p:spPr>
-        <p:style>
-          <a:lnRef idx="1">
-            <a:schemeClr val="accent1"/>
-          </a:lnRef>
-          <a:fillRef idx="3">
-            <a:schemeClr val="accent1"/>
-          </a:fillRef>
-          <a:effectRef idx="2">
-            <a:schemeClr val="accent1"/>
-          </a:effectRef>
-          <a:fontRef idx="minor">
-            <a:schemeClr val="lt1"/>
-          </a:fontRef>
-        </p:style>
-        <p:txBody>
-          <a:bodyPr rtlCol="0" anchor="ctr"/>
-          <a:lstStyle/>
-          <a:p>
-            <a:pPr algn="ctr"/>
-          </a:p>
-        </p:txBody>
-      </p:sp>
-      <p:sp>
-        <p:nvSpPr>
-          <p:cNvPr id="5" name="Rectangle 4"/>
-          <p:cNvSpPr/>
-          <p:nvPr/>
-        </p:nvSpPr>
-        <p:spPr>
-          <a:xfrm>
-            <a:off x="320040" y="3291840"/>
-            <a:ext cx="3474720" cy="3474720"/>
-          </a:xfrm>
-          <a:prstGeom prst="rect">
-            <a:avLst/>
-          </a:prstGeom>
-          <a:solidFill>
-            <a:srgbClr val="FFFFFF"/>
-          </a:solidFill>
-          <a:ln w="19050">
-            <a:solidFill>
-              <a:srgbClr val="7C3AED"/>
-            </a:solidFill>
-          </a:ln>
-        </p:spPr>
-        <p:style>
-          <a:lnRef idx="1">
-            <a:schemeClr val="accent1"/>
-          </a:lnRef>
-          <a:fillRef idx="3">
-            <a:schemeClr val="accent1"/>
-          </a:fillRef>
-          <a:effectRef idx="2">
-            <a:schemeClr val="accent1"/>
-          </a:effectRef>
-          <a:fontRef idx="minor">
-            <a:schemeClr val="lt1"/>
-          </a:fontRef>
-        </p:style>
-        <p:txBody>
-          <a:bodyPr rtlCol="0" anchor="ctr"/>
-          <a:lstStyle/>
-          <a:p>
-            <a:pPr algn="ctr"/>
-          </a:p>
-        </p:txBody>
-      </p:sp>
-      <p:sp>
-        <p:nvSpPr>
-          <p:cNvPr id="6" name="Rectangle 5"/>
-          <p:cNvSpPr/>
-          <p:nvPr/>
-        </p:nvSpPr>
-        <p:spPr>
-          <a:xfrm>
-            <a:off x="320040" y="3291840"/>
-            <a:ext cx="3474720" cy="54864"/>
-          </a:xfrm>
-          <a:prstGeom prst="rect">
-            <a:avLst/>
-          </a:prstGeom>
-          <a:solidFill>
-            <a:srgbClr val="7C3AED"/>
-          </a:solidFill>
-          <a:ln>
-            <a:noFill/>
-          </a:ln>
-        </p:spPr>
-        <p:style>
-          <a:lnRef idx="1">
-            <a:schemeClr val="accent1"/>
-          </a:lnRef>
-          <a:fillRef idx="3">
-            <a:schemeClr val="accent1"/>
-          </a:fillRef>
-          <a:effectRef idx="2">
-            <a:schemeClr val="accent1"/>
-          </a:effectRef>
-          <a:fontRef idx="minor">
-            <a:schemeClr val="lt1"/>
-          </a:fontRef>
-        </p:style>
-        <p:txBody>
-          <a:bodyPr rtlCol="0" anchor="ctr"/>
-          <a:lstStyle/>
-          <a:p>
-            <a:pPr algn="ctr"/>
-          </a:p>
-        </p:txBody>
-      </p:sp>
-      <p:sp>
-        <p:nvSpPr>
-          <p:cNvPr id="7" name="TextBox 6"/>
-          <p:cNvSpPr txBox="1"/>
-          <p:nvPr/>
-        </p:nvSpPr>
-        <p:spPr>
-          <a:xfrm>
-            <a:off x="548640" y="3456432"/>
-            <a:ext cx="3108960" cy="502920"/>
-          </a:xfrm>
-          <a:prstGeom prst="rect">
-            <a:avLst/>
-          </a:prstGeom>
-          <a:noFill/>
-        </p:spPr>
-        <p:txBody>
-          <a:bodyPr wrap="square">
-            <a:spAutoFit/>
-          </a:bodyPr>
-          <a:lstStyle/>
-          <a:p>
-            <a:pPr algn="l"/>
-            <a:r>
-              <a:rPr sz="2200" b="0" i="0">
-                <a:solidFill>
-                  <a:srgbClr val="4C1D95"/>
-                </a:solidFill>
-              </a:rPr>
-              <a:t>🌐</a:t>
-            </a:r>
-          </a:p>
-        </p:txBody>
-      </p:sp>
-      <p:sp>
-        <p:nvSpPr>
-          <p:cNvPr id="8" name="TextBox 7"/>
-          <p:cNvSpPr txBox="1"/>
-          <p:nvPr/>
-        </p:nvSpPr>
-        <p:spPr>
-          <a:xfrm>
-            <a:off x="548640" y="3977639"/>
-            <a:ext cx="3108960" cy="457200"/>
-          </a:xfrm>
-          <a:prstGeom prst="rect">
-            <a:avLst/>
-          </a:prstGeom>
-          <a:noFill/>
-        </p:spPr>
-        <p:txBody>
-          <a:bodyPr wrap="square">
-            <a:spAutoFit/>
-          </a:bodyPr>
-          <a:lstStyle/>
-          <a:p>
-            <a:pPr algn="l"/>
-            <a:r>
-              <a:rPr sz="1600" b="1" i="0">
-                <a:solidFill>
-                  <a:srgbClr val="4C1D95"/>
-                </a:solidFill>
-              </a:rPr>
-              <a:t>Browser</a:t>
-            </a:r>
-          </a:p>
-        </p:txBody>
-      </p:sp>
-      <p:sp>
-        <p:nvSpPr>
-          <p:cNvPr id="9" name="TextBox 8"/>
-          <p:cNvSpPr txBox="1"/>
-          <p:nvPr/>
-        </p:nvSpPr>
-        <p:spPr>
-          <a:xfrm>
-            <a:off x="548640" y="4480560"/>
-            <a:ext cx="3108960" cy="2103120"/>
-          </a:xfrm>
-          <a:prstGeom prst="rect">
-            <a:avLst/>
-          </a:prstGeom>
-          <a:noFill/>
-        </p:spPr>
-        <p:txBody>
-          <a:bodyPr wrap="square">
-            <a:spAutoFit/>
-          </a:bodyPr>
-          <a:lstStyle/>
-          <a:p>
-            <a:pPr algn="l"/>
-            <a:r>
-              <a:rPr sz="1150" b="0" i="0">
-                <a:solidFill>
-                  <a:srgbClr val="7C3AED"/>
-                </a:solidFill>
-              </a:rPr>
-              <a:t>index.html
-PDF.js viewer
-SSE streaming
-citation pills</a:t>
-            </a:r>
-          </a:p>
-        </p:txBody>
-      </p:sp>
-      <p:sp>
-        <p:nvSpPr>
-          <p:cNvPr id="10" name="Rectangle 9"/>
-          <p:cNvSpPr/>
-          <p:nvPr/>
-        </p:nvSpPr>
-        <p:spPr>
-          <a:xfrm>
-            <a:off x="7406640" y="2194560"/>
-            <a:ext cx="3474720" cy="5120640"/>
-          </a:xfrm>
-          <a:prstGeom prst="rect">
-            <a:avLst/>
-          </a:prstGeom>
-          <a:solidFill>
-            <a:srgbClr val="FFFFFF"/>
-          </a:solidFill>
-          <a:ln w="19050">
-            <a:solidFill>
-              <a:srgbClr val="059669"/>
-            </a:solidFill>
-          </a:ln>
-        </p:spPr>
-        <p:style>
-          <a:lnRef idx="1">
-            <a:schemeClr val="accent1"/>
-          </a:lnRef>
-          <a:fillRef idx="3">
-            <a:schemeClr val="accent1"/>
-          </a:fillRef>
-          <a:effectRef idx="2">
-            <a:schemeClr val="accent1"/>
-          </a:effectRef>
-          <a:fontRef idx="minor">
-            <a:schemeClr val="lt1"/>
-          </a:fontRef>
-        </p:style>
-        <p:txBody>
-          <a:bodyPr rtlCol="0" anchor="ctr"/>
-          <a:lstStyle/>
-          <a:p>
-            <a:pPr algn="ctr"/>
-          </a:p>
-        </p:txBody>
-      </p:sp>
-      <p:sp>
-        <p:nvSpPr>
-          <p:cNvPr id="11" name="Rectangle 10"/>
-          <p:cNvSpPr/>
-          <p:nvPr/>
-        </p:nvSpPr>
-        <p:spPr>
-          <a:xfrm>
-            <a:off x="7406640" y="2194560"/>
-            <a:ext cx="3474720" cy="54864"/>
-          </a:xfrm>
-          <a:prstGeom prst="rect">
-            <a:avLst/>
-          </a:prstGeom>
-          <a:solidFill>
-            <a:srgbClr val="059669"/>
-          </a:solidFill>
-          <a:ln>
-            <a:noFill/>
-          </a:ln>
-        </p:spPr>
-        <p:style>
-          <a:lnRef idx="1">
-            <a:schemeClr val="accent1"/>
-          </a:lnRef>
-          <a:fillRef idx="3">
-            <a:schemeClr val="accent1"/>
-          </a:fillRef>
-          <a:effectRef idx="2">
-            <a:schemeClr val="accent1"/>
-          </a:effectRef>
-          <a:fontRef idx="minor">
-            <a:schemeClr val="lt1"/>
-          </a:fontRef>
-        </p:style>
-        <p:txBody>
-          <a:bodyPr rtlCol="0" anchor="ctr"/>
-          <a:lstStyle/>
-          <a:p>
-            <a:pPr algn="ctr"/>
-          </a:p>
-        </p:txBody>
-      </p:sp>
-      <p:sp>
-        <p:nvSpPr>
-          <p:cNvPr id="12" name="TextBox 11"/>
-          <p:cNvSpPr txBox="1"/>
-          <p:nvPr/>
-        </p:nvSpPr>
-        <p:spPr>
-          <a:xfrm>
-            <a:off x="7635240" y="2359152"/>
-            <a:ext cx="3108960" cy="502920"/>
-          </a:xfrm>
-          <a:prstGeom prst="rect">
-            <a:avLst/>
-          </a:prstGeom>
-          <a:noFill/>
-        </p:spPr>
-        <p:txBody>
-          <a:bodyPr wrap="square">
-            <a:spAutoFit/>
-          </a:bodyPr>
-          <a:lstStyle/>
-          <a:p>
-            <a:pPr algn="l"/>
-            <a:r>
-              <a:rPr sz="2200" b="0" i="0">
-                <a:solidFill>
-                  <a:srgbClr val="4C1D95"/>
-                </a:solidFill>
-              </a:rPr>
-              <a:t>⚙️</a:t>
-            </a:r>
-          </a:p>
-        </p:txBody>
-      </p:sp>
-      <p:sp>
-        <p:nvSpPr>
-          <p:cNvPr id="13" name="TextBox 12"/>
-          <p:cNvSpPr txBox="1"/>
-          <p:nvPr/>
-        </p:nvSpPr>
-        <p:spPr>
-          <a:xfrm>
-            <a:off x="7635240" y="2880360"/>
-            <a:ext cx="3108960" cy="457200"/>
-          </a:xfrm>
-          <a:prstGeom prst="rect">
-            <a:avLst/>
-          </a:prstGeom>
-          <a:noFill/>
-        </p:spPr>
-        <p:txBody>
-          <a:bodyPr wrap="square">
-            <a:spAutoFit/>
-          </a:bodyPr>
-          <a:lstStyle/>
-          <a:p>
-            <a:pPr algn="l"/>
-            <a:r>
-              <a:rPr sz="1600" b="1" i="0">
-                <a:solidFill>
-                  <a:srgbClr val="4C1D95"/>
-                </a:solidFill>
-              </a:rPr>
-              <a:t>FastAPI</a:t>
-            </a:r>
-          </a:p>
-        </p:txBody>
-      </p:sp>
-      <p:sp>
-        <p:nvSpPr>
-          <p:cNvPr id="14" name="TextBox 13"/>
-          <p:cNvSpPr txBox="1"/>
-          <p:nvPr/>
-        </p:nvSpPr>
-        <p:spPr>
-          <a:xfrm>
-            <a:off x="7635240" y="3383280"/>
-            <a:ext cx="3108960" cy="3749039"/>
-          </a:xfrm>
-          <a:prstGeom prst="rect">
-            <a:avLst/>
-          </a:prstGeom>
-          <a:noFill/>
-        </p:spPr>
-        <p:txBody>
-          <a:bodyPr wrap="square">
-            <a:spAutoFit/>
-          </a:bodyPr>
-          <a:lstStyle/>
-          <a:p>
-            <a:pPr algn="l"/>
-            <a:r>
-              <a:rPr sz="1150" b="0" i="0">
-                <a:solidFill>
-                  <a:srgbClr val="7C3AED"/>
-                </a:solidFill>
-              </a:rPr>
-              <a:t>POST /ingest
-POST /query
-DELETE /doc
-GET /doc/info
-GET /health
-asyncpg · uvicorn</a:t>
-            </a:r>
-          </a:p>
-        </p:txBody>
-      </p:sp>
-      <p:sp>
-        <p:nvSpPr>
-          <p:cNvPr id="15" name="Rectangle 14"/>
-          <p:cNvSpPr/>
-          <p:nvPr/>
-        </p:nvSpPr>
-        <p:spPr>
-          <a:xfrm>
-            <a:off x="14493240" y="3291840"/>
-            <a:ext cx="3474720" cy="3474720"/>
-          </a:xfrm>
-          <a:prstGeom prst="rect">
-            <a:avLst/>
-          </a:prstGeom>
-          <a:solidFill>
-            <a:srgbClr val="FFFFFF"/>
-          </a:solidFill>
-          <a:ln w="19050">
-            <a:solidFill>
-              <a:srgbClr val="4285F4"/>
-            </a:solidFill>
-          </a:ln>
-        </p:spPr>
-        <p:style>
-          <a:lnRef idx="1">
-            <a:schemeClr val="accent1"/>
-          </a:lnRef>
-          <a:fillRef idx="3">
-            <a:schemeClr val="accent1"/>
-          </a:fillRef>
-          <a:effectRef idx="2">
-            <a:schemeClr val="accent1"/>
-          </a:effectRef>
-          <a:fontRef idx="minor">
-            <a:schemeClr val="lt1"/>
-          </a:fontRef>
-        </p:style>
-        <p:txBody>
-          <a:bodyPr rtlCol="0" anchor="ctr"/>
-          <a:lstStyle/>
-          <a:p>
-            <a:pPr algn="ctr"/>
-          </a:p>
-        </p:txBody>
-      </p:sp>
-      <p:sp>
-        <p:nvSpPr>
-          <p:cNvPr id="16" name="Rectangle 15"/>
-          <p:cNvSpPr/>
-          <p:nvPr/>
-        </p:nvSpPr>
-        <p:spPr>
-          <a:xfrm>
-            <a:off x="14493240" y="3291840"/>
-            <a:ext cx="3474720" cy="54864"/>
-          </a:xfrm>
-          <a:prstGeom prst="rect">
-            <a:avLst/>
-          </a:prstGeom>
-          <a:solidFill>
-            <a:srgbClr val="4285F4"/>
-          </a:solidFill>
-          <a:ln>
-            <a:noFill/>
-          </a:ln>
-        </p:spPr>
-        <p:style>
-          <a:lnRef idx="1">
-            <a:schemeClr val="accent1"/>
-          </a:lnRef>
-          <a:fillRef idx="3">
-            <a:schemeClr val="accent1"/>
-          </a:fillRef>
-          <a:effectRef idx="2">
-            <a:schemeClr val="accent1"/>
-          </a:effectRef>
-          <a:fontRef idx="minor">
-            <a:schemeClr val="lt1"/>
-          </a:fontRef>
-        </p:style>
-        <p:txBody>
-          <a:bodyPr rtlCol="0" anchor="ctr"/>
-          <a:lstStyle/>
-          <a:p>
-            <a:pPr algn="ctr"/>
-          </a:p>
-        </p:txBody>
-      </p:sp>
-      <p:sp>
-        <p:nvSpPr>
-          <p:cNvPr id="17" name="TextBox 16"/>
-          <p:cNvSpPr txBox="1"/>
-          <p:nvPr/>
-        </p:nvSpPr>
-        <p:spPr>
-          <a:xfrm>
-            <a:off x="14721840" y="3456432"/>
-            <a:ext cx="3108960" cy="502920"/>
-          </a:xfrm>
-          <a:prstGeom prst="rect">
-            <a:avLst/>
-          </a:prstGeom>
-          <a:noFill/>
-        </p:spPr>
-        <p:txBody>
-          <a:bodyPr wrap="square">
-            <a:spAutoFit/>
-          </a:bodyPr>
-          <a:lstStyle/>
-          <a:p>
-            <a:pPr algn="l"/>
-            <a:r>
-              <a:rPr sz="2200" b="0" i="0">
-                <a:solidFill>
-                  <a:srgbClr val="4C1D95"/>
-                </a:solidFill>
-              </a:rPr>
-              <a:t>🧠</a:t>
-            </a:r>
-          </a:p>
-        </p:txBody>
-      </p:sp>
-      <p:sp>
-        <p:nvSpPr>
-          <p:cNvPr id="18" name="TextBox 17"/>
-          <p:cNvSpPr txBox="1"/>
-          <p:nvPr/>
-        </p:nvSpPr>
-        <p:spPr>
-          <a:xfrm>
-            <a:off x="14721840" y="3977639"/>
-            <a:ext cx="3108960" cy="457200"/>
-          </a:xfrm>
-          <a:prstGeom prst="rect">
-            <a:avLst/>
-          </a:prstGeom>
-          <a:noFill/>
-        </p:spPr>
-        <p:txBody>
-          <a:bodyPr wrap="square">
-            <a:spAutoFit/>
-          </a:bodyPr>
-          <a:lstStyle/>
-          <a:p>
-            <a:pPr algn="l"/>
-            <a:r>
-              <a:rPr sz="1600" b="1" i="0">
-                <a:solidFill>
-                  <a:srgbClr val="4C1D95"/>
-                </a:solidFill>
-              </a:rPr>
-              <a:t>Gemini API</a:t>
-            </a:r>
-          </a:p>
-        </p:txBody>
-      </p:sp>
-      <p:sp>
-        <p:nvSpPr>
-          <p:cNvPr id="19" name="TextBox 18"/>
-          <p:cNvSpPr txBox="1"/>
-          <p:nvPr/>
-        </p:nvSpPr>
-        <p:spPr>
-          <a:xfrm>
-            <a:off x="14721840" y="4480560"/>
-            <a:ext cx="3108960" cy="2103120"/>
-          </a:xfrm>
-          <a:prstGeom prst="rect">
-            <a:avLst/>
-          </a:prstGeom>
-          <a:noFill/>
-        </p:spPr>
-        <p:txBody>
-          <a:bodyPr wrap="square">
-            <a:spAutoFit/>
-          </a:bodyPr>
-          <a:lstStyle/>
-          <a:p>
-            <a:pPr algn="l"/>
-            <a:r>
-              <a:rPr sz="1150" b="0" i="0">
-                <a:solidFill>
-                  <a:srgbClr val="7C3AED"/>
-                </a:solidFill>
-              </a:rPr>
-              <a:t>embedding-2 (768-dim)
-RETRIEVAL_DOCUMENT/QUERY
-2.5-flash rerank
-2.5-flash answer (SSE)</a:t>
-            </a:r>
-          </a:p>
-        </p:txBody>
-      </p:sp>
-      <p:sp>
-        <p:nvSpPr>
-          <p:cNvPr id="20" name="Rectangle 19"/>
-          <p:cNvSpPr/>
-          <p:nvPr/>
-        </p:nvSpPr>
-        <p:spPr>
-          <a:xfrm>
-            <a:off x="7406640" y="7863840"/>
-            <a:ext cx="3474720" cy="2103120"/>
-          </a:xfrm>
-          <a:prstGeom prst="rect">
-            <a:avLst/>
-          </a:prstGeom>
-          <a:solidFill>
-            <a:srgbClr val="FFFFFF"/>
-          </a:solidFill>
-          <a:ln w="19050">
-            <a:solidFill>
-              <a:srgbClr val="336791"/>
-            </a:solidFill>
-          </a:ln>
-        </p:spPr>
-        <p:style>
-          <a:lnRef idx="1">
-            <a:schemeClr val="accent1"/>
-          </a:lnRef>
-          <a:fillRef idx="3">
-            <a:schemeClr val="accent1"/>
-          </a:fillRef>
-          <a:effectRef idx="2">
-            <a:schemeClr val="accent1"/>
-          </a:effectRef>
-          <a:fontRef idx="minor">
-            <a:schemeClr val="lt1"/>
-          </a:fontRef>
-        </p:style>
-        <p:txBody>
-          <a:bodyPr rtlCol="0" anchor="ctr"/>
-          <a:lstStyle/>
-          <a:p>
-            <a:pPr algn="ctr"/>
-          </a:p>
-        </p:txBody>
-      </p:sp>
-      <p:sp>
-        <p:nvSpPr>
-          <p:cNvPr id="21" name="Rectangle 20"/>
-          <p:cNvSpPr/>
-          <p:nvPr/>
-        </p:nvSpPr>
-        <p:spPr>
-          <a:xfrm>
-            <a:off x="7406640" y="7863840"/>
-            <a:ext cx="3474720" cy="54864"/>
-          </a:xfrm>
-          <a:prstGeom prst="rect">
-            <a:avLst/>
-          </a:prstGeom>
-          <a:solidFill>
-            <a:srgbClr val="336791"/>
-          </a:solidFill>
-          <a:ln>
-            <a:noFill/>
-          </a:ln>
-        </p:spPr>
-        <p:style>
-          <a:lnRef idx="1">
-            <a:schemeClr val="accent1"/>
-          </a:lnRef>
-          <a:fillRef idx="3">
-            <a:schemeClr val="accent1"/>
-          </a:fillRef>
-          <a:effectRef idx="2">
-            <a:schemeClr val="accent1"/>
-          </a:effectRef>
-          <a:fontRef idx="minor">
-            <a:schemeClr val="lt1"/>
-          </a:fontRef>
-        </p:style>
-        <p:txBody>
-          <a:bodyPr rtlCol="0" anchor="ctr"/>
-          <a:lstStyle/>
-          <a:p>
-            <a:pPr algn="ctr"/>
-          </a:p>
-        </p:txBody>
-      </p:sp>
-      <p:sp>
-        <p:nvSpPr>
-          <p:cNvPr id="22" name="TextBox 21"/>
-          <p:cNvSpPr txBox="1"/>
-          <p:nvPr/>
-        </p:nvSpPr>
-        <p:spPr>
-          <a:xfrm>
-            <a:off x="7635240" y="8028431"/>
-            <a:ext cx="3108960" cy="502920"/>
-          </a:xfrm>
-          <a:prstGeom prst="rect">
-            <a:avLst/>
-          </a:prstGeom>
-          <a:noFill/>
-        </p:spPr>
-        <p:txBody>
-          <a:bodyPr wrap="square">
-            <a:spAutoFit/>
-          </a:bodyPr>
-          <a:lstStyle/>
-          <a:p>
-            <a:pPr algn="l"/>
-            <a:r>
-              <a:rPr sz="2200" b="0" i="0">
-                <a:solidFill>
-                  <a:srgbClr val="4C1D95"/>
-                </a:solidFill>
-              </a:rPr>
-              <a:t>🗄️</a:t>
-            </a:r>
-          </a:p>
-        </p:txBody>
-      </p:sp>
-      <p:sp>
-        <p:nvSpPr>
-          <p:cNvPr id="23" name="TextBox 22"/>
-          <p:cNvSpPr txBox="1"/>
-          <p:nvPr/>
-        </p:nvSpPr>
-        <p:spPr>
-          <a:xfrm>
-            <a:off x="7635240" y="8549640"/>
-            <a:ext cx="3108960" cy="457200"/>
-          </a:xfrm>
-          <a:prstGeom prst="rect">
-            <a:avLst/>
-          </a:prstGeom>
-          <a:noFill/>
-        </p:spPr>
-        <p:txBody>
-          <a:bodyPr wrap="square">
-            <a:spAutoFit/>
-          </a:bodyPr>
-          <a:lstStyle/>
-          <a:p>
-            <a:pPr algn="l"/>
-            <a:r>
-              <a:rPr sz="1600" b="1" i="0">
-                <a:solidFill>
-                  <a:srgbClr val="4C1D95"/>
-                </a:solidFill>
-              </a:rPr>
-              <a:t>PostgreSQL + pgvector</a:t>
-            </a:r>
-          </a:p>
-        </p:txBody>
-      </p:sp>
-      <p:sp>
-        <p:nvSpPr>
-          <p:cNvPr id="24" name="TextBox 23"/>
-          <p:cNvSpPr txBox="1"/>
-          <p:nvPr/>
-        </p:nvSpPr>
-        <p:spPr>
-          <a:xfrm>
-            <a:off x="7635240" y="9052560"/>
-            <a:ext cx="3108960" cy="731519"/>
-          </a:xfrm>
-          <a:prstGeom prst="rect">
-            <a:avLst/>
-          </a:prstGeom>
-          <a:noFill/>
-        </p:spPr>
-        <p:txBody>
-          <a:bodyPr wrap="square">
-            <a:spAutoFit/>
-          </a:bodyPr>
-          <a:lstStyle/>
-          <a:p>
-            <a:pPr algn="l"/>
-            <a:r>
-              <a:rPr sz="1150" b="0" i="0">
-                <a:solidFill>
-                  <a:srgbClr val="7C3AED"/>
-                </a:solidFill>
-              </a:rPr>
-              <a:t>chunks · doc_meta
-HNSW cosine · tsvector BM25
-RRF fusion</a:t>
-            </a:r>
-          </a:p>
-        </p:txBody>
-      </p:sp>
-      <p:cxnSp>
-        <p:nvCxnSpPr>
-          <p:cNvPr id="25" name="Connector 24"/>
-          <p:cNvCxnSpPr/>
-          <p:nvPr/>
-        </p:nvCxnSpPr>
-        <p:spPr>
-          <a:xfrm>
-            <a:off x="3794759" y="4297680"/>
-            <a:ext cx="3611881" cy="0"/>
-          </a:xfrm>
-          <a:prstGeom prst="line">
-            <a:avLst/>
-          </a:prstGeom>
-          <a:ln w="25400">
-            <a:solidFill>
-              <a:srgbClr val="7C3AED"/>
-            </a:solidFill>
-            <a:tailEnd type="arrow" w="med" len="med"/>
-          </a:ln>
-        </p:spPr>
-        <p:style>
-          <a:lnRef idx="2">
-            <a:schemeClr val="accent1"/>
-          </a:lnRef>
-          <a:fillRef idx="0">
-            <a:schemeClr val="accent1"/>
-          </a:fillRef>
-          <a:effectRef idx="1">
-            <a:schemeClr val="accent1"/>
-          </a:effectRef>
-          <a:fontRef idx="minor">
-            <a:schemeClr val="tx1"/>
-          </a:fontRef>
-        </p:style>
-      </p:cxnSp>
-      <p:sp>
-        <p:nvSpPr>
-          <p:cNvPr id="26" name="TextBox 25"/>
-          <p:cNvSpPr txBox="1"/>
-          <p:nvPr/>
-        </p:nvSpPr>
-        <p:spPr>
-          <a:xfrm>
-            <a:off x="3840479" y="3977640"/>
-            <a:ext cx="3520440" cy="292608"/>
-          </a:xfrm>
-          <a:prstGeom prst="rect">
-            <a:avLst/>
-          </a:prstGeom>
-          <a:noFill/>
-        </p:spPr>
-        <p:txBody>
-          <a:bodyPr wrap="square">
-            <a:spAutoFit/>
-          </a:bodyPr>
-          <a:lstStyle/>
-          <a:p>
-            <a:pPr algn="ctr"/>
-            <a:r>
-              <a:rPr sz="1000" b="0" i="1">
-                <a:solidFill>
-                  <a:srgbClr val="64748B"/>
-                </a:solidFill>
-              </a:rPr>
-              <a:t>upload PDF / query</a:t>
-            </a:r>
-          </a:p>
-        </p:txBody>
-      </p:sp>
-      <p:cxnSp>
-        <p:nvCxnSpPr>
-          <p:cNvPr id="27" name="Connector 26"/>
-          <p:cNvCxnSpPr/>
-          <p:nvPr/>
-        </p:nvCxnSpPr>
-        <p:spPr>
-          <a:xfrm flipH="1">
-            <a:off x="3794759" y="5486400"/>
-            <a:ext cx="3611881" cy="0"/>
-          </a:xfrm>
-          <a:prstGeom prst="line">
-            <a:avLst/>
-          </a:prstGeom>
-          <a:ln w="25400">
-            <a:solidFill>
-              <a:srgbClr val="059669"/>
-            </a:solidFill>
-            <a:tailEnd type="arrow" w="med" len="med"/>
-          </a:ln>
-        </p:spPr>
-        <p:style>
-          <a:lnRef idx="2">
-            <a:schemeClr val="accent1"/>
-          </a:lnRef>
-          <a:fillRef idx="0">
-            <a:schemeClr val="accent1"/>
-          </a:fillRef>
-          <a:effectRef idx="1">
-            <a:schemeClr val="accent1"/>
-          </a:effectRef>
-          <a:fontRef idx="minor">
-            <a:schemeClr val="tx1"/>
-          </a:fontRef>
-        </p:style>
-      </p:cxnSp>
-      <p:sp>
-        <p:nvSpPr>
-          <p:cNvPr id="28" name="TextBox 27"/>
-          <p:cNvSpPr txBox="1"/>
-          <p:nvPr/>
-        </p:nvSpPr>
-        <p:spPr>
-          <a:xfrm>
-            <a:off x="3840479" y="5559552"/>
-            <a:ext cx="3520440" cy="292608"/>
-          </a:xfrm>
-          <a:prstGeom prst="rect">
-            <a:avLst/>
-          </a:prstGeom>
-          <a:noFill/>
-        </p:spPr>
-        <p:txBody>
-          <a:bodyPr wrap="square">
-            <a:spAutoFit/>
-          </a:bodyPr>
-          <a:lstStyle/>
-          <a:p>
-            <a:pPr algn="ctr"/>
-            <a:r>
-              <a:rPr sz="1000" b="0" i="1">
-                <a:solidFill>
-                  <a:srgbClr val="64748B"/>
-                </a:solidFill>
-              </a:rPr>
-              <a:t>SSE stream</a:t>
-            </a:r>
-          </a:p>
-        </p:txBody>
-      </p:sp>
-      <p:cxnSp>
-        <p:nvCxnSpPr>
-          <p:cNvPr id="29" name="Connector 28"/>
-          <p:cNvCxnSpPr/>
-          <p:nvPr/>
-        </p:nvCxnSpPr>
-        <p:spPr>
-          <a:xfrm>
-            <a:off x="10881359" y="4297680"/>
-            <a:ext cx="3611881" cy="0"/>
-          </a:xfrm>
-          <a:prstGeom prst="line">
-            <a:avLst/>
-          </a:prstGeom>
-          <a:ln w="25400">
-            <a:solidFill>
-              <a:srgbClr val="4285F4"/>
-            </a:solidFill>
-            <a:tailEnd type="arrow" w="med" len="med"/>
-          </a:ln>
-        </p:spPr>
-        <p:style>
-          <a:lnRef idx="2">
-            <a:schemeClr val="accent1"/>
-          </a:lnRef>
-          <a:fillRef idx="0">
-            <a:schemeClr val="accent1"/>
-          </a:fillRef>
-          <a:effectRef idx="1">
-            <a:schemeClr val="accent1"/>
-          </a:effectRef>
-          <a:fontRef idx="minor">
-            <a:schemeClr val="tx1"/>
-          </a:fontRef>
-        </p:style>
-      </p:cxnSp>
-      <p:sp>
-        <p:nvSpPr>
-          <p:cNvPr id="30" name="TextBox 29"/>
-          <p:cNvSpPr txBox="1"/>
-          <p:nvPr/>
-        </p:nvSpPr>
-        <p:spPr>
-          <a:xfrm>
-            <a:off x="10927080" y="3977640"/>
-            <a:ext cx="3520440" cy="292608"/>
-          </a:xfrm>
-          <a:prstGeom prst="rect">
-            <a:avLst/>
-          </a:prstGeom>
-          <a:noFill/>
-        </p:spPr>
-        <p:txBody>
-          <a:bodyPr wrap="square">
-            <a:spAutoFit/>
-          </a:bodyPr>
-          <a:lstStyle/>
-          <a:p>
-            <a:pPr algn="ctr"/>
-            <a:r>
-              <a:rPr sz="1000" b="0" i="1">
-                <a:solidFill>
-                  <a:srgbClr val="64748B"/>
-                </a:solidFill>
-              </a:rPr>
-              <a:t>embed / rerank / answer</a:t>
-            </a:r>
-          </a:p>
-        </p:txBody>
-      </p:sp>
-      <p:cxnSp>
-        <p:nvCxnSpPr>
-          <p:cNvPr id="31" name="Connector 30"/>
-          <p:cNvCxnSpPr/>
-          <p:nvPr/>
-        </p:nvCxnSpPr>
-        <p:spPr>
-          <a:xfrm flipH="1">
-            <a:off x="10881359" y="5577840"/>
-            <a:ext cx="3611881" cy="0"/>
-          </a:xfrm>
-          <a:prstGeom prst="line">
-            <a:avLst/>
-          </a:prstGeom>
-          <a:ln w="25400">
-            <a:solidFill>
-              <a:srgbClr val="4285F4"/>
-            </a:solidFill>
-            <a:tailEnd type="arrow" w="med" len="med"/>
-          </a:ln>
-        </p:spPr>
-        <p:style>
-          <a:lnRef idx="2">
-            <a:schemeClr val="accent1"/>
-          </a:lnRef>
-          <a:fillRef idx="0">
-            <a:schemeClr val="accent1"/>
-          </a:fillRef>
-          <a:effectRef idx="1">
-            <a:schemeClr val="accent1"/>
-          </a:effectRef>
-          <a:fontRef idx="minor">
-            <a:schemeClr val="tx1"/>
-          </a:fontRef>
-        </p:style>
-      </p:cxnSp>
-      <p:sp>
-        <p:nvSpPr>
-          <p:cNvPr id="32" name="TextBox 31"/>
-          <p:cNvSpPr txBox="1"/>
-          <p:nvPr/>
-        </p:nvSpPr>
-        <p:spPr>
-          <a:xfrm>
-            <a:off x="10927080" y="5650992"/>
-            <a:ext cx="3520440" cy="292608"/>
-          </a:xfrm>
-          <a:prstGeom prst="rect">
-            <a:avLst/>
-          </a:prstGeom>
-          <a:noFill/>
-        </p:spPr>
-        <p:txBody>
-          <a:bodyPr wrap="square">
-            <a:spAutoFit/>
-          </a:bodyPr>
-          <a:lstStyle/>
-          <a:p>
-            <a:pPr algn="ctr"/>
-            <a:r>
-              <a:rPr sz="1000" b="0" i="1">
-                <a:solidFill>
-                  <a:srgbClr val="64748B"/>
-                </a:solidFill>
-              </a:rPr>
-              <a:t>vectors / rankings / tokens</a:t>
-            </a:r>
-          </a:p>
-        </p:txBody>
-      </p:sp>
-      <p:cxnSp>
-        <p:nvCxnSpPr>
-          <p:cNvPr id="33" name="Connector 32"/>
-          <p:cNvCxnSpPr/>
-          <p:nvPr/>
-        </p:nvCxnSpPr>
-        <p:spPr>
-          <a:xfrm>
-            <a:off x="9144000" y="7315200"/>
-            <a:ext cx="0" cy="548640"/>
-          </a:xfrm>
-          <a:prstGeom prst="line">
-            <a:avLst/>
-          </a:prstGeom>
-          <a:ln w="25400">
-            <a:solidFill>
-              <a:srgbClr val="336791"/>
-            </a:solidFill>
-            <a:tailEnd type="arrow" w="med" len="med"/>
-          </a:ln>
-        </p:spPr>
-        <p:style>
-          <a:lnRef idx="2">
-            <a:schemeClr val="accent1"/>
-          </a:lnRef>
-          <a:fillRef idx="0">
-            <a:schemeClr val="accent1"/>
-          </a:fillRef>
-          <a:effectRef idx="1">
-            <a:schemeClr val="accent1"/>
-          </a:effectRef>
-          <a:fontRef idx="minor">
-            <a:schemeClr val="tx1"/>
-          </a:fontRef>
-        </p:style>
-      </p:cxnSp>
-      <p:sp>
-        <p:nvSpPr>
-          <p:cNvPr id="34" name="TextBox 33"/>
-          <p:cNvSpPr txBox="1"/>
-          <p:nvPr/>
-        </p:nvSpPr>
-        <p:spPr>
-          <a:xfrm>
-            <a:off x="9235440" y="7424928"/>
-            <a:ext cx="2011680" cy="329184"/>
-          </a:xfrm>
-          <a:prstGeom prst="rect">
-            <a:avLst/>
-          </a:prstGeom>
-          <a:noFill/>
-        </p:spPr>
-        <p:txBody>
-          <a:bodyPr wrap="square">
-            <a:spAutoFit/>
-          </a:bodyPr>
-          <a:lstStyle/>
-          <a:p>
-            <a:pPr algn="l"/>
-            <a:r>
-              <a:rPr sz="1000" b="0" i="1">
-                <a:solidFill>
-                  <a:srgbClr val="64748B"/>
-                </a:solidFill>
-              </a:rPr>
-              <a:t>store &amp; retrieve</a:t>
-            </a:r>
-          </a:p>
-        </p:txBody>
-      </p:sp>
-      <p:sp>
-        <p:nvSpPr>
-          <p:cNvPr id="35" name="TextBox 34"/>
-          <p:cNvSpPr txBox="1"/>
-          <p:nvPr/>
-        </p:nvSpPr>
-        <p:spPr>
-          <a:xfrm>
-            <a:off x="457200" y="10058400"/>
-            <a:ext cx="17373600" cy="274320"/>
-          </a:xfrm>
-          <a:prstGeom prst="rect">
-            <a:avLst/>
-          </a:prstGeom>
-          <a:noFill/>
-        </p:spPr>
-        <p:txBody>
-          <a:bodyPr wrap="none">
-            <a:spAutoFit/>
-          </a:bodyPr>
-          <a:lstStyle/>
-          <a:p>
-            <a:pPr algn="l"/>
-            <a:r>
-              <a:rPr sz="900" b="0" i="0">
-                <a:solidFill>
-                  <a:srgbClr val="94A3B8"/>
-                </a:solidFill>
-              </a:rPr>
-              <a:t>Ingest flow: Browser → FastAPI → Gemini (embed) → Postgres (store)     Query flow: Browser → FastAPI → Postgres (hybrid search) → Gemini (rerank+answer) → Browser (SSE)</a:t>
-            </a:r>
-          </a:p>
-        </p:txBody>
-      </p:sp>
-    </p:spTree>
-  </p:cSld>
-  <p:clrMapOvr>
-    <a:masterClrMapping/>
-  </p:clrMapOvr>
-</p:sld>
-</file>
-
 <file path=ppt/slides/slide2.xml><?xml version="1.0" encoding="utf-8"?>
 <p:sld xmlns:p="http://schemas.openxmlformats.org/presentationml/2006/main" xmlns:a="http://schemas.openxmlformats.org/drawingml/2006/main">
   <p:cSld>
@@ -16123,7 +16120,7 @@
                 <a:cs typeface="Calibri (MS)"/>
                 <a:sym typeface="Calibri (MS)"/>
               </a:rPr>
-              <a:t>🔃</a:t>
+              <a:t>💬</a:t>
             </a:r>
           </a:p>
         </p:txBody>
@@ -16164,7 +16161,7 @@
                 <a:cs typeface="Calibri (MS) Bold"/>
                 <a:sym typeface="Calibri (MS) Bold"/>
               </a:rPr>
-              <a:t>Re-rank</a:t>
+              <a:t>Generate</a:t>
             </a:r>
           </a:p>
         </p:txBody>
@@ -16205,7 +16202,7 @@
                 <a:cs typeface="Calibri (MS)"/>
                 <a:sym typeface="Calibri (MS)"/>
               </a:rPr>
-              <a:t>Gemini ranks</a:t>
+              <a:t>Gemini 2.5 Flash</a:t>
             </a:r>
           </a:p>
           <a:p>
@@ -16224,7 +16221,7 @@
                 <a:cs typeface="Calibri (MS)"/>
                 <a:sym typeface="Calibri (MS)"/>
               </a:rPr>
-              <a:t>top k/2</a:t>
+              <a:t>streamed SSE</a:t>
             </a:r>
           </a:p>
         </p:txBody>

</xml_diff>

<commit_message>
feat(rag): retrieve and answer over PDF images via Gemini Vision
Extract embedded images with PyMuPDF at ingest, caption each with
Gemini 2.5 Flash Vision, and store as image chunks (caption embedded
into the same hybrid search space; image bytes in BYTEA). At answer
time, image chunks are passed as Gemini multimodal Parts so the
model reasons over the picture itself, not just the caption. Image
citations open a new /image-viewer page.

Co-Authored-By: Claude Sonnet 4.6 <noreply@anthropic.com>
</commit_message>
<xml_diff>
--- a/NYMBL-DOCRAG.pptx
+++ b/NYMBL-DOCRAG.pptx
@@ -7329,7 +7329,7 @@
                   <a:srgbClr val="4C1D95"/>
                 </a:solidFill>
               </a:rPr>
-              <a:t>🔍  No Scanned PDF / OCR</a:t>
+              <a:t>🔍  Limited OCR Support</a:t>
             </a:r>
           </a:p>
         </p:txBody>
@@ -7363,7 +7363,7 @@
                   <a:srgbClr val="7C3AED"/>
                 </a:solidFill>
               </a:rPr>
-              <a:t>PyMuPDF extracts text from digital PDFs only. Image-based or scanned pages return empty text — no Tesseract / Vision fallback.</a:t>
+              <a:t>Embedded images are extracted and captioned by Gemini Vision, so figures and diagrams are queryable. But full-page scanned PDFs (e.g. scanned books) aren't OCR'd to text — only the page-as-image caption is indexed.</a:t>
             </a:r>
           </a:p>
         </p:txBody>
@@ -8697,12 +8697,45 @@
           <a:p>
             <a:pPr algn="l"/>
             <a:r>
-              <a:rPr sz="1150" b="0" i="0">
+              <a:rPr sz="1150">
                 <a:solidFill>
                   <a:srgbClr val="7C3AED"/>
                 </a:solidFill>
               </a:rPr>
-              <a:t/>
+              <a:t>embedding-2 (768-dim)</a:t>
+            </a:r>
+          </a:p>
+          <a:p>
+            <a:pPr algn="l"/>
+            <a:r>
+              <a:rPr sz="1150">
+                <a:solidFill>
+                  <a:srgbClr val="7C3AED"/>
+                </a:solidFill>
+              </a:rPr>
+              <a:t>RETRIEVAL_DOCUMENT/QUERY</a:t>
+            </a:r>
+          </a:p>
+          <a:p>
+            <a:pPr algn="l"/>
+            <a:r>
+              <a:rPr sz="1150">
+                <a:solidFill>
+                  <a:srgbClr val="7C3AED"/>
+                </a:solidFill>
+              </a:rPr>
+              <a:t>2.5-flash vision (image captions)</a:t>
+            </a:r>
+          </a:p>
+          <a:p>
+            <a:pPr algn="l"/>
+            <a:r>
+              <a:rPr sz="1150">
+                <a:solidFill>
+                  <a:srgbClr val="7C3AED"/>
+                </a:solidFill>
+              </a:rPr>
+              <a:t>2.5-flash answer (SSE)</a:t>
             </a:r>
           </a:p>
         </p:txBody>

</xml_diff>

<commit_message>
docs: update README and PPT for image features
Co-Authored-By: Claude Sonnet 4.6 <noreply@anthropic.com>
</commit_message>
<xml_diff>
--- a/NYMBL-DOCRAG.pptx
+++ b/NYMBL-DOCRAG.pptx
@@ -9739,7 +9739,7 @@
                 <a:cs typeface="Calibri (MS)"/>
                 <a:sym typeface="Calibri (MS)"/>
               </a:rPr>
-              <a:t>🔃 Gemini re-ranking</a:t>
+              <a:t>🖼 Image retrieval + linking</a:t>
             </a:r>
           </a:p>
         </p:txBody>
@@ -24998,7 +24998,7 @@
                 <a:cs typeface="Calibri (MS) Bold"/>
                 <a:sym typeface="Calibri (MS) Bold"/>
               </a:rPr>
-              <a:t>🔃  Gemini Re-ranking</a:t>
+              <a:t>🖼  Multimodal Image Retrieval</a:t>
             </a:r>
           </a:p>
         </p:txBody>
@@ -25039,7 +25039,7 @@
                 <a:cs typeface="Calibri (MS)"/>
                 <a:sym typeface="Calibri (MS)"/>
               </a:rPr>
-              <a:t>After hybrid retrieval returns k chunks, Gemini ranks them by relevance to the question and keeps the top k/2. Filters out chunks that are semantically close but topically irrelevant before they reach the LLM context window.</a:t>
+              <a:t>Opt-in at upload: extract embedded images with PyMuPDF, caption each with Gemini Vision (downsized + bounded concurrency), embed captions into the same hybrid space, and store image bytes in BYTEA. At answer time, image chunks are passed as multimodal Parts so Gemini reasons over the picture itself. Bold painting/figure names in the answer become clickable hyperlinks via fuzzy match against caption + adjacent page text.</a:t>
             </a:r>
           </a:p>
         </p:txBody>

</xml_diff>

<commit_message>
docs(ppt): reflect shipped OCR feature
- Roadmap (slide 11): "OCR for scanned PDFs" moves from a planned
  reliability item to ✅ shipped, description updated to describe
  the actual implementation (Gemini Vision JSON + bbox overlays).
- Limitations (slide 12): "Limited OCR Support" replaced with
  "OCR opt-in only" — accurately reflects the remaining constraint
  (user toggles per upload; every empty-text page is a Vision call).

README was already updated alongside the implementation.

Co-Authored-By: Claude Opus 4.7 (1M context) <noreply@anthropic.com>
</commit_message>
<xml_diff>
--- a/NYMBL-DOCRAG.pptx
+++ b/NYMBL-DOCRAG.pptx
@@ -5711,7 +5711,7 @@
                 <a:cs typeface="Calibri (MS) Bold"/>
                 <a:sym typeface="Calibri (MS) Bold"/>
               </a:rPr>
-              <a:t>• OCR for scanned PDFs</a:t>
+              <a:t>✅ OCR for scanned PDFs (shipped)</a:t>
             </a:r>
           </a:p>
         </p:txBody>
@@ -5752,7 +5752,7 @@
                 <a:cs typeface="Calibri (MS)"/>
                 <a:sym typeface="Calibri (MS)"/>
               </a:rPr>
-              <a:t>Tesseract or Google Vision fallback when PyMuPDF returns empty text — currently image-based PDFs produce no chunks.</a:t>
+              <a:t>Gemini 2.5 Flash with structured JSON output: empty-text pages render at 200 DPI, get transcribed, and per-line bboxes power yellow overlay highlights in the viewer.</a:t>
             </a:r>
           </a:p>
         </p:txBody>
@@ -7329,7 +7329,7 @@
                   <a:srgbClr val="4C1D95"/>
                 </a:solidFill>
               </a:rPr>
-              <a:t>🔍  Limited OCR Support</a:t>
+              <a:t>🔍  OCR opt-in only</a:t>
             </a:r>
           </a:p>
         </p:txBody>
@@ -7363,7 +7363,7 @@
                   <a:srgbClr val="7C3AED"/>
                 </a:solidFill>
               </a:rPr>
-              <a:t>Embedded images are extracted and captioned by Gemini Vision, so figures and diagrams are queryable. But full-page scanned PDFs (e.g. scanned books) aren't OCR'd to text — only the page-as-image caption is indexed.</a:t>
+              <a:t>OCR for scanned/handwritten pages is supported via Gemini Vision but must be enabled at upload — every empty-text page (≤ 50 chars from PyMuPDF) becomes a Vision call. No automatic detection: the user toggles it per upload.</a:t>
             </a:r>
           </a:p>
         </p:txBody>

</xml_diff>

<commit_message>
docs: add toggle-by-PDF-type guide
Co-Authored-By: Claude Sonnet 4.6 <noreply@anthropic.com>
</commit_message>
<xml_diff>
--- a/NYMBL-DOCRAG.pptx
+++ b/NYMBL-DOCRAG.pptx
@@ -4845,7 +4845,7 @@
                 <a:cs typeface="Calibri (MS)"/>
                 <a:sym typeface="Calibri (MS)"/>
               </a:rPr>
-              <a:t>Drag &amp; drop — watch ingest progress: extract → chunk → embed → done</a:t>
+              <a:t>Drag &amp; drop, then pick toggles for the PDF: Hand Written? for scans / image-only PDFs (fills empty text), Detect hand-drawn markup for hand-drawn underlines/highlights baked into the page raster (slow — use the page-range input on long docs).</a:t>
             </a:r>
           </a:p>
         </p:txBody>
@@ -5752,7 +5752,7 @@
                 <a:cs typeface="Calibri (MS)"/>
                 <a:sym typeface="Calibri (MS)"/>
               </a:rPr>
-              <a:t>Shipped: (1) Vision OCR on empty/sparse pages so handwritten/scanned content becomes searchable; (2) PDF annotation reader pulls Acrobat/Preview highlights, underlines and sticky notes into chunk context; (3) Vision visual-markup pass detects hand-drawn underlines/highlights flattened into the page raster. OCR is bundled with the 'Hand Written?' toggle (cheap); markup detection is a separate opt-in (one Vision call per page — slow on long PDFs).</a:t>
+              <a:t>Shipped: (1) Vision OCR on empty/sparse pages so handwritten/scanned content becomes searchable; (2) PDF annotation reader pulls Acrobat/Preview highlights, underlines and sticky notes into chunk context; (3) Vision visual-markup pass detects hand-drawn underlines/highlights flattened into the page raster. Toggle guide: typed PDF + hand-marked → markup only; image-only scan → both; pre-OCR'd scan → markup only; fully handwritten notebook → both. Markup pass takes one Vision call per page — page-range input scopes long docs.</a:t>
             </a:r>
           </a:p>
         </p:txBody>

</xml_diff>

<commit_message>
docs(ppt): drop re-ranking from slide deck to match current pipeline
Slide 1: replace "Gemini re-ranking" feature bullet with "Multimodal
image retrieval (opt-in)" — re-ranking was removed from the pipeline;
multimodal image retrieval is a real opt-in feature documented in
README.md.

Slide 5: drop the Re-rank stage from the query-flow diagram; shift
Stream answer left so the 4-stage flow is evenly spaced
(User question -> Embed query -> Hybrid search -> Stream answer).

Slide 7: remove "Also used for re-ranking." from the Gemini 2.5 Flash
generation row.

Cross-checked all 14 slides against verified canonical docs — no
further drift found.

Co-Authored-By: Claude Opus 4.7 (1M context) <noreply@anthropic.com>
</commit_message>
<xml_diff>
--- a/NYMBL-DOCRAG.pptx
+++ b/NYMBL-DOCRAG.pptx
@@ -4280,7 +4280,7 @@
                 <a:cs typeface="Calibri (MS)"/>
                 <a:sym typeface="Calibri (MS)"/>
               </a:rPr>
-              <a:t>🔃  Gemini re-ranking</a:t>
+              <a:t>🖼  Multimodal image retrieval (opt-in)</a:t>
             </a:r>
           </a:p>
         </p:txBody>
@@ -19423,7 +19423,7 @@
       </p:sp>
       <p:sp>
         <p:nvSpPr>
-          <p:cNvPr name="TextBox 18" id="18"/>
+          <p:cNvPr name="TextBox 21" id="21"/>
           <p:cNvSpPr txBox="true"/>
           <p:nvPr/>
         </p:nvSpPr>
@@ -19457,14 +19457,14 @@
                 <a:cs typeface="Calibri (MS)"/>
                 <a:sym typeface="Calibri (MS)"/>
               </a:rPr>
-              <a:t>🔃</a:t>
-            </a:r>
-          </a:p>
-        </p:txBody>
-      </p:sp>
-      <p:sp>
-        <p:nvSpPr>
-          <p:cNvPr name="TextBox 19" id="19"/>
+              <a:t>📎</a:t>
+            </a:r>
+          </a:p>
+        </p:txBody>
+      </p:sp>
+      <p:sp>
+        <p:nvSpPr>
+          <p:cNvPr name="TextBox 22" id="22"/>
           <p:cNvSpPr txBox="true"/>
           <p:nvPr/>
         </p:nvSpPr>
@@ -19498,129 +19498,6 @@
                 <a:cs typeface="Calibri (MS) Bold"/>
                 <a:sym typeface="Calibri (MS) Bold"/>
               </a:rPr>
-              <a:t>Re-rank</a:t>
-            </a:r>
-          </a:p>
-        </p:txBody>
-      </p:sp>
-      <p:sp>
-        <p:nvSpPr>
-          <p:cNvPr name="TextBox 20" id="20"/>
-          <p:cNvSpPr txBox="true"/>
-          <p:nvPr/>
-        </p:nvSpPr>
-        <p:spPr>
-          <a:xfrm rot="0">
-            <a:off x="10304126" y="3380194"/>
-            <a:ext cx="2974267" cy="280302"/>
-          </a:xfrm>
-          <a:prstGeom prst="rect">
-            <a:avLst/>
-          </a:prstGeom>
-        </p:spPr>
-        <p:txBody>
-          <a:bodyPr anchor="t" rtlCol="false" tIns="0" lIns="0" bIns="0" rIns="0">
-            <a:spAutoFit/>
-          </a:bodyPr>
-          <a:lstStyle/>
-          <a:p>
-            <a:pPr algn="ctr">
-              <a:lnSpc>
-                <a:spcPts val="1621"/>
-              </a:lnSpc>
-            </a:pPr>
-            <a:r>
-              <a:rPr lang="en-US" sz="1351">
-                <a:solidFill>
-                  <a:srgbClr val="7C3AED"/>
-                </a:solidFill>
-                <a:latin typeface="Calibri (MS)"/>
-                <a:ea typeface="Calibri (MS)"/>
-                <a:cs typeface="Calibri (MS)"/>
-                <a:sym typeface="Calibri (MS)"/>
-              </a:rPr>
-              <a:t>Gemini · top k/2</a:t>
-            </a:r>
-          </a:p>
-        </p:txBody>
-      </p:sp>
-      <p:sp>
-        <p:nvSpPr>
-          <p:cNvPr name="TextBox 21" id="21"/>
-          <p:cNvSpPr txBox="true"/>
-          <p:nvPr/>
-        </p:nvSpPr>
-        <p:spPr>
-          <a:xfrm rot="0">
-            <a:off x="13571087" y="2349570"/>
-            <a:ext cx="2974267" cy="583416"/>
-          </a:xfrm>
-          <a:prstGeom prst="rect">
-            <a:avLst/>
-          </a:prstGeom>
-        </p:spPr>
-        <p:txBody>
-          <a:bodyPr anchor="t" rtlCol="false" tIns="0" lIns="0" bIns="0" rIns="0">
-            <a:spAutoFit/>
-          </a:bodyPr>
-          <a:lstStyle/>
-          <a:p>
-            <a:pPr algn="ctr">
-              <a:lnSpc>
-                <a:spcPts val="3242"/>
-              </a:lnSpc>
-            </a:pPr>
-            <a:r>
-              <a:rPr lang="en-US" sz="2702">
-                <a:solidFill>
-                  <a:srgbClr val="4C1D95"/>
-                </a:solidFill>
-                <a:latin typeface="Calibri (MS)"/>
-                <a:ea typeface="Calibri (MS)"/>
-                <a:cs typeface="Calibri (MS)"/>
-                <a:sym typeface="Calibri (MS)"/>
-              </a:rPr>
-              <a:t>📎</a:t>
-            </a:r>
-          </a:p>
-        </p:txBody>
-      </p:sp>
-      <p:sp>
-        <p:nvSpPr>
-          <p:cNvPr name="TextBox 22" id="22"/>
-          <p:cNvSpPr txBox="true"/>
-          <p:nvPr/>
-        </p:nvSpPr>
-        <p:spPr>
-          <a:xfrm rot="0">
-            <a:off x="13571087" y="2968390"/>
-            <a:ext cx="2974267" cy="348939"/>
-          </a:xfrm>
-          <a:prstGeom prst="rect">
-            <a:avLst/>
-          </a:prstGeom>
-        </p:spPr>
-        <p:txBody>
-          <a:bodyPr anchor="t" rtlCol="false" tIns="0" lIns="0" bIns="0" rIns="0">
-            <a:spAutoFit/>
-          </a:bodyPr>
-          <a:lstStyle/>
-          <a:p>
-            <a:pPr algn="ctr">
-              <a:lnSpc>
-                <a:spcPts val="1981"/>
-              </a:lnSpc>
-            </a:pPr>
-            <a:r>
-              <a:rPr lang="en-US" sz="1651" b="true">
-                <a:solidFill>
-                  <a:srgbClr val="4C1D95"/>
-                </a:solidFill>
-                <a:latin typeface="Calibri (MS) Bold"/>
-                <a:ea typeface="Calibri (MS) Bold"/>
-                <a:cs typeface="Calibri (MS) Bold"/>
-                <a:sym typeface="Calibri (MS) Bold"/>
-              </a:rPr>
               <a:t>Stream answer</a:t>
             </a:r>
           </a:p>
@@ -19634,7 +19511,7 @@
         </p:nvSpPr>
         <p:spPr>
           <a:xfrm rot="0">
-            <a:off x="13571087" y="3380194"/>
+            <a:off x="10304126" y="3380194"/>
             <a:ext cx="2974267" cy="280302"/>
           </a:xfrm>
           <a:prstGeom prst="rect">
@@ -22828,7 +22705,7 @@
                 <a:cs typeface="Calibri (MS)"/>
                 <a:sym typeface="Calibri (MS)"/>
               </a:rPr>
-              <a:t>Fast, cost-effective, streamed output via SSE for a responsive UX. Also used for re-ranking.</a:t>
+              <a:t>Fast, cost-effective, streamed output via SSE for a responsive UX.</a:t>
             </a:r>
           </a:p>
         </p:txBody>

</xml_diff>